<commit_message>
Include GPU/PNM card cost in Baseline vs Target cost row; PIM-SSD priced equal to NVMe
Co-Authored-By: Claude Sonnet 5.5 <noreply@anthropic.com>
Claude-Session: https://claude.ai/code/session_01N1hDbMkxPdrcYvvdEog1Sh
</commit_message>
<xml_diff>
--- a/Baseline_vs_Target_cost_updated.pptx
+++ b/Baseline_vs_Target_cost_updated.pptx
@@ -9902,7 +9902,7 @@
                 <a:latin typeface="맑은 고딕"/>
                 <a:ea typeface="맑은 고딕"/>
               </a:rPr>
-              <a:t>메모리 비용 (추정)</a:t>
+              <a:t>총 비용 (메모리 + 카드)</a:t>
             </a:r>
           </a:p>
         </p:txBody>
@@ -9938,7 +9938,7 @@
                 <a:latin typeface="맑은 고딕"/>
                 <a:ea typeface="맑은 고딕"/>
               </a:rPr>
-              <a:t>$53.8K  (1.00×)</a:t>
+              <a:t>$139.8K  (1.00×)</a:t>
             </a:r>
           </a:p>
         </p:txBody>
@@ -9974,7 +9974,7 @@
                 <a:latin typeface="맑은 고딕"/>
                 <a:ea typeface="맑은 고딕"/>
               </a:rPr>
-              <a:t>$78.8K  (1.46×)</a:t>
+              <a:t>$123.8K  (0.89×)</a:t>
             </a:r>
           </a:p>
         </p:txBody>
@@ -10010,7 +10010,7 @@
                 <a:latin typeface="맑은 고딕"/>
                 <a:ea typeface="맑은 고딕"/>
               </a:rPr>
-              <a:t>$78.8K  (1.46×)</a:t>
+              <a:t>$123.8K  (0.89×)</a:t>
             </a:r>
           </a:p>
         </p:txBody>
@@ -10144,7 +10144,7 @@
                 <a:latin typeface="맑은 고딕"/>
                 <a:ea typeface="맑은 고딕"/>
               </a:rPr>
-              <a:t>※ 단가(2026.10 시장가) HBM3E $15.6 / HBF $1.95(HBM÷8 가정) / DDR5 RDIMM $35 / NVMe $0.50 / PIM-SSD $0.75(NVMe×1.5) per GB. 메모리 매체 비용만 비교 — GPU 8대 → 4대 감소분은 카드 비용 제외라 별도 절감이다.</a:t>
+              <a:t>※ 단가(2026.10) GPU 카드 $12K(A100 80GB, HBM 포함 → 카드만 $10.75K) · PNM 카드 $1.5K(가정) · HBM $15.6 / HBF $1.95 / DDR5 $35 / NVMe·PIM-SSD $0.50 per GB. 메모리만 비교 시 $53.8K / $74.8K (1.39×).</a:t>
             </a:r>
           </a:p>
         </p:txBody>

</xml_diff>

<commit_message>
Recheck DRAM/HBM unit prices against memoryb2b index; use HBM2e for A100-class
Co-Authored-By: Claude Sonnet 5.5 <noreply@anthropic.com>
Claude-Session: https://claude.ai/code/session_01N1hDbMkxPdrcYvvdEog1Sh
</commit_message>
<xml_diff>
--- a/Baseline_vs_Target_cost_updated.pptx
+++ b/Baseline_vs_Target_cost_updated.pptx
@@ -9938,7 +9938,7 @@
                 <a:latin typeface="맑은 고딕"/>
                 <a:ea typeface="맑은 고딕"/>
               </a:rPr>
-              <a:t>$139.8K  (1.00×)</a:t>
+              <a:t>$145.0K  (1.00×)</a:t>
             </a:r>
           </a:p>
         </p:txBody>
@@ -9974,7 +9974,7 @@
                 <a:latin typeface="맑은 고딕"/>
                 <a:ea typeface="맑은 고딕"/>
               </a:rPr>
-              <a:t>$123.8K  (0.89×)</a:t>
+              <a:t>$131.4K  (0.91×)</a:t>
             </a:r>
           </a:p>
         </p:txBody>
@@ -10010,7 +10010,7 @@
                 <a:latin typeface="맑은 고딕"/>
                 <a:ea typeface="맑은 고딕"/>
               </a:rPr>
-              <a:t>$123.8K  (0.89×)</a:t>
+              <a:t>$131.4K  (0.91×)</a:t>
             </a:r>
           </a:p>
         </p:txBody>
@@ -10144,7 +10144,7 @@
                 <a:latin typeface="맑은 고딕"/>
                 <a:ea typeface="맑은 고딕"/>
               </a:rPr>
-              <a:t>※ 단가(2026.10) GPU 카드 $12K(A100 80GB, HBM 포함 → 카드만 $10.75K) · PNM 카드 $1.5K(가정) · HBM $15.6 / HBF $1.95 / DDR5 $35 / NVMe·PIM-SSD $0.50 per GB. 메모리만 비교 시 $53.8K / $74.8K (1.39×).</a:t>
+              <a:t>※ 단가(2026.10) GPU 카드 $12K(A100 80GB, HBM 포함 → 카드만 $11.4K) · PNM 카드 $1.5K(가정) · HBM2e $8 / HBF $1.00 / DDR5 $40 / NVMe·PIM-SSD $0.50 per GB. 메모리만 비교 시 $54.1K / $80.0K (1.48×).</a:t>
             </a:r>
           </a:p>
         </p:txBody>

</xml_diff>

<commit_message>
Baseline vs Target slide: H100 x 4 nodes, new-product prices, drop Target 2, add formula/product column
Co-Authored-By: Claude Sonnet 5.5 <noreply@anthropic.com>
Claude-Session: https://claude.ai/code/session_01N1hDbMkxPdrcYvvdEog1Sh
</commit_message>
<xml_diff>
--- a/Baseline_vs_Target_cost_updated.pptx
+++ b/Baseline_vs_Target_cost_updated.pptx
@@ -3928,8 +3928,8 @@
         </p:nvSpPr>
         <p:spPr>
           <a:xfrm>
-            <a:off x="365760" y="804672"/>
-            <a:ext cx="2011680" cy="292608"/>
+            <a:off x="361950" y="804672"/>
+            <a:ext cx="1733550" cy="292608"/>
           </a:xfrm>
           <a:prstGeom prst="rect">
             <a:avLst/>
@@ -3951,7 +3951,7 @@
                 <a:latin typeface="맑은 고딕"/>
                 <a:ea typeface="맑은 고딕"/>
               </a:rPr>
-              <a:t>구성</a:t>
+              <a:t>구성  (1노드 · ×4노드)</a:t>
             </a:r>
           </a:p>
         </p:txBody>
@@ -3964,8 +3964,8 @@
         </p:nvSpPr>
         <p:spPr>
           <a:xfrm>
-            <a:off x="2468880" y="804672"/>
-            <a:ext cx="3054096" cy="292608"/>
+            <a:off x="2171700" y="804672"/>
+            <a:ext cx="2381250" cy="292608"/>
           </a:xfrm>
           <a:prstGeom prst="rect">
             <a:avLst/>
@@ -4009,7 +4009,7 @@
                 <a:latin typeface="맑은 고딕"/>
                 <a:ea typeface="맑은 고딕"/>
               </a:rPr>
-              <a:t>Baseline  —  GPU × 8</a:t>
+              <a:t>Baseline  —  H100 × 8</a:t>
             </a:r>
           </a:p>
         </p:txBody>
@@ -4022,8 +4022,8 @@
         </p:nvSpPr>
         <p:spPr>
           <a:xfrm>
-            <a:off x="5650992" y="804672"/>
-            <a:ext cx="3054096" cy="292608"/>
+            <a:off x="4629150" y="804672"/>
+            <a:ext cx="2381250" cy="292608"/>
           </a:xfrm>
           <a:prstGeom prst="rect">
             <a:avLst/>
@@ -4067,7 +4067,7 @@
                 <a:latin typeface="맑은 고딕"/>
                 <a:ea typeface="맑은 고딕"/>
               </a:rPr>
-              <a:t>Target 1  —  GPU × 4  +  CXL-PNM × 4</a:t>
+              <a:t>Target  —  H100 × 4  +  CXL-PNM × 4</a:t>
             </a:r>
           </a:p>
         </p:txBody>
@@ -4080,8 +4080,8 @@
         </p:nvSpPr>
         <p:spPr>
           <a:xfrm>
-            <a:off x="8833104" y="804672"/>
-            <a:ext cx="3054096" cy="292608"/>
+            <a:off x="7086600" y="804672"/>
+            <a:ext cx="4791075" cy="292608"/>
           </a:xfrm>
           <a:prstGeom prst="rect">
             <a:avLst/>
@@ -4125,7 +4125,7 @@
                 <a:latin typeface="맑은 고딕"/>
                 <a:ea typeface="맑은 고딕"/>
               </a:rPr>
-              <a:t>Target 2  —  Target 1 + HBM 절반을 HBF로</a:t>
+              <a:t>산출식  ·  제품 (세대 / 타입)</a:t>
             </a:r>
           </a:p>
         </p:txBody>
@@ -4138,8 +4138,8 @@
         </p:nvSpPr>
         <p:spPr>
           <a:xfrm>
-            <a:off x="365760" y="1207008"/>
-            <a:ext cx="2011680" cy="621792"/>
+            <a:off x="361950" y="1181100"/>
+            <a:ext cx="1733550" cy="533400"/>
           </a:xfrm>
           <a:prstGeom prst="rect">
             <a:avLst/>
@@ -4195,8 +4195,8 @@
         </p:nvSpPr>
         <p:spPr>
           <a:xfrm>
-            <a:off x="365760" y="1865376"/>
-            <a:ext cx="2011680" cy="475488"/>
+            <a:off x="361950" y="1752600"/>
+            <a:ext cx="1733550" cy="381000"/>
           </a:xfrm>
           <a:prstGeom prst="rect">
             <a:avLst/>
@@ -4235,8 +4235,8 @@
         </p:nvSpPr>
         <p:spPr>
           <a:xfrm>
-            <a:off x="365760" y="2377440"/>
-            <a:ext cx="2011680" cy="621792"/>
+            <a:off x="361950" y="2181225"/>
+            <a:ext cx="1733550" cy="533400"/>
           </a:xfrm>
           <a:prstGeom prst="rect">
             <a:avLst/>
@@ -4275,8 +4275,8 @@
         </p:nvSpPr>
         <p:spPr>
           <a:xfrm>
-            <a:off x="365760" y="3035808"/>
-            <a:ext cx="2011680" cy="274320"/>
+            <a:off x="361950" y="2762250"/>
+            <a:ext cx="1733550" cy="247650"/>
           </a:xfrm>
           <a:prstGeom prst="rect">
             <a:avLst/>
@@ -4315,8 +4315,8 @@
         </p:nvSpPr>
         <p:spPr>
           <a:xfrm>
-            <a:off x="2468880" y="1133856"/>
-            <a:ext cx="3054096" cy="2249424"/>
+            <a:off x="2171700" y="1133475"/>
+            <a:ext cx="2381250" cy="1933575"/>
           </a:xfrm>
           <a:prstGeom prst="rect">
             <a:avLst/>
@@ -4366,8 +4366,8 @@
         </p:nvSpPr>
         <p:spPr>
           <a:xfrm>
-            <a:off x="2560320" y="1207008"/>
-            <a:ext cx="697230" cy="237744"/>
+            <a:off x="2247900" y="1181100"/>
+            <a:ext cx="523875" cy="209550"/>
           </a:xfrm>
           <a:prstGeom prst="rect">
             <a:avLst/>
@@ -4424,8 +4424,8 @@
         </p:nvSpPr>
         <p:spPr>
           <a:xfrm>
-            <a:off x="2560320" y="1444752"/>
-            <a:ext cx="697230" cy="384048"/>
+            <a:off x="2247900" y="1409700"/>
+            <a:ext cx="523875" cy="304800"/>
           </a:xfrm>
           <a:prstGeom prst="rect">
             <a:avLst/>
@@ -4484,8 +4484,8 @@
         </p:nvSpPr>
         <p:spPr>
           <a:xfrm>
-            <a:off x="3284982" y="1207008"/>
-            <a:ext cx="697230" cy="237744"/>
+            <a:off x="2805112" y="1181100"/>
+            <a:ext cx="523875" cy="209550"/>
           </a:xfrm>
           <a:prstGeom prst="rect">
             <a:avLst/>
@@ -4542,8 +4542,8 @@
         </p:nvSpPr>
         <p:spPr>
           <a:xfrm>
-            <a:off x="3284982" y="1444752"/>
-            <a:ext cx="697230" cy="384048"/>
+            <a:off x="2805112" y="1409700"/>
+            <a:ext cx="523875" cy="304800"/>
           </a:xfrm>
           <a:prstGeom prst="rect">
             <a:avLst/>
@@ -4602,8 +4602,8 @@
         </p:nvSpPr>
         <p:spPr>
           <a:xfrm>
-            <a:off x="4009644" y="1207008"/>
-            <a:ext cx="697230" cy="237744"/>
+            <a:off x="3362325" y="1181100"/>
+            <a:ext cx="523875" cy="209550"/>
           </a:xfrm>
           <a:prstGeom prst="rect">
             <a:avLst/>
@@ -4660,8 +4660,8 @@
         </p:nvSpPr>
         <p:spPr>
           <a:xfrm>
-            <a:off x="4009644" y="1444752"/>
-            <a:ext cx="697230" cy="384048"/>
+            <a:off x="3362325" y="1409700"/>
+            <a:ext cx="523875" cy="304800"/>
           </a:xfrm>
           <a:prstGeom prst="rect">
             <a:avLst/>
@@ -4720,8 +4720,8 @@
         </p:nvSpPr>
         <p:spPr>
           <a:xfrm>
-            <a:off x="4734306" y="1207008"/>
-            <a:ext cx="697230" cy="237744"/>
+            <a:off x="3919538" y="1181100"/>
+            <a:ext cx="523875" cy="209550"/>
           </a:xfrm>
           <a:prstGeom prst="rect">
             <a:avLst/>
@@ -4778,8 +4778,8 @@
         </p:nvSpPr>
         <p:spPr>
           <a:xfrm>
-            <a:off x="4734306" y="1444752"/>
-            <a:ext cx="697230" cy="384048"/>
+            <a:off x="3919538" y="1409700"/>
+            <a:ext cx="523875" cy="304800"/>
           </a:xfrm>
           <a:prstGeom prst="rect">
             <a:avLst/>
@@ -4838,8 +4838,8 @@
         </p:nvSpPr>
         <p:spPr>
           <a:xfrm>
-            <a:off x="2560320" y="1865376"/>
-            <a:ext cx="1421892" cy="475488"/>
+            <a:off x="2247900" y="1752600"/>
+            <a:ext cx="1081088" cy="381000"/>
           </a:xfrm>
           <a:prstGeom prst="rect">
             <a:avLst/>
@@ -4902,7 +4902,7 @@
                 <a:latin typeface="맑은 고딕"/>
                 <a:ea typeface="맑은 고딕"/>
               </a:rPr>
-              <a:t>56 cores · DDR 512GB</a:t>
+              <a:t>56C · DDR 512GB</a:t>
             </a:r>
           </a:p>
         </p:txBody>
@@ -4915,8 +4915,8 @@
         </p:nvSpPr>
         <p:spPr>
           <a:xfrm>
-            <a:off x="4009644" y="1865376"/>
-            <a:ext cx="1421892" cy="475488"/>
+            <a:off x="3362325" y="1752600"/>
+            <a:ext cx="1081088" cy="381000"/>
           </a:xfrm>
           <a:prstGeom prst="rect">
             <a:avLst/>
@@ -4979,7 +4979,7 @@
                 <a:latin typeface="맑은 고딕"/>
                 <a:ea typeface="맑은 고딕"/>
               </a:rPr>
-              <a:t>56 cores · DDR 512GB</a:t>
+              <a:t>56C · DDR 512GB</a:t>
             </a:r>
           </a:p>
         </p:txBody>
@@ -4992,8 +4992,8 @@
         </p:nvSpPr>
         <p:spPr>
           <a:xfrm>
-            <a:off x="2560320" y="2377440"/>
-            <a:ext cx="697230" cy="237744"/>
+            <a:off x="2247900" y="2181225"/>
+            <a:ext cx="523875" cy="209550"/>
           </a:xfrm>
           <a:prstGeom prst="rect">
             <a:avLst/>
@@ -5050,8 +5050,8 @@
         </p:nvSpPr>
         <p:spPr>
           <a:xfrm>
-            <a:off x="2560320" y="2615184"/>
-            <a:ext cx="697230" cy="384048"/>
+            <a:off x="2247900" y="2409825"/>
+            <a:ext cx="523875" cy="304800"/>
           </a:xfrm>
           <a:prstGeom prst="rect">
             <a:avLst/>
@@ -5110,8 +5110,8 @@
         </p:nvSpPr>
         <p:spPr>
           <a:xfrm>
-            <a:off x="3284982" y="2377440"/>
-            <a:ext cx="697230" cy="237744"/>
+            <a:off x="2805112" y="2181225"/>
+            <a:ext cx="523875" cy="209550"/>
           </a:xfrm>
           <a:prstGeom prst="rect">
             <a:avLst/>
@@ -5168,8 +5168,8 @@
         </p:nvSpPr>
         <p:spPr>
           <a:xfrm>
-            <a:off x="3284982" y="2615184"/>
-            <a:ext cx="697230" cy="384048"/>
+            <a:off x="2805112" y="2409825"/>
+            <a:ext cx="523875" cy="304800"/>
           </a:xfrm>
           <a:prstGeom prst="rect">
             <a:avLst/>
@@ -5228,8 +5228,8 @@
         </p:nvSpPr>
         <p:spPr>
           <a:xfrm>
-            <a:off x="4009644" y="2377440"/>
-            <a:ext cx="697230" cy="237744"/>
+            <a:off x="3362325" y="2181225"/>
+            <a:ext cx="523875" cy="209550"/>
           </a:xfrm>
           <a:prstGeom prst="rect">
             <a:avLst/>
@@ -5286,8 +5286,8 @@
         </p:nvSpPr>
         <p:spPr>
           <a:xfrm>
-            <a:off x="4009644" y="2615184"/>
-            <a:ext cx="697230" cy="384048"/>
+            <a:off x="3362325" y="2409825"/>
+            <a:ext cx="523875" cy="304800"/>
           </a:xfrm>
           <a:prstGeom prst="rect">
             <a:avLst/>
@@ -5346,8 +5346,8 @@
         </p:nvSpPr>
         <p:spPr>
           <a:xfrm>
-            <a:off x="4734306" y="2377440"/>
-            <a:ext cx="697230" cy="237744"/>
+            <a:off x="3919538" y="2181225"/>
+            <a:ext cx="523875" cy="209550"/>
           </a:xfrm>
           <a:prstGeom prst="rect">
             <a:avLst/>
@@ -5404,8 +5404,8 @@
         </p:nvSpPr>
         <p:spPr>
           <a:xfrm>
-            <a:off x="4734306" y="2615184"/>
-            <a:ext cx="697230" cy="384048"/>
+            <a:off x="3919538" y="2409825"/>
+            <a:ext cx="523875" cy="304800"/>
           </a:xfrm>
           <a:prstGeom prst="rect">
             <a:avLst/>
@@ -5464,8 +5464,8 @@
         </p:nvSpPr>
         <p:spPr>
           <a:xfrm>
-            <a:off x="2560320" y="3035808"/>
-            <a:ext cx="2871215" cy="274320"/>
+            <a:off x="2247900" y="2762250"/>
+            <a:ext cx="2195512" cy="247650"/>
           </a:xfrm>
           <a:prstGeom prst="rect">
             <a:avLst/>
@@ -5524,8 +5524,8 @@
         </p:nvSpPr>
         <p:spPr>
           <a:xfrm>
-            <a:off x="5650992" y="1133856"/>
-            <a:ext cx="3054096" cy="2249424"/>
+            <a:off x="4629150" y="1133475"/>
+            <a:ext cx="2381250" cy="1933575"/>
           </a:xfrm>
           <a:prstGeom prst="rect">
             <a:avLst/>
@@ -5575,8 +5575,8 @@
         </p:nvSpPr>
         <p:spPr>
           <a:xfrm>
-            <a:off x="5742431" y="1207008"/>
-            <a:ext cx="697230" cy="237744"/>
+            <a:off x="4705350" y="1181100"/>
+            <a:ext cx="523875" cy="209550"/>
           </a:xfrm>
           <a:prstGeom prst="rect">
             <a:avLst/>
@@ -5633,8 +5633,8 @@
         </p:nvSpPr>
         <p:spPr>
           <a:xfrm>
-            <a:off x="5742431" y="1444752"/>
-            <a:ext cx="697230" cy="384048"/>
+            <a:off x="4705350" y="1409700"/>
+            <a:ext cx="523875" cy="304800"/>
           </a:xfrm>
           <a:prstGeom prst="rect">
             <a:avLst/>
@@ -5693,8 +5693,8 @@
         </p:nvSpPr>
         <p:spPr>
           <a:xfrm>
-            <a:off x="6467094" y="1207008"/>
-            <a:ext cx="697230" cy="237744"/>
+            <a:off x="5262562" y="1181100"/>
+            <a:ext cx="523875" cy="209550"/>
           </a:xfrm>
           <a:prstGeom prst="rect">
             <a:avLst/>
@@ -5751,8 +5751,8 @@
         </p:nvSpPr>
         <p:spPr>
           <a:xfrm>
-            <a:off x="6467094" y="1444752"/>
-            <a:ext cx="697230" cy="384048"/>
+            <a:off x="5262562" y="1409700"/>
+            <a:ext cx="523875" cy="304800"/>
           </a:xfrm>
           <a:prstGeom prst="rect">
             <a:avLst/>
@@ -5811,8 +5811,8 @@
         </p:nvSpPr>
         <p:spPr>
           <a:xfrm>
-            <a:off x="7191755" y="1207008"/>
-            <a:ext cx="697230" cy="237744"/>
+            <a:off x="5819775" y="1181100"/>
+            <a:ext cx="523875" cy="209550"/>
           </a:xfrm>
           <a:prstGeom prst="rect">
             <a:avLst/>
@@ -5869,8 +5869,8 @@
         </p:nvSpPr>
         <p:spPr>
           <a:xfrm>
-            <a:off x="7191755" y="1444752"/>
-            <a:ext cx="697230" cy="384048"/>
+            <a:off x="5819775" y="1409700"/>
+            <a:ext cx="523875" cy="304800"/>
           </a:xfrm>
           <a:prstGeom prst="rect">
             <a:avLst/>
@@ -5929,8 +5929,8 @@
         </p:nvSpPr>
         <p:spPr>
           <a:xfrm>
-            <a:off x="7916417" y="1207008"/>
-            <a:ext cx="697230" cy="237744"/>
+            <a:off x="6376988" y="1181100"/>
+            <a:ext cx="523875" cy="209550"/>
           </a:xfrm>
           <a:prstGeom prst="rect">
             <a:avLst/>
@@ -5987,8 +5987,8 @@
         </p:nvSpPr>
         <p:spPr>
           <a:xfrm>
-            <a:off x="7916417" y="1444752"/>
-            <a:ext cx="697230" cy="384048"/>
+            <a:off x="6376988" y="1409700"/>
+            <a:ext cx="523875" cy="304800"/>
           </a:xfrm>
           <a:prstGeom prst="rect">
             <a:avLst/>
@@ -6047,8 +6047,8 @@
         </p:nvSpPr>
         <p:spPr>
           <a:xfrm>
-            <a:off x="5742431" y="1865376"/>
-            <a:ext cx="1421892" cy="475488"/>
+            <a:off x="4705350" y="1752600"/>
+            <a:ext cx="1081088" cy="381000"/>
           </a:xfrm>
           <a:prstGeom prst="rect">
             <a:avLst/>
@@ -6111,7 +6111,7 @@
                 <a:latin typeface="맑은 고딕"/>
                 <a:ea typeface="맑은 고딕"/>
               </a:rPr>
-              <a:t>56 cores · DDR 512GB</a:t>
+              <a:t>56C · DDR 512GB</a:t>
             </a:r>
           </a:p>
         </p:txBody>
@@ -6124,8 +6124,8 @@
         </p:nvSpPr>
         <p:spPr>
           <a:xfrm>
-            <a:off x="7191755" y="1865376"/>
-            <a:ext cx="1421892" cy="475488"/>
+            <a:off x="5819775" y="1752600"/>
+            <a:ext cx="1081088" cy="381000"/>
           </a:xfrm>
           <a:prstGeom prst="rect">
             <a:avLst/>
@@ -6188,7 +6188,7 @@
                 <a:latin typeface="맑은 고딕"/>
                 <a:ea typeface="맑은 고딕"/>
               </a:rPr>
-              <a:t>56 cores · DDR 512GB</a:t>
+              <a:t>56C · DDR 512GB</a:t>
             </a:r>
           </a:p>
         </p:txBody>
@@ -6201,8 +6201,8 @@
         </p:nvSpPr>
         <p:spPr>
           <a:xfrm>
-            <a:off x="5742431" y="2377440"/>
-            <a:ext cx="697230" cy="237744"/>
+            <a:off x="4705350" y="2181225"/>
+            <a:ext cx="523875" cy="209550"/>
           </a:xfrm>
           <a:prstGeom prst="rect">
             <a:avLst/>
@@ -6246,7 +6246,7 @@
                 <a:latin typeface="맑은 고딕"/>
                 <a:ea typeface="맑은 고딕"/>
               </a:rPr>
-              <a:t>CXL-PNM0</a:t>
+              <a:t>PNM0</a:t>
             </a:r>
           </a:p>
         </p:txBody>
@@ -6259,8 +6259,8 @@
         </p:nvSpPr>
         <p:spPr>
           <a:xfrm>
-            <a:off x="5742431" y="2615184"/>
-            <a:ext cx="697230" cy="384048"/>
+            <a:off x="4705350" y="2409825"/>
+            <a:ext cx="523875" cy="304800"/>
           </a:xfrm>
           <a:prstGeom prst="rect">
             <a:avLst/>
@@ -6319,8 +6319,8 @@
         </p:nvSpPr>
         <p:spPr>
           <a:xfrm>
-            <a:off x="6467094" y="2377440"/>
-            <a:ext cx="697230" cy="237744"/>
+            <a:off x="5262562" y="2181225"/>
+            <a:ext cx="523875" cy="209550"/>
           </a:xfrm>
           <a:prstGeom prst="rect">
             <a:avLst/>
@@ -6364,7 +6364,7 @@
                 <a:latin typeface="맑은 고딕"/>
                 <a:ea typeface="맑은 고딕"/>
               </a:rPr>
-              <a:t>CXL-PNM1</a:t>
+              <a:t>PNM1</a:t>
             </a:r>
           </a:p>
         </p:txBody>
@@ -6377,8 +6377,8 @@
         </p:nvSpPr>
         <p:spPr>
           <a:xfrm>
-            <a:off x="6467094" y="2615184"/>
-            <a:ext cx="697230" cy="384048"/>
+            <a:off x="5262562" y="2409825"/>
+            <a:ext cx="523875" cy="304800"/>
           </a:xfrm>
           <a:prstGeom prst="rect">
             <a:avLst/>
@@ -6437,8 +6437,8 @@
         </p:nvSpPr>
         <p:spPr>
           <a:xfrm>
-            <a:off x="7191755" y="2377440"/>
-            <a:ext cx="697230" cy="237744"/>
+            <a:off x="5819775" y="2181225"/>
+            <a:ext cx="523875" cy="209550"/>
           </a:xfrm>
           <a:prstGeom prst="rect">
             <a:avLst/>
@@ -6482,7 +6482,7 @@
                 <a:latin typeface="맑은 고딕"/>
                 <a:ea typeface="맑은 고딕"/>
               </a:rPr>
-              <a:t>CXL-PNM2</a:t>
+              <a:t>PNM2</a:t>
             </a:r>
           </a:p>
         </p:txBody>
@@ -6495,8 +6495,8 @@
         </p:nvSpPr>
         <p:spPr>
           <a:xfrm>
-            <a:off x="7191755" y="2615184"/>
-            <a:ext cx="697230" cy="384048"/>
+            <a:off x="5819775" y="2409825"/>
+            <a:ext cx="523875" cy="304800"/>
           </a:xfrm>
           <a:prstGeom prst="rect">
             <a:avLst/>
@@ -6555,8 +6555,8 @@
         </p:nvSpPr>
         <p:spPr>
           <a:xfrm>
-            <a:off x="7916417" y="2377440"/>
-            <a:ext cx="697230" cy="237744"/>
+            <a:off x="6376988" y="2181225"/>
+            <a:ext cx="523875" cy="209550"/>
           </a:xfrm>
           <a:prstGeom prst="rect">
             <a:avLst/>
@@ -6600,7 +6600,7 @@
                 <a:latin typeface="맑은 고딕"/>
                 <a:ea typeface="맑은 고딕"/>
               </a:rPr>
-              <a:t>CXL-PNM3</a:t>
+              <a:t>PNM3</a:t>
             </a:r>
           </a:p>
         </p:txBody>
@@ -6613,8 +6613,8 @@
         </p:nvSpPr>
         <p:spPr>
           <a:xfrm>
-            <a:off x="7916417" y="2615184"/>
-            <a:ext cx="697230" cy="384048"/>
+            <a:off x="6376988" y="2409825"/>
+            <a:ext cx="523875" cy="304800"/>
           </a:xfrm>
           <a:prstGeom prst="rect">
             <a:avLst/>
@@ -6673,8 +6673,8 @@
         </p:nvSpPr>
         <p:spPr>
           <a:xfrm>
-            <a:off x="5742431" y="3035808"/>
-            <a:ext cx="1421892" cy="274320"/>
+            <a:off x="4705350" y="2762250"/>
+            <a:ext cx="1081088" cy="247650"/>
           </a:xfrm>
           <a:prstGeom prst="rect">
             <a:avLst/>
@@ -6733,8 +6733,8 @@
         </p:nvSpPr>
         <p:spPr>
           <a:xfrm>
-            <a:off x="7191755" y="3035808"/>
-            <a:ext cx="1421892" cy="274320"/>
+            <a:off x="5819775" y="2762250"/>
+            <a:ext cx="1081088" cy="247650"/>
           </a:xfrm>
           <a:prstGeom prst="rect">
             <a:avLst/>
@@ -6793,8 +6793,8 @@
         </p:nvSpPr>
         <p:spPr>
           <a:xfrm>
-            <a:off x="8833104" y="1133856"/>
-            <a:ext cx="3054096" cy="2249424"/>
+            <a:off x="7086600" y="1133475"/>
+            <a:ext cx="4791075" cy="1933575"/>
           </a:xfrm>
           <a:prstGeom prst="rect">
             <a:avLst/>
@@ -6824,1472 +6824,186 @@
           </a:fontRef>
         </p:style>
         <p:txBody>
-          <a:bodyPr wrap="square" lIns="27432" tIns="0" rIns="27432" bIns="0" rtlCol="0" anchor="ctr"/>
-          <a:lstStyle/>
-          <a:p>
-            <a:pPr algn="ctr">
-              <a:lnSpc>
-                <a:spcPct val="95000"/>
-              </a:lnSpc>
-            </a:pPr>
-            <a:endParaRPr/>
-          </a:p>
-        </p:txBody>
-      </p:sp>
-      <p:sp>
-        <p:nvSpPr>
-          <p:cNvPr id="284" name="Rectangle 54"/>
-          <p:cNvSpPr/>
-          <p:nvPr/>
-        </p:nvSpPr>
-        <p:spPr>
-          <a:xfrm>
-            <a:off x="8924544" y="1207008"/>
-            <a:ext cx="697230" cy="237744"/>
-          </a:xfrm>
-          <a:prstGeom prst="rect">
-            <a:avLst/>
-          </a:prstGeom>
-          <a:solidFill>
-            <a:srgbClr val="1F6FB5"/>
-          </a:solidFill>
-          <a:ln>
-            <a:noFill/>
-          </a:ln>
-          <a:effectLst/>
-        </p:spPr>
-        <p:style>
-          <a:lnRef idx="1">
-            <a:schemeClr val="accent1"/>
-          </a:lnRef>
-          <a:fillRef idx="3">
-            <a:schemeClr val="accent1"/>
-          </a:fillRef>
-          <a:effectRef idx="2">
-            <a:schemeClr val="accent1"/>
-          </a:effectRef>
-          <a:fontRef idx="minor">
-            <a:schemeClr val="lt1"/>
-          </a:fontRef>
-        </p:style>
-        <p:txBody>
-          <a:bodyPr wrap="square" lIns="27432" tIns="0" rIns="27432" bIns="0" rtlCol="0" anchor="ctr"/>
-          <a:lstStyle/>
-          <a:p>
-            <a:pPr algn="ctr">
-              <a:lnSpc>
-                <a:spcPct val="95000"/>
-              </a:lnSpc>
-            </a:pPr>
-            <a:r>
-              <a:rPr sz="700" b="1" i="0">
-                <a:solidFill>
-                  <a:srgbClr val="FFFFFF"/>
-                </a:solidFill>
-                <a:latin typeface="맑은 고딕"/>
-                <a:ea typeface="맑은 고딕"/>
-              </a:rPr>
-              <a:t>GPU0</a:t>
-            </a:r>
-          </a:p>
-        </p:txBody>
-      </p:sp>
-      <p:sp>
-        <p:nvSpPr>
-          <p:cNvPr id="285" name="Rectangle 55"/>
-          <p:cNvSpPr/>
-          <p:nvPr/>
-        </p:nvSpPr>
-        <p:spPr>
-          <a:xfrm>
-            <a:off x="8924544" y="1444752"/>
-            <a:ext cx="697230" cy="192024"/>
-          </a:xfrm>
-          <a:prstGeom prst="rect">
-            <a:avLst/>
-          </a:prstGeom>
-          <a:solidFill>
-            <a:srgbClr val="DAE8F6"/>
-          </a:solidFill>
-          <a:ln w="9525">
-            <a:solidFill>
-              <a:srgbClr val="1F6FB5"/>
-            </a:solidFill>
-          </a:ln>
-          <a:effectLst/>
-        </p:spPr>
-        <p:style>
-          <a:lnRef idx="1">
-            <a:schemeClr val="accent1"/>
-          </a:lnRef>
-          <a:fillRef idx="3">
-            <a:schemeClr val="accent1"/>
-          </a:fillRef>
-          <a:effectRef idx="2">
-            <a:schemeClr val="accent1"/>
-          </a:effectRef>
-          <a:fontRef idx="minor">
-            <a:schemeClr val="lt1"/>
-          </a:fontRef>
-        </p:style>
-        <p:txBody>
-          <a:bodyPr wrap="square" lIns="27432" tIns="0" rIns="27432" bIns="0" rtlCol="0" anchor="ctr"/>
-          <a:lstStyle/>
-          <a:p>
-            <a:pPr algn="ctr">
-              <a:lnSpc>
-                <a:spcPct val="95000"/>
-              </a:lnSpc>
-            </a:pPr>
-            <a:r>
-              <a:rPr sz="700" b="1" i="0">
-                <a:solidFill>
-                  <a:srgbClr val="1F6FB5"/>
-                </a:solidFill>
-                <a:latin typeface="맑은 고딕"/>
-                <a:ea typeface="맑은 고딕"/>
-              </a:rPr>
-              <a:t>HBM 40GB</a:t>
-            </a:r>
-          </a:p>
-        </p:txBody>
-      </p:sp>
-      <p:sp>
-        <p:nvSpPr>
-          <p:cNvPr id="286" name="Rectangle 56"/>
-          <p:cNvSpPr/>
-          <p:nvPr/>
-        </p:nvSpPr>
-        <p:spPr>
-          <a:xfrm>
-            <a:off x="8924544" y="1636776"/>
-            <a:ext cx="697230" cy="192024"/>
-          </a:xfrm>
-          <a:prstGeom prst="rect">
-            <a:avLst/>
-          </a:prstGeom>
-          <a:solidFill>
-            <a:srgbClr val="E7DEF2"/>
-          </a:solidFill>
-          <a:ln w="9525">
-            <a:solidFill>
-              <a:srgbClr val="7B5EA7"/>
-            </a:solidFill>
-          </a:ln>
-          <a:effectLst/>
-        </p:spPr>
-        <p:style>
-          <a:lnRef idx="1">
-            <a:schemeClr val="accent1"/>
-          </a:lnRef>
-          <a:fillRef idx="3">
-            <a:schemeClr val="accent1"/>
-          </a:fillRef>
-          <a:effectRef idx="2">
-            <a:schemeClr val="accent1"/>
-          </a:effectRef>
-          <a:fontRef idx="minor">
-            <a:schemeClr val="lt1"/>
-          </a:fontRef>
-        </p:style>
-        <p:txBody>
-          <a:bodyPr wrap="square" lIns="27432" tIns="0" rIns="27432" bIns="0" rtlCol="0" anchor="ctr"/>
-          <a:lstStyle/>
-          <a:p>
-            <a:pPr algn="ctr">
-              <a:lnSpc>
-                <a:spcPct val="95000"/>
-              </a:lnSpc>
-            </a:pPr>
-            <a:r>
-              <a:rPr sz="700" b="1" i="0">
-                <a:solidFill>
-                  <a:srgbClr val="4A2E73"/>
-                </a:solidFill>
-                <a:latin typeface="맑은 고딕"/>
-                <a:ea typeface="맑은 고딕"/>
-              </a:rPr>
-              <a:t>HBF 320GB</a:t>
-            </a:r>
-          </a:p>
-        </p:txBody>
-      </p:sp>
-      <p:sp>
-        <p:nvSpPr>
-          <p:cNvPr id="287" name="Rectangle 57"/>
-          <p:cNvSpPr/>
-          <p:nvPr/>
-        </p:nvSpPr>
-        <p:spPr>
-          <a:xfrm>
-            <a:off x="9649206" y="1207008"/>
-            <a:ext cx="697230" cy="237744"/>
-          </a:xfrm>
-          <a:prstGeom prst="rect">
-            <a:avLst/>
-          </a:prstGeom>
-          <a:solidFill>
-            <a:srgbClr val="1F6FB5"/>
-          </a:solidFill>
-          <a:ln>
-            <a:noFill/>
-          </a:ln>
-          <a:effectLst/>
-        </p:spPr>
-        <p:style>
-          <a:lnRef idx="1">
-            <a:schemeClr val="accent1"/>
-          </a:lnRef>
-          <a:fillRef idx="3">
-            <a:schemeClr val="accent1"/>
-          </a:fillRef>
-          <a:effectRef idx="2">
-            <a:schemeClr val="accent1"/>
-          </a:effectRef>
-          <a:fontRef idx="minor">
-            <a:schemeClr val="lt1"/>
-          </a:fontRef>
-        </p:style>
-        <p:txBody>
-          <a:bodyPr wrap="square" lIns="27432" tIns="0" rIns="27432" bIns="0" rtlCol="0" anchor="ctr"/>
-          <a:lstStyle/>
-          <a:p>
-            <a:pPr algn="ctr">
-              <a:lnSpc>
-                <a:spcPct val="95000"/>
-              </a:lnSpc>
-            </a:pPr>
-            <a:r>
-              <a:rPr sz="700" b="1" i="0">
-                <a:solidFill>
-                  <a:srgbClr val="FFFFFF"/>
-                </a:solidFill>
-                <a:latin typeface="맑은 고딕"/>
-                <a:ea typeface="맑은 고딕"/>
-              </a:rPr>
-              <a:t>GPU1</a:t>
-            </a:r>
-          </a:p>
-        </p:txBody>
-      </p:sp>
-      <p:sp>
-        <p:nvSpPr>
-          <p:cNvPr id="288" name="Rectangle 58"/>
-          <p:cNvSpPr/>
-          <p:nvPr/>
-        </p:nvSpPr>
-        <p:spPr>
-          <a:xfrm>
-            <a:off x="9649206" y="1444752"/>
-            <a:ext cx="697230" cy="192024"/>
-          </a:xfrm>
-          <a:prstGeom prst="rect">
-            <a:avLst/>
-          </a:prstGeom>
-          <a:solidFill>
-            <a:srgbClr val="DAE8F6"/>
-          </a:solidFill>
-          <a:ln w="9525">
-            <a:solidFill>
-              <a:srgbClr val="1F6FB5"/>
-            </a:solidFill>
-          </a:ln>
-          <a:effectLst/>
-        </p:spPr>
-        <p:style>
-          <a:lnRef idx="1">
-            <a:schemeClr val="accent1"/>
-          </a:lnRef>
-          <a:fillRef idx="3">
-            <a:schemeClr val="accent1"/>
-          </a:fillRef>
-          <a:effectRef idx="2">
-            <a:schemeClr val="accent1"/>
-          </a:effectRef>
-          <a:fontRef idx="minor">
-            <a:schemeClr val="lt1"/>
-          </a:fontRef>
-        </p:style>
-        <p:txBody>
-          <a:bodyPr wrap="square" lIns="27432" tIns="0" rIns="27432" bIns="0" rtlCol="0" anchor="ctr"/>
-          <a:lstStyle/>
-          <a:p>
-            <a:pPr algn="ctr">
-              <a:lnSpc>
-                <a:spcPct val="95000"/>
-              </a:lnSpc>
-            </a:pPr>
-            <a:r>
-              <a:rPr sz="700" b="1" i="0">
-                <a:solidFill>
-                  <a:srgbClr val="1F6FB5"/>
-                </a:solidFill>
-                <a:latin typeface="맑은 고딕"/>
-                <a:ea typeface="맑은 고딕"/>
-              </a:rPr>
-              <a:t>HBM 40GB</a:t>
-            </a:r>
-          </a:p>
-        </p:txBody>
-      </p:sp>
-      <p:sp>
-        <p:nvSpPr>
-          <p:cNvPr id="289" name="Rectangle 59"/>
-          <p:cNvSpPr/>
-          <p:nvPr/>
-        </p:nvSpPr>
-        <p:spPr>
-          <a:xfrm>
-            <a:off x="9649206" y="1636776"/>
-            <a:ext cx="697230" cy="192024"/>
-          </a:xfrm>
-          <a:prstGeom prst="rect">
-            <a:avLst/>
-          </a:prstGeom>
-          <a:solidFill>
-            <a:srgbClr val="E7DEF2"/>
-          </a:solidFill>
-          <a:ln w="9525">
-            <a:solidFill>
-              <a:srgbClr val="7B5EA7"/>
-            </a:solidFill>
-          </a:ln>
-          <a:effectLst/>
-        </p:spPr>
-        <p:style>
-          <a:lnRef idx="1">
-            <a:schemeClr val="accent1"/>
-          </a:lnRef>
-          <a:fillRef idx="3">
-            <a:schemeClr val="accent1"/>
-          </a:fillRef>
-          <a:effectRef idx="2">
-            <a:schemeClr val="accent1"/>
-          </a:effectRef>
-          <a:fontRef idx="minor">
-            <a:schemeClr val="lt1"/>
-          </a:fontRef>
-        </p:style>
-        <p:txBody>
-          <a:bodyPr wrap="square" lIns="27432" tIns="0" rIns="27432" bIns="0" rtlCol="0" anchor="ctr"/>
-          <a:lstStyle/>
-          <a:p>
-            <a:pPr algn="ctr">
-              <a:lnSpc>
-                <a:spcPct val="95000"/>
-              </a:lnSpc>
-            </a:pPr>
-            <a:r>
-              <a:rPr sz="700" b="1" i="0">
-                <a:solidFill>
-                  <a:srgbClr val="4A2E73"/>
-                </a:solidFill>
-                <a:latin typeface="맑은 고딕"/>
-                <a:ea typeface="맑은 고딕"/>
-              </a:rPr>
-              <a:t>HBF 320GB</a:t>
-            </a:r>
-          </a:p>
-        </p:txBody>
-      </p:sp>
-      <p:sp>
-        <p:nvSpPr>
-          <p:cNvPr id="290" name="Rectangle 60"/>
-          <p:cNvSpPr/>
-          <p:nvPr/>
-        </p:nvSpPr>
-        <p:spPr>
-          <a:xfrm>
-            <a:off x="10373867" y="1207008"/>
-            <a:ext cx="697230" cy="237744"/>
-          </a:xfrm>
-          <a:prstGeom prst="rect">
-            <a:avLst/>
-          </a:prstGeom>
-          <a:solidFill>
-            <a:srgbClr val="1F6FB5"/>
-          </a:solidFill>
-          <a:ln>
-            <a:noFill/>
-          </a:ln>
-          <a:effectLst/>
-        </p:spPr>
-        <p:style>
-          <a:lnRef idx="1">
-            <a:schemeClr val="accent1"/>
-          </a:lnRef>
-          <a:fillRef idx="3">
-            <a:schemeClr val="accent1"/>
-          </a:fillRef>
-          <a:effectRef idx="2">
-            <a:schemeClr val="accent1"/>
-          </a:effectRef>
-          <a:fontRef idx="minor">
-            <a:schemeClr val="lt1"/>
-          </a:fontRef>
-        </p:style>
-        <p:txBody>
-          <a:bodyPr wrap="square" lIns="27432" tIns="0" rIns="27432" bIns="0" rtlCol="0" anchor="ctr"/>
-          <a:lstStyle/>
-          <a:p>
-            <a:pPr algn="ctr">
-              <a:lnSpc>
-                <a:spcPct val="95000"/>
-              </a:lnSpc>
-            </a:pPr>
-            <a:r>
-              <a:rPr sz="700" b="1" i="0">
-                <a:solidFill>
-                  <a:srgbClr val="FFFFFF"/>
-                </a:solidFill>
-                <a:latin typeface="맑은 고딕"/>
-                <a:ea typeface="맑은 고딕"/>
-              </a:rPr>
-              <a:t>GPU2</a:t>
-            </a:r>
-          </a:p>
-        </p:txBody>
-      </p:sp>
-      <p:sp>
-        <p:nvSpPr>
-          <p:cNvPr id="291" name="Rectangle 61"/>
-          <p:cNvSpPr/>
-          <p:nvPr/>
-        </p:nvSpPr>
-        <p:spPr>
-          <a:xfrm>
-            <a:off x="10373867" y="1444752"/>
-            <a:ext cx="697230" cy="192024"/>
-          </a:xfrm>
-          <a:prstGeom prst="rect">
-            <a:avLst/>
-          </a:prstGeom>
-          <a:solidFill>
-            <a:srgbClr val="DAE8F6"/>
-          </a:solidFill>
-          <a:ln w="9525">
-            <a:solidFill>
-              <a:srgbClr val="1F6FB5"/>
-            </a:solidFill>
-          </a:ln>
-          <a:effectLst/>
-        </p:spPr>
-        <p:style>
-          <a:lnRef idx="1">
-            <a:schemeClr val="accent1"/>
-          </a:lnRef>
-          <a:fillRef idx="3">
-            <a:schemeClr val="accent1"/>
-          </a:fillRef>
-          <a:effectRef idx="2">
-            <a:schemeClr val="accent1"/>
-          </a:effectRef>
-          <a:fontRef idx="minor">
-            <a:schemeClr val="lt1"/>
-          </a:fontRef>
-        </p:style>
-        <p:txBody>
-          <a:bodyPr wrap="square" lIns="27432" tIns="0" rIns="27432" bIns="0" rtlCol="0" anchor="ctr"/>
-          <a:lstStyle/>
-          <a:p>
-            <a:pPr algn="ctr">
-              <a:lnSpc>
-                <a:spcPct val="95000"/>
-              </a:lnSpc>
-            </a:pPr>
-            <a:r>
-              <a:rPr sz="700" b="1" i="0">
-                <a:solidFill>
-                  <a:srgbClr val="1F6FB5"/>
-                </a:solidFill>
-                <a:latin typeface="맑은 고딕"/>
-                <a:ea typeface="맑은 고딕"/>
-              </a:rPr>
-              <a:t>HBM 40GB</a:t>
-            </a:r>
-          </a:p>
-        </p:txBody>
-      </p:sp>
-      <p:sp>
-        <p:nvSpPr>
-          <p:cNvPr id="292" name="Rectangle 62"/>
-          <p:cNvSpPr/>
-          <p:nvPr/>
-        </p:nvSpPr>
-        <p:spPr>
-          <a:xfrm>
-            <a:off x="10373867" y="1636776"/>
-            <a:ext cx="697230" cy="192024"/>
-          </a:xfrm>
-          <a:prstGeom prst="rect">
-            <a:avLst/>
-          </a:prstGeom>
-          <a:solidFill>
-            <a:srgbClr val="E7DEF2"/>
-          </a:solidFill>
-          <a:ln w="9525">
-            <a:solidFill>
-              <a:srgbClr val="7B5EA7"/>
-            </a:solidFill>
-          </a:ln>
-          <a:effectLst/>
-        </p:spPr>
-        <p:style>
-          <a:lnRef idx="1">
-            <a:schemeClr val="accent1"/>
-          </a:lnRef>
-          <a:fillRef idx="3">
-            <a:schemeClr val="accent1"/>
-          </a:fillRef>
-          <a:effectRef idx="2">
-            <a:schemeClr val="accent1"/>
-          </a:effectRef>
-          <a:fontRef idx="minor">
-            <a:schemeClr val="lt1"/>
-          </a:fontRef>
-        </p:style>
-        <p:txBody>
-          <a:bodyPr wrap="square" lIns="27432" tIns="0" rIns="27432" bIns="0" rtlCol="0" anchor="ctr"/>
-          <a:lstStyle/>
-          <a:p>
-            <a:pPr algn="ctr">
-              <a:lnSpc>
-                <a:spcPct val="95000"/>
-              </a:lnSpc>
-            </a:pPr>
-            <a:r>
-              <a:rPr sz="700" b="1" i="0">
-                <a:solidFill>
-                  <a:srgbClr val="4A2E73"/>
-                </a:solidFill>
-                <a:latin typeface="맑은 고딕"/>
-                <a:ea typeface="맑은 고딕"/>
-              </a:rPr>
-              <a:t>HBF 320GB</a:t>
-            </a:r>
-          </a:p>
-        </p:txBody>
-      </p:sp>
-      <p:sp>
-        <p:nvSpPr>
-          <p:cNvPr id="293" name="Rectangle 63"/>
-          <p:cNvSpPr/>
-          <p:nvPr/>
-        </p:nvSpPr>
-        <p:spPr>
-          <a:xfrm>
-            <a:off x="11098530" y="1207008"/>
-            <a:ext cx="697230" cy="237744"/>
-          </a:xfrm>
-          <a:prstGeom prst="rect">
-            <a:avLst/>
-          </a:prstGeom>
-          <a:solidFill>
-            <a:srgbClr val="1F6FB5"/>
-          </a:solidFill>
-          <a:ln>
-            <a:noFill/>
-          </a:ln>
-          <a:effectLst/>
-        </p:spPr>
-        <p:style>
-          <a:lnRef idx="1">
-            <a:schemeClr val="accent1"/>
-          </a:lnRef>
-          <a:fillRef idx="3">
-            <a:schemeClr val="accent1"/>
-          </a:fillRef>
-          <a:effectRef idx="2">
-            <a:schemeClr val="accent1"/>
-          </a:effectRef>
-          <a:fontRef idx="minor">
-            <a:schemeClr val="lt1"/>
-          </a:fontRef>
-        </p:style>
-        <p:txBody>
-          <a:bodyPr wrap="square" lIns="27432" tIns="0" rIns="27432" bIns="0" rtlCol="0" anchor="ctr"/>
-          <a:lstStyle/>
-          <a:p>
-            <a:pPr algn="ctr">
-              <a:lnSpc>
-                <a:spcPct val="95000"/>
-              </a:lnSpc>
-            </a:pPr>
-            <a:r>
-              <a:rPr sz="700" b="1" i="0">
-                <a:solidFill>
-                  <a:srgbClr val="FFFFFF"/>
-                </a:solidFill>
-                <a:latin typeface="맑은 고딕"/>
-                <a:ea typeface="맑은 고딕"/>
-              </a:rPr>
-              <a:t>GPU3</a:t>
-            </a:r>
-          </a:p>
-        </p:txBody>
-      </p:sp>
-      <p:sp>
-        <p:nvSpPr>
-          <p:cNvPr id="294" name="Rectangle 64"/>
-          <p:cNvSpPr/>
-          <p:nvPr/>
-        </p:nvSpPr>
-        <p:spPr>
-          <a:xfrm>
-            <a:off x="11098530" y="1444752"/>
-            <a:ext cx="697230" cy="192024"/>
-          </a:xfrm>
-          <a:prstGeom prst="rect">
-            <a:avLst/>
-          </a:prstGeom>
-          <a:solidFill>
-            <a:srgbClr val="DAE8F6"/>
-          </a:solidFill>
-          <a:ln w="9525">
-            <a:solidFill>
-              <a:srgbClr val="1F6FB5"/>
-            </a:solidFill>
-          </a:ln>
-          <a:effectLst/>
-        </p:spPr>
-        <p:style>
-          <a:lnRef idx="1">
-            <a:schemeClr val="accent1"/>
-          </a:lnRef>
-          <a:fillRef idx="3">
-            <a:schemeClr val="accent1"/>
-          </a:fillRef>
-          <a:effectRef idx="2">
-            <a:schemeClr val="accent1"/>
-          </a:effectRef>
-          <a:fontRef idx="minor">
-            <a:schemeClr val="lt1"/>
-          </a:fontRef>
-        </p:style>
-        <p:txBody>
-          <a:bodyPr wrap="square" lIns="27432" tIns="0" rIns="27432" bIns="0" rtlCol="0" anchor="ctr"/>
-          <a:lstStyle/>
-          <a:p>
-            <a:pPr algn="ctr">
-              <a:lnSpc>
-                <a:spcPct val="95000"/>
-              </a:lnSpc>
-            </a:pPr>
-            <a:r>
-              <a:rPr sz="700" b="1" i="0">
-                <a:solidFill>
-                  <a:srgbClr val="1F6FB5"/>
-                </a:solidFill>
-                <a:latin typeface="맑은 고딕"/>
-                <a:ea typeface="맑은 고딕"/>
-              </a:rPr>
-              <a:t>HBM 40GB</a:t>
-            </a:r>
-          </a:p>
-        </p:txBody>
-      </p:sp>
-      <p:sp>
-        <p:nvSpPr>
-          <p:cNvPr id="295" name="Rectangle 65"/>
-          <p:cNvSpPr/>
-          <p:nvPr/>
-        </p:nvSpPr>
-        <p:spPr>
-          <a:xfrm>
-            <a:off x="11098530" y="1636776"/>
-            <a:ext cx="697230" cy="192024"/>
-          </a:xfrm>
-          <a:prstGeom prst="rect">
-            <a:avLst/>
-          </a:prstGeom>
-          <a:solidFill>
-            <a:srgbClr val="E7DEF2"/>
-          </a:solidFill>
-          <a:ln w="9525">
-            <a:solidFill>
-              <a:srgbClr val="7B5EA7"/>
-            </a:solidFill>
-          </a:ln>
-          <a:effectLst/>
-        </p:spPr>
-        <p:style>
-          <a:lnRef idx="1">
-            <a:schemeClr val="accent1"/>
-          </a:lnRef>
-          <a:fillRef idx="3">
-            <a:schemeClr val="accent1"/>
-          </a:fillRef>
-          <a:effectRef idx="2">
-            <a:schemeClr val="accent1"/>
-          </a:effectRef>
-          <a:fontRef idx="minor">
-            <a:schemeClr val="lt1"/>
-          </a:fontRef>
-        </p:style>
-        <p:txBody>
-          <a:bodyPr wrap="square" lIns="27432" tIns="0" rIns="27432" bIns="0" rtlCol="0" anchor="ctr"/>
-          <a:lstStyle/>
-          <a:p>
-            <a:pPr algn="ctr">
-              <a:lnSpc>
-                <a:spcPct val="95000"/>
-              </a:lnSpc>
-            </a:pPr>
-            <a:r>
-              <a:rPr sz="700" b="1" i="0">
-                <a:solidFill>
-                  <a:srgbClr val="4A2E73"/>
-                </a:solidFill>
-                <a:latin typeface="맑은 고딕"/>
-                <a:ea typeface="맑은 고딕"/>
-              </a:rPr>
-              <a:t>HBF 320GB</a:t>
-            </a:r>
-          </a:p>
-        </p:txBody>
-      </p:sp>
-      <p:sp>
-        <p:nvSpPr>
-          <p:cNvPr id="296" name="Rectangle 66"/>
-          <p:cNvSpPr/>
-          <p:nvPr/>
-        </p:nvSpPr>
-        <p:spPr>
-          <a:xfrm>
-            <a:off x="8924544" y="1865376"/>
-            <a:ext cx="1421892" cy="475488"/>
-          </a:xfrm>
-          <a:prstGeom prst="rect">
-            <a:avLst/>
-          </a:prstGeom>
-          <a:solidFill>
-            <a:srgbClr val="F2F2F2"/>
-          </a:solidFill>
-          <a:ln w="9525">
-            <a:solidFill>
-              <a:srgbClr val="A6A6A6"/>
-            </a:solidFill>
-          </a:ln>
-          <a:effectLst/>
-        </p:spPr>
-        <p:style>
-          <a:lnRef idx="1">
-            <a:schemeClr val="accent1"/>
-          </a:lnRef>
-          <a:fillRef idx="3">
-            <a:schemeClr val="accent1"/>
-          </a:fillRef>
-          <a:effectRef idx="2">
-            <a:schemeClr val="accent1"/>
-          </a:effectRef>
-          <a:fontRef idx="minor">
-            <a:schemeClr val="lt1"/>
-          </a:fontRef>
-        </p:style>
-        <p:txBody>
-          <a:bodyPr wrap="square" lIns="27432" tIns="0" rIns="27432" bIns="0" rtlCol="0" anchor="ctr"/>
-          <a:lstStyle/>
-          <a:p>
-            <a:pPr algn="ctr">
+          <a:bodyPr wrap="square" lIns="82296" tIns="64008" rIns="82296" bIns="0" rtlCol="0" anchor="t"/>
+          <a:lstStyle/>
+          <a:p>
+            <a:pPr algn="l">
               <a:lnSpc>
                 <a:spcPct val="115000"/>
               </a:lnSpc>
+              <a:spcAft>
+                <a:spcPts val="400"/>
+              </a:spcAft>
             </a:pPr>
             <a:r>
-              <a:rPr sz="750" b="0" i="0">
+              <a:rPr sz="800" b="1" i="0">
+                <a:solidFill>
+                  <a:srgbClr val="1F4E79"/>
+                </a:solidFill>
+                <a:latin typeface="맑은 고딕"/>
+                <a:ea typeface="맑은 고딕"/>
+              </a:rPr>
+              <a:t>GPU  </a:t>
+            </a:r>
+            <a:r>
+              <a:rPr sz="800" b="0" i="0">
                 <a:solidFill>
                   <a:srgbClr val="262626"/>
                 </a:solidFill>
                 <a:latin typeface="맑은 고딕"/>
                 <a:ea typeface="맑은 고딕"/>
               </a:rPr>
-              <a:t>CPU0</a:t>
-            </a:r>
-          </a:p>
-          <a:p>
-            <a:pPr algn="ctr">
+              <a:t>NVIDIA H100 SXM5 80GB · HBM3 (5-stack) · 3.35 TB/s · 132 SM — 신품 $30K/장 (HBM 포함)</a:t>
+            </a:r>
+          </a:p>
+          <a:p>
+            <a:pPr algn="l">
               <a:lnSpc>
                 <a:spcPct val="115000"/>
               </a:lnSpc>
+              <a:spcAft>
+                <a:spcPts val="400"/>
+              </a:spcAft>
             </a:pPr>
             <a:r>
-              <a:rPr sz="750" b="0" i="0">
+              <a:rPr sz="800" b="1" i="0">
+                <a:solidFill>
+                  <a:srgbClr val="1F4E79"/>
+                </a:solidFill>
+                <a:latin typeface="맑은 고딕"/>
+                <a:ea typeface="맑은 고딕"/>
+              </a:rPr>
+              <a:t>CPU  </a:t>
+            </a:r>
+            <a:r>
+              <a:rPr sz="800" b="0" i="0">
                 <a:solidFill>
                   <a:srgbClr val="262626"/>
                 </a:solidFill>
                 <a:latin typeface="맑은 고딕"/>
                 <a:ea typeface="맑은 고딕"/>
               </a:rPr>
-              <a:t>56 cores · DDR 512GB</a:t>
-            </a:r>
-          </a:p>
-        </p:txBody>
-      </p:sp>
-      <p:sp>
-        <p:nvSpPr>
-          <p:cNvPr id="297" name="Rectangle 67"/>
-          <p:cNvSpPr/>
-          <p:nvPr/>
-        </p:nvSpPr>
-        <p:spPr>
-          <a:xfrm>
-            <a:off x="10373867" y="1865376"/>
-            <a:ext cx="1421892" cy="475488"/>
-          </a:xfrm>
-          <a:prstGeom prst="rect">
-            <a:avLst/>
-          </a:prstGeom>
-          <a:solidFill>
-            <a:srgbClr val="F2F2F2"/>
-          </a:solidFill>
-          <a:ln w="9525">
-            <a:solidFill>
-              <a:srgbClr val="A6A6A6"/>
-            </a:solidFill>
-          </a:ln>
-          <a:effectLst/>
-        </p:spPr>
-        <p:style>
-          <a:lnRef idx="1">
-            <a:schemeClr val="accent1"/>
-          </a:lnRef>
-          <a:fillRef idx="3">
-            <a:schemeClr val="accent1"/>
-          </a:fillRef>
-          <a:effectRef idx="2">
-            <a:schemeClr val="accent1"/>
-          </a:effectRef>
-          <a:fontRef idx="minor">
-            <a:schemeClr val="lt1"/>
-          </a:fontRef>
-        </p:style>
-        <p:txBody>
-          <a:bodyPr wrap="square" lIns="27432" tIns="0" rIns="27432" bIns="0" rtlCol="0" anchor="ctr"/>
-          <a:lstStyle/>
-          <a:p>
-            <a:pPr algn="ctr">
+              <a:t>Xeon Platinum 8480+급 (Sapphire Rapids, 56C) × 2소켓 · DDR5-4800 8ch × 64GB RDIMM = 512GB/소켓 — 신품 $35/GB</a:t>
+            </a:r>
+          </a:p>
+          <a:p>
+            <a:pPr algn="l">
               <a:lnSpc>
                 <a:spcPct val="115000"/>
               </a:lnSpc>
+              <a:spcAft>
+                <a:spcPts val="400"/>
+              </a:spcAft>
             </a:pPr>
             <a:r>
-              <a:rPr sz="750" b="0" i="0">
+              <a:rPr sz="800" b="1" i="0">
+                <a:solidFill>
+                  <a:srgbClr val="1F4E79"/>
+                </a:solidFill>
+                <a:latin typeface="맑은 고딕"/>
+                <a:ea typeface="맑은 고딕"/>
+              </a:rPr>
+              <a:t>CXL-PNM  </a:t>
+            </a:r>
+            <a:r>
+              <a:rPr sz="800" b="0" i="0">
                 <a:solidFill>
                   <a:srgbClr val="262626"/>
                 </a:solidFill>
                 <a:latin typeface="맑은 고딕"/>
                 <a:ea typeface="맑은 고딕"/>
               </a:rPr>
-              <a:t>CPU1</a:t>
-            </a:r>
-          </a:p>
-          <a:p>
-            <a:pPr algn="ctr">
+              <a:t>Marvell Structera A 2504 (CXL Type-3 · Arm Neoverse V2 16코어 near-memory) · DDR5-6400 4ch × 32GB RDIMM = 128GB/카드 — 카드 $1.5K (가정, 가격 비공개)</a:t>
+            </a:r>
+          </a:p>
+          <a:p>
+            <a:pPr algn="l">
               <a:lnSpc>
                 <a:spcPct val="115000"/>
               </a:lnSpc>
+              <a:spcAft>
+                <a:spcPts val="400"/>
+              </a:spcAft>
             </a:pPr>
             <a:r>
-              <a:rPr sz="750" b="0" i="0">
+              <a:rPr sz="800" b="1" i="0">
+                <a:solidFill>
+                  <a:srgbClr val="1F4E79"/>
+                </a:solidFill>
+                <a:latin typeface="맑은 고딕"/>
+                <a:ea typeface="맑은 고딕"/>
+              </a:rPr>
+              <a:t>NVMe SSD  </a:t>
+            </a:r>
+            <a:r>
+              <a:rPr sz="800" b="0" i="0">
                 <a:solidFill>
                   <a:srgbClr val="262626"/>
                 </a:solidFill>
                 <a:latin typeface="맑은 고딕"/>
                 <a:ea typeface="맑은 고딕"/>
               </a:rPr>
-              <a:t>56 cores · DDR 512GB</a:t>
-            </a:r>
-          </a:p>
-        </p:txBody>
-      </p:sp>
-      <p:sp>
-        <p:nvSpPr>
-          <p:cNvPr id="298" name="Rectangle 68"/>
-          <p:cNvSpPr/>
-          <p:nvPr/>
-        </p:nvSpPr>
-        <p:spPr>
-          <a:xfrm>
-            <a:off x="8924544" y="2377440"/>
-            <a:ext cx="697230" cy="237744"/>
-          </a:xfrm>
-          <a:prstGeom prst="rect">
-            <a:avLst/>
-          </a:prstGeom>
-          <a:solidFill>
-            <a:srgbClr val="BF8F00"/>
-          </a:solidFill>
-          <a:ln>
-            <a:noFill/>
-          </a:ln>
-          <a:effectLst/>
-        </p:spPr>
-        <p:style>
-          <a:lnRef idx="1">
-            <a:schemeClr val="accent1"/>
-          </a:lnRef>
-          <a:fillRef idx="3">
-            <a:schemeClr val="accent1"/>
-          </a:fillRef>
-          <a:effectRef idx="2">
-            <a:schemeClr val="accent1"/>
-          </a:effectRef>
-          <a:fontRef idx="minor">
-            <a:schemeClr val="lt1"/>
-          </a:fontRef>
-        </p:style>
-        <p:txBody>
-          <a:bodyPr wrap="square" lIns="27432" tIns="0" rIns="27432" bIns="0" rtlCol="0" anchor="ctr"/>
-          <a:lstStyle/>
-          <a:p>
-            <a:pPr algn="ctr">
+              <a:t>엔터프라이즈 PCIe Gen4 U.3 TLC (Micron 7450 PRO급) 4TB × 4대, 7 GB/s × 4 = 28 GB/s — 신품 $0.45/GB</a:t>
+            </a:r>
+          </a:p>
+          <a:p>
+            <a:pPr algn="l">
               <a:lnSpc>
-                <a:spcPct val="95000"/>
+                <a:spcPct val="115000"/>
               </a:lnSpc>
+              <a:spcAft>
+                <a:spcPts val="400"/>
+              </a:spcAft>
             </a:pPr>
             <a:r>
-              <a:rPr sz="700" b="1" i="0">
-                <a:solidFill>
-                  <a:srgbClr val="FFFFFF"/>
-                </a:solidFill>
-                <a:latin typeface="맑은 고딕"/>
-                <a:ea typeface="맑은 고딕"/>
-              </a:rPr>
-              <a:t>CXL-PNM0</a:t>
-            </a:r>
-          </a:p>
-        </p:txBody>
-      </p:sp>
-      <p:sp>
-        <p:nvSpPr>
-          <p:cNvPr id="299" name="Rectangle 69"/>
-          <p:cNvSpPr/>
-          <p:nvPr/>
-        </p:nvSpPr>
-        <p:spPr>
-          <a:xfrm>
-            <a:off x="8924544" y="2615184"/>
-            <a:ext cx="697230" cy="384048"/>
-          </a:xfrm>
-          <a:prstGeom prst="rect">
-            <a:avLst/>
-          </a:prstGeom>
-          <a:solidFill>
-            <a:srgbClr val="FFF2CC"/>
-          </a:solidFill>
-          <a:ln w="9525">
-            <a:solidFill>
-              <a:srgbClr val="BF8F00"/>
-            </a:solidFill>
-          </a:ln>
-          <a:effectLst/>
-        </p:spPr>
-        <p:style>
-          <a:lnRef idx="1">
-            <a:schemeClr val="accent1"/>
-          </a:lnRef>
-          <a:fillRef idx="3">
-            <a:schemeClr val="accent1"/>
-          </a:fillRef>
-          <a:effectRef idx="2">
-            <a:schemeClr val="accent1"/>
-          </a:effectRef>
-          <a:fontRef idx="minor">
-            <a:schemeClr val="lt1"/>
-          </a:fontRef>
-        </p:style>
-        <p:txBody>
-          <a:bodyPr wrap="square" lIns="27432" tIns="0" rIns="27432" bIns="0" rtlCol="0" anchor="ctr"/>
-          <a:lstStyle/>
-          <a:p>
-            <a:pPr algn="ctr">
+              <a:rPr sz="800" b="1" i="0">
+                <a:solidFill>
+                  <a:srgbClr val="1F4E79"/>
+                </a:solidFill>
+                <a:latin typeface="맑은 고딕"/>
+                <a:ea typeface="맑은 고딕"/>
+              </a:rPr>
+              <a:t>PIM-SSD  </a:t>
+            </a:r>
+            <a:r>
+              <a:rPr sz="800" b="0" i="0">
+                <a:solidFill>
+                  <a:srgbClr val="262626"/>
+                </a:solidFill>
+                <a:latin typeface="맑은 고딕"/>
+                <a:ea typeface="맑은 고딕"/>
+              </a:rPr>
+              <a:t>연산 내장 SSD — NVMe와 동일 용량 · 대역폭 · 단가로 가정</a:t>
+            </a:r>
+          </a:p>
+          <a:p>
+            <a:pPr algn="l">
               <a:lnSpc>
-                <a:spcPct val="95000"/>
+                <a:spcPct val="115000"/>
               </a:lnSpc>
+              <a:spcAft>
+                <a:spcPts val="400"/>
+              </a:spcAft>
             </a:pPr>
             <a:r>
-              <a:rPr sz="700" b="1" i="0">
-                <a:solidFill>
-                  <a:srgbClr val="7F5F00"/>
-                </a:solidFill>
-                <a:latin typeface="맑은 고딕"/>
-                <a:ea typeface="맑은 고딕"/>
-              </a:rPr>
-              <a:t>DDR 128GB</a:t>
-            </a:r>
-          </a:p>
-        </p:txBody>
-      </p:sp>
-      <p:sp>
-        <p:nvSpPr>
-          <p:cNvPr id="300" name="Rectangle 70"/>
-          <p:cNvSpPr/>
-          <p:nvPr/>
-        </p:nvSpPr>
-        <p:spPr>
-          <a:xfrm>
-            <a:off x="9649206" y="2377440"/>
-            <a:ext cx="697230" cy="237744"/>
-          </a:xfrm>
-          <a:prstGeom prst="rect">
-            <a:avLst/>
-          </a:prstGeom>
-          <a:solidFill>
-            <a:srgbClr val="BF8F00"/>
-          </a:solidFill>
-          <a:ln>
-            <a:noFill/>
-          </a:ln>
-          <a:effectLst/>
-        </p:spPr>
-        <p:style>
-          <a:lnRef idx="1">
-            <a:schemeClr val="accent1"/>
-          </a:lnRef>
-          <a:fillRef idx="3">
-            <a:schemeClr val="accent1"/>
-          </a:fillRef>
-          <a:effectRef idx="2">
-            <a:schemeClr val="accent1"/>
-          </a:effectRef>
-          <a:fontRef idx="minor">
-            <a:schemeClr val="lt1"/>
-          </a:fontRef>
-        </p:style>
-        <p:txBody>
-          <a:bodyPr wrap="square" lIns="27432" tIns="0" rIns="27432" bIns="0" rtlCol="0" anchor="ctr"/>
-          <a:lstStyle/>
-          <a:p>
-            <a:pPr algn="ctr">
-              <a:lnSpc>
-                <a:spcPct val="95000"/>
-              </a:lnSpc>
-            </a:pPr>
-            <a:r>
-              <a:rPr sz="700" b="1" i="0">
-                <a:solidFill>
-                  <a:srgbClr val="FFFFFF"/>
-                </a:solidFill>
-                <a:latin typeface="맑은 고딕"/>
-                <a:ea typeface="맑은 고딕"/>
-              </a:rPr>
-              <a:t>CXL-PNM1</a:t>
-            </a:r>
-          </a:p>
-        </p:txBody>
-      </p:sp>
-      <p:sp>
-        <p:nvSpPr>
-          <p:cNvPr id="301" name="Rectangle 71"/>
-          <p:cNvSpPr/>
-          <p:nvPr/>
-        </p:nvSpPr>
-        <p:spPr>
-          <a:xfrm>
-            <a:off x="9649206" y="2615184"/>
-            <a:ext cx="697230" cy="384048"/>
-          </a:xfrm>
-          <a:prstGeom prst="rect">
-            <a:avLst/>
-          </a:prstGeom>
-          <a:solidFill>
-            <a:srgbClr val="FFF2CC"/>
-          </a:solidFill>
-          <a:ln w="9525">
-            <a:solidFill>
-              <a:srgbClr val="BF8F00"/>
-            </a:solidFill>
-          </a:ln>
-          <a:effectLst/>
-        </p:spPr>
-        <p:style>
-          <a:lnRef idx="1">
-            <a:schemeClr val="accent1"/>
-          </a:lnRef>
-          <a:fillRef idx="3">
-            <a:schemeClr val="accent1"/>
-          </a:fillRef>
-          <a:effectRef idx="2">
-            <a:schemeClr val="accent1"/>
-          </a:effectRef>
-          <a:fontRef idx="minor">
-            <a:schemeClr val="lt1"/>
-          </a:fontRef>
-        </p:style>
-        <p:txBody>
-          <a:bodyPr wrap="square" lIns="27432" tIns="0" rIns="27432" bIns="0" rtlCol="0" anchor="ctr"/>
-          <a:lstStyle/>
-          <a:p>
-            <a:pPr algn="ctr">
-              <a:lnSpc>
-                <a:spcPct val="95000"/>
-              </a:lnSpc>
-            </a:pPr>
-            <a:r>
-              <a:rPr sz="700" b="1" i="0">
-                <a:solidFill>
-                  <a:srgbClr val="7F5F00"/>
-                </a:solidFill>
-                <a:latin typeface="맑은 고딕"/>
-                <a:ea typeface="맑은 고딕"/>
-              </a:rPr>
-              <a:t>DDR 128GB</a:t>
-            </a:r>
-          </a:p>
-        </p:txBody>
-      </p:sp>
-      <p:sp>
-        <p:nvSpPr>
-          <p:cNvPr id="302" name="Rectangle 72"/>
-          <p:cNvSpPr/>
-          <p:nvPr/>
-        </p:nvSpPr>
-        <p:spPr>
-          <a:xfrm>
-            <a:off x="10373867" y="2377440"/>
-            <a:ext cx="697230" cy="237744"/>
-          </a:xfrm>
-          <a:prstGeom prst="rect">
-            <a:avLst/>
-          </a:prstGeom>
-          <a:solidFill>
-            <a:srgbClr val="BF8F00"/>
-          </a:solidFill>
-          <a:ln>
-            <a:noFill/>
-          </a:ln>
-          <a:effectLst/>
-        </p:spPr>
-        <p:style>
-          <a:lnRef idx="1">
-            <a:schemeClr val="accent1"/>
-          </a:lnRef>
-          <a:fillRef idx="3">
-            <a:schemeClr val="accent1"/>
-          </a:fillRef>
-          <a:effectRef idx="2">
-            <a:schemeClr val="accent1"/>
-          </a:effectRef>
-          <a:fontRef idx="minor">
-            <a:schemeClr val="lt1"/>
-          </a:fontRef>
-        </p:style>
-        <p:txBody>
-          <a:bodyPr wrap="square" lIns="27432" tIns="0" rIns="27432" bIns="0" rtlCol="0" anchor="ctr"/>
-          <a:lstStyle/>
-          <a:p>
-            <a:pPr algn="ctr">
-              <a:lnSpc>
-                <a:spcPct val="95000"/>
-              </a:lnSpc>
-            </a:pPr>
-            <a:r>
-              <a:rPr sz="700" b="1" i="0">
-                <a:solidFill>
-                  <a:srgbClr val="FFFFFF"/>
-                </a:solidFill>
-                <a:latin typeface="맑은 고딕"/>
-                <a:ea typeface="맑은 고딕"/>
-              </a:rPr>
-              <a:t>CXL-PNM2</a:t>
-            </a:r>
-          </a:p>
-        </p:txBody>
-      </p:sp>
-      <p:sp>
-        <p:nvSpPr>
-          <p:cNvPr id="303" name="Rectangle 73"/>
-          <p:cNvSpPr/>
-          <p:nvPr/>
-        </p:nvSpPr>
-        <p:spPr>
-          <a:xfrm>
-            <a:off x="10373867" y="2615184"/>
-            <a:ext cx="697230" cy="384048"/>
-          </a:xfrm>
-          <a:prstGeom prst="rect">
-            <a:avLst/>
-          </a:prstGeom>
-          <a:solidFill>
-            <a:srgbClr val="FFF2CC"/>
-          </a:solidFill>
-          <a:ln w="9525">
-            <a:solidFill>
-              <a:srgbClr val="BF8F00"/>
-            </a:solidFill>
-          </a:ln>
-          <a:effectLst/>
-        </p:spPr>
-        <p:style>
-          <a:lnRef idx="1">
-            <a:schemeClr val="accent1"/>
-          </a:lnRef>
-          <a:fillRef idx="3">
-            <a:schemeClr val="accent1"/>
-          </a:fillRef>
-          <a:effectRef idx="2">
-            <a:schemeClr val="accent1"/>
-          </a:effectRef>
-          <a:fontRef idx="minor">
-            <a:schemeClr val="lt1"/>
-          </a:fontRef>
-        </p:style>
-        <p:txBody>
-          <a:bodyPr wrap="square" lIns="27432" tIns="0" rIns="27432" bIns="0" rtlCol="0" anchor="ctr"/>
-          <a:lstStyle/>
-          <a:p>
-            <a:pPr algn="ctr">
-              <a:lnSpc>
-                <a:spcPct val="95000"/>
-              </a:lnSpc>
-            </a:pPr>
-            <a:r>
-              <a:rPr sz="700" b="1" i="0">
-                <a:solidFill>
-                  <a:srgbClr val="7F5F00"/>
-                </a:solidFill>
-                <a:latin typeface="맑은 고딕"/>
-                <a:ea typeface="맑은 고딕"/>
-              </a:rPr>
-              <a:t>DDR 128GB</a:t>
-            </a:r>
-          </a:p>
-        </p:txBody>
-      </p:sp>
-      <p:sp>
-        <p:nvSpPr>
-          <p:cNvPr id="304" name="Rectangle 74"/>
-          <p:cNvSpPr/>
-          <p:nvPr/>
-        </p:nvSpPr>
-        <p:spPr>
-          <a:xfrm>
-            <a:off x="11098530" y="2377440"/>
-            <a:ext cx="697230" cy="237744"/>
-          </a:xfrm>
-          <a:prstGeom prst="rect">
-            <a:avLst/>
-          </a:prstGeom>
-          <a:solidFill>
-            <a:srgbClr val="BF8F00"/>
-          </a:solidFill>
-          <a:ln>
-            <a:noFill/>
-          </a:ln>
-          <a:effectLst/>
-        </p:spPr>
-        <p:style>
-          <a:lnRef idx="1">
-            <a:schemeClr val="accent1"/>
-          </a:lnRef>
-          <a:fillRef idx="3">
-            <a:schemeClr val="accent1"/>
-          </a:fillRef>
-          <a:effectRef idx="2">
-            <a:schemeClr val="accent1"/>
-          </a:effectRef>
-          <a:fontRef idx="minor">
-            <a:schemeClr val="lt1"/>
-          </a:fontRef>
-        </p:style>
-        <p:txBody>
-          <a:bodyPr wrap="square" lIns="27432" tIns="0" rIns="27432" bIns="0" rtlCol="0" anchor="ctr"/>
-          <a:lstStyle/>
-          <a:p>
-            <a:pPr algn="ctr">
-              <a:lnSpc>
-                <a:spcPct val="95000"/>
-              </a:lnSpc>
-            </a:pPr>
-            <a:r>
-              <a:rPr sz="700" b="1" i="0">
-                <a:solidFill>
-                  <a:srgbClr val="FFFFFF"/>
-                </a:solidFill>
-                <a:latin typeface="맑은 고딕"/>
-                <a:ea typeface="맑은 고딕"/>
-              </a:rPr>
-              <a:t>CXL-PNM3</a:t>
-            </a:r>
-          </a:p>
-        </p:txBody>
-      </p:sp>
-      <p:sp>
-        <p:nvSpPr>
-          <p:cNvPr id="305" name="Rectangle 75"/>
-          <p:cNvSpPr/>
-          <p:nvPr/>
-        </p:nvSpPr>
-        <p:spPr>
-          <a:xfrm>
-            <a:off x="11098530" y="2615184"/>
-            <a:ext cx="697230" cy="384048"/>
-          </a:xfrm>
-          <a:prstGeom prst="rect">
-            <a:avLst/>
-          </a:prstGeom>
-          <a:solidFill>
-            <a:srgbClr val="FFF2CC"/>
-          </a:solidFill>
-          <a:ln w="9525">
-            <a:solidFill>
-              <a:srgbClr val="BF8F00"/>
-            </a:solidFill>
-          </a:ln>
-          <a:effectLst/>
-        </p:spPr>
-        <p:style>
-          <a:lnRef idx="1">
-            <a:schemeClr val="accent1"/>
-          </a:lnRef>
-          <a:fillRef idx="3">
-            <a:schemeClr val="accent1"/>
-          </a:fillRef>
-          <a:effectRef idx="2">
-            <a:schemeClr val="accent1"/>
-          </a:effectRef>
-          <a:fontRef idx="minor">
-            <a:schemeClr val="lt1"/>
-          </a:fontRef>
-        </p:style>
-        <p:txBody>
-          <a:bodyPr wrap="square" lIns="27432" tIns="0" rIns="27432" bIns="0" rtlCol="0" anchor="ctr"/>
-          <a:lstStyle/>
-          <a:p>
-            <a:pPr algn="ctr">
-              <a:lnSpc>
-                <a:spcPct val="95000"/>
-              </a:lnSpc>
-            </a:pPr>
-            <a:r>
-              <a:rPr sz="700" b="1" i="0">
-                <a:solidFill>
-                  <a:srgbClr val="7F5F00"/>
-                </a:solidFill>
-                <a:latin typeface="맑은 고딕"/>
-                <a:ea typeface="맑은 고딕"/>
-              </a:rPr>
-              <a:t>DDR 128GB</a:t>
-            </a:r>
-          </a:p>
-        </p:txBody>
-      </p:sp>
-      <p:sp>
-        <p:nvSpPr>
-          <p:cNvPr id="306" name="Rectangle 76"/>
-          <p:cNvSpPr/>
-          <p:nvPr/>
-        </p:nvSpPr>
-        <p:spPr>
-          <a:xfrm>
-            <a:off x="8924544" y="3035808"/>
-            <a:ext cx="1421892" cy="274320"/>
-          </a:xfrm>
-          <a:prstGeom prst="rect">
-            <a:avLst/>
-          </a:prstGeom>
-          <a:solidFill>
-            <a:srgbClr val="F2F2F2"/>
-          </a:solidFill>
-          <a:ln w="9525">
-            <a:solidFill>
-              <a:srgbClr val="A6A6A6"/>
-            </a:solidFill>
-          </a:ln>
-          <a:effectLst/>
-        </p:spPr>
-        <p:style>
-          <a:lnRef idx="1">
-            <a:schemeClr val="accent1"/>
-          </a:lnRef>
-          <a:fillRef idx="3">
-            <a:schemeClr val="accent1"/>
-          </a:fillRef>
-          <a:effectRef idx="2">
-            <a:schemeClr val="accent1"/>
-          </a:effectRef>
-          <a:fontRef idx="minor">
-            <a:schemeClr val="lt1"/>
-          </a:fontRef>
-        </p:style>
-        <p:txBody>
-          <a:bodyPr wrap="square" lIns="27432" tIns="0" rIns="27432" bIns="0" rtlCol="0" anchor="ctr"/>
-          <a:lstStyle/>
-          <a:p>
-            <a:pPr algn="ctr">
-              <a:lnSpc>
-                <a:spcPct val="95000"/>
-              </a:lnSpc>
-            </a:pPr>
-            <a:r>
-              <a:rPr sz="750" b="1" i="0">
+              <a:rPr sz="800" b="1" i="0">
+                <a:solidFill>
+                  <a:srgbClr val="1F4E79"/>
+                </a:solidFill>
+                <a:latin typeface="맑은 고딕"/>
+                <a:ea typeface="맑은 고딕"/>
+              </a:rPr>
+              <a:t>노드  </a:t>
+            </a:r>
+            <a:r>
+              <a:rPr sz="800" b="0" i="0">
                 <a:solidFill>
                   <a:srgbClr val="262626"/>
                 </a:solidFill>
                 <a:latin typeface="맑은 고딕"/>
                 <a:ea typeface="맑은 고딕"/>
               </a:rPr>
-              <a:t>NVMe SSD  16TB</a:t>
-            </a:r>
-          </a:p>
-        </p:txBody>
-      </p:sp>
-      <p:sp>
-        <p:nvSpPr>
-          <p:cNvPr id="307" name="Rectangle 77"/>
-          <p:cNvSpPr/>
-          <p:nvPr/>
-        </p:nvSpPr>
-        <p:spPr>
-          <a:xfrm>
-            <a:off x="10373867" y="3035808"/>
-            <a:ext cx="1421892" cy="274320"/>
-          </a:xfrm>
-          <a:prstGeom prst="rect">
-            <a:avLst/>
-          </a:prstGeom>
-          <a:solidFill>
-            <a:srgbClr val="E2EFDA"/>
-          </a:solidFill>
-          <a:ln w="9525">
-            <a:solidFill>
-              <a:srgbClr val="548235"/>
-            </a:solidFill>
-          </a:ln>
-          <a:effectLst/>
-        </p:spPr>
-        <p:style>
-          <a:lnRef idx="1">
-            <a:schemeClr val="accent1"/>
-          </a:lnRef>
-          <a:fillRef idx="3">
-            <a:schemeClr val="accent1"/>
-          </a:fillRef>
-          <a:effectRef idx="2">
-            <a:schemeClr val="accent1"/>
-          </a:effectRef>
-          <a:fontRef idx="minor">
-            <a:schemeClr val="lt1"/>
-          </a:fontRef>
-        </p:style>
-        <p:txBody>
-          <a:bodyPr wrap="square" lIns="27432" tIns="0" rIns="27432" bIns="0" rtlCol="0" anchor="ctr"/>
-          <a:lstStyle/>
-          <a:p>
-            <a:pPr algn="ctr">
-              <a:lnSpc>
-                <a:spcPct val="95000"/>
-              </a:lnSpc>
-            </a:pPr>
-            <a:r>
-              <a:rPr sz="750" b="1" i="0">
-                <a:solidFill>
-                  <a:srgbClr val="375623"/>
-                </a:solidFill>
-                <a:latin typeface="맑은 고딕"/>
-                <a:ea typeface="맑은 고딕"/>
-              </a:rPr>
-              <a:t>PIM-SSD  16TB</a:t>
+              <a:t>Baseline · Target 모두 4노드. 표의 용량 · 대역폭은 1노드 기준, 비용은 4노드 합계</a:t>
             </a:r>
           </a:p>
         </p:txBody>
@@ -8302,8 +7016,8 @@
         </p:nvSpPr>
         <p:spPr>
           <a:xfrm>
-            <a:off x="365760" y="3493008"/>
-            <a:ext cx="11521440" cy="18288"/>
+            <a:off x="361950" y="3124200"/>
+            <a:ext cx="11515725" cy="18288"/>
           </a:xfrm>
           <a:prstGeom prst="rect">
             <a:avLst/>
@@ -8351,8 +7065,8 @@
         </p:nvSpPr>
         <p:spPr>
           <a:xfrm>
-            <a:off x="365760" y="3401568"/>
-            <a:ext cx="2011680" cy="164592"/>
+            <a:off x="361950" y="3171825"/>
+            <a:ext cx="2686050" cy="133350"/>
           </a:xfrm>
           <a:prstGeom prst="rect">
             <a:avLst/>
@@ -8374,7 +7088,7 @@
                 <a:latin typeface="맑은 고딕"/>
                 <a:ea typeface="맑은 고딕"/>
               </a:rPr>
-              <a:t>계층별  용량  ·  대역폭</a:t>
+              <a:t>계층별  용량  ·  대역폭  (1노드 기준)</a:t>
             </a:r>
           </a:p>
         </p:txBody>
@@ -8387,8 +7101,8 @@
         </p:nvSpPr>
         <p:spPr>
           <a:xfrm>
-            <a:off x="365760" y="3584448"/>
-            <a:ext cx="2011680" cy="210312"/>
+            <a:off x="361950" y="3333750"/>
+            <a:ext cx="1733550" cy="209550"/>
           </a:xfrm>
           <a:prstGeom prst="rect">
             <a:avLst/>
@@ -8423,8 +7137,8 @@
         </p:nvSpPr>
         <p:spPr>
           <a:xfrm>
-            <a:off x="2468880" y="3584448"/>
-            <a:ext cx="3054096" cy="210312"/>
+            <a:off x="2171700" y="3333750"/>
+            <a:ext cx="2381250" cy="209550"/>
           </a:xfrm>
           <a:prstGeom prst="rect">
             <a:avLst/>
@@ -8446,7 +7160,7 @@
                 <a:latin typeface="맑은 고딕"/>
                 <a:ea typeface="맑은 고딕"/>
               </a:rPr>
-              <a:t>640 GB  ·  16.0 TB/s</a:t>
+              <a:t>640 GB  ·  26.8 TB/s</a:t>
             </a:r>
           </a:p>
         </p:txBody>
@@ -8459,8 +7173,8 @@
         </p:nvSpPr>
         <p:spPr>
           <a:xfrm>
-            <a:off x="5650992" y="3584448"/>
-            <a:ext cx="3054096" cy="210312"/>
+            <a:off x="4629150" y="3333750"/>
+            <a:ext cx="2381250" cy="209550"/>
           </a:xfrm>
           <a:prstGeom prst="rect">
             <a:avLst/>
@@ -8482,7 +7196,7 @@
                 <a:latin typeface="맑은 고딕"/>
                 <a:ea typeface="맑은 고딕"/>
               </a:rPr>
-              <a:t>320 GB  ·  8.0 TB/s</a:t>
+              <a:t>320 GB  ·  13.4 TB/s</a:t>
             </a:r>
           </a:p>
         </p:txBody>
@@ -8495,8 +7209,8 @@
         </p:nvSpPr>
         <p:spPr>
           <a:xfrm>
-            <a:off x="8833104" y="3584448"/>
-            <a:ext cx="3054096" cy="210312"/>
+            <a:off x="7143750" y="3333750"/>
+            <a:ext cx="4733925" cy="209550"/>
           </a:xfrm>
           <a:prstGeom prst="rect">
             <a:avLst/>
@@ -8509,30 +7223,30 @@
           </a:bodyPr>
           <a:lstStyle/>
           <a:p>
-            <a:pPr algn="ctr"/>
-            <a:r>
-              <a:rPr sz="900" b="0" i="0">
-                <a:solidFill>
-                  <a:srgbClr val="404040"/>
-                </a:solidFill>
-                <a:latin typeface="맑은 고딕"/>
-                <a:ea typeface="맑은 고딕"/>
-              </a:rPr>
-              <a:t>160 GB  ·  4.0 TB/s</a:t>
-            </a:r>
-          </a:p>
-        </p:txBody>
-      </p:sp>
-      <p:sp>
-        <p:nvSpPr>
-          <p:cNvPr id="314" name="TextBox 313"/>
+            <a:pPr algn="l"/>
+            <a:r>
+              <a:rPr sz="800" b="0" i="0">
+                <a:solidFill>
+                  <a:srgbClr val="595959"/>
+                </a:solidFill>
+                <a:latin typeface="맑은 고딕"/>
+                <a:ea typeface="맑은 고딕"/>
+              </a:rPr>
+              <a:t>H100 SXM5 80GB · HBM3 · 3.35 TB/s — Base 8×80GB, 8×3.35 / Target 4×80GB, 4×3.35</a:t>
+            </a:r>
+          </a:p>
+        </p:txBody>
+      </p:sp>
+      <p:sp>
+        <p:nvSpPr>
+          <p:cNvPr id="318" name="TextBox 317"/>
           <p:cNvSpPr txBox="1"/>
           <p:nvPr/>
         </p:nvSpPr>
         <p:spPr>
           <a:xfrm>
-            <a:off x="365760" y="3794760"/>
-            <a:ext cx="2011680" cy="210312"/>
+            <a:off x="361950" y="3543300"/>
+            <a:ext cx="1733550" cy="209550"/>
           </a:xfrm>
           <a:prstGeom prst="rect">
             <a:avLst/>
@@ -8554,21 +7268,21 @@
                 <a:latin typeface="맑은 고딕"/>
                 <a:ea typeface="맑은 고딕"/>
               </a:rPr>
-              <a:t>HBF</a:t>
-            </a:r>
-          </a:p>
-        </p:txBody>
-      </p:sp>
-      <p:sp>
-        <p:nvSpPr>
-          <p:cNvPr id="315" name="TextBox 314"/>
+              <a:t>CXL-PNM (DDR)</a:t>
+            </a:r>
+          </a:p>
+        </p:txBody>
+      </p:sp>
+      <p:sp>
+        <p:nvSpPr>
+          <p:cNvPr id="319" name="TextBox 318"/>
           <p:cNvSpPr txBox="1"/>
           <p:nvPr/>
         </p:nvSpPr>
         <p:spPr>
           <a:xfrm>
-            <a:off x="2468880" y="3794760"/>
-            <a:ext cx="3054096" cy="210312"/>
+            <a:off x="2171700" y="3543300"/>
+            <a:ext cx="2381250" cy="209550"/>
           </a:xfrm>
           <a:prstGeom prst="rect">
             <a:avLst/>
@@ -8597,14 +7311,14 @@
       </p:sp>
       <p:sp>
         <p:nvSpPr>
-          <p:cNvPr id="316" name="TextBox 315"/>
+          <p:cNvPr id="320" name="TextBox 319"/>
           <p:cNvSpPr txBox="1"/>
           <p:nvPr/>
         </p:nvSpPr>
         <p:spPr>
           <a:xfrm>
-            <a:off x="5650992" y="3794760"/>
-            <a:ext cx="3054096" cy="210312"/>
+            <a:off x="4629150" y="3543300"/>
+            <a:ext cx="2381250" cy="209550"/>
           </a:xfrm>
           <a:prstGeom prst="rect">
             <a:avLst/>
@@ -8626,21 +7340,21 @@
                 <a:latin typeface="맑은 고딕"/>
                 <a:ea typeface="맑은 고딕"/>
               </a:rPr>
-              <a:t>—</a:t>
-            </a:r>
-          </a:p>
-        </p:txBody>
-      </p:sp>
-      <p:sp>
-        <p:nvSpPr>
-          <p:cNvPr id="317" name="TextBox 316"/>
+              <a:t>512 GB  ·  800 GB/s</a:t>
+            </a:r>
+          </a:p>
+        </p:txBody>
+      </p:sp>
+      <p:sp>
+        <p:nvSpPr>
+          <p:cNvPr id="321" name="TextBox 320"/>
           <p:cNvSpPr txBox="1"/>
           <p:nvPr/>
         </p:nvSpPr>
         <p:spPr>
           <a:xfrm>
-            <a:off x="8833104" y="3794760"/>
-            <a:ext cx="3054096" cy="210312"/>
+            <a:off x="7143750" y="3543300"/>
+            <a:ext cx="4733925" cy="209550"/>
           </a:xfrm>
           <a:prstGeom prst="rect">
             <a:avLst/>
@@ -8653,30 +7367,30 @@
           </a:bodyPr>
           <a:lstStyle/>
           <a:p>
-            <a:pPr algn="ctr"/>
-            <a:r>
-              <a:rPr sz="900" b="0" i="0">
-                <a:solidFill>
-                  <a:srgbClr val="404040"/>
-                </a:solidFill>
-                <a:latin typeface="맑은 고딕"/>
-                <a:ea typeface="맑은 고딕"/>
-              </a:rPr>
-              <a:t>1,280 GB  ·  4.0 TB/s</a:t>
-            </a:r>
-          </a:p>
-        </p:txBody>
-      </p:sp>
-      <p:sp>
-        <p:nvSpPr>
-          <p:cNvPr id="318" name="TextBox 317"/>
+            <a:pPr algn="l"/>
+            <a:r>
+              <a:rPr sz="800" b="0" i="0">
+                <a:solidFill>
+                  <a:srgbClr val="595959"/>
+                </a:solidFill>
+                <a:latin typeface="맑은 고딕"/>
+                <a:ea typeface="맑은 고딕"/>
+              </a:rPr>
+              <a:t>Structera A 2504 · DDR5-6400 4ch×32GB = 128GB, ≈200 GB/s/카드 — 4카드: 4×128, 4×200</a:t>
+            </a:r>
+          </a:p>
+        </p:txBody>
+      </p:sp>
+      <p:sp>
+        <p:nvSpPr>
+          <p:cNvPr id="322" name="TextBox 321"/>
           <p:cNvSpPr txBox="1"/>
           <p:nvPr/>
         </p:nvSpPr>
         <p:spPr>
           <a:xfrm>
-            <a:off x="365760" y="4005072"/>
-            <a:ext cx="2011680" cy="210312"/>
+            <a:off x="361950" y="3752850"/>
+            <a:ext cx="1733550" cy="209550"/>
           </a:xfrm>
           <a:prstGeom prst="rect">
             <a:avLst/>
@@ -8698,21 +7412,21 @@
                 <a:latin typeface="맑은 고딕"/>
                 <a:ea typeface="맑은 고딕"/>
               </a:rPr>
-              <a:t>CXL-PNM (DDR)</a:t>
-            </a:r>
-          </a:p>
-        </p:txBody>
-      </p:sp>
-      <p:sp>
-        <p:nvSpPr>
-          <p:cNvPr id="319" name="TextBox 318"/>
+              <a:t>CPU DDR</a:t>
+            </a:r>
+          </a:p>
+        </p:txBody>
+      </p:sp>
+      <p:sp>
+        <p:nvSpPr>
+          <p:cNvPr id="323" name="TextBox 322"/>
           <p:cNvSpPr txBox="1"/>
           <p:nvPr/>
         </p:nvSpPr>
         <p:spPr>
           <a:xfrm>
-            <a:off x="2468880" y="4005072"/>
-            <a:ext cx="3054096" cy="210312"/>
+            <a:off x="2171700" y="3752850"/>
+            <a:ext cx="2381250" cy="209550"/>
           </a:xfrm>
           <a:prstGeom prst="rect">
             <a:avLst/>
@@ -8734,21 +7448,21 @@
                 <a:latin typeface="맑은 고딕"/>
                 <a:ea typeface="맑은 고딕"/>
               </a:rPr>
-              <a:t>—</a:t>
-            </a:r>
-          </a:p>
-        </p:txBody>
-      </p:sp>
-      <p:sp>
-        <p:nvSpPr>
-          <p:cNvPr id="320" name="TextBox 319"/>
+              <a:t>1,024 GB  ·  350 GB/s</a:t>
+            </a:r>
+          </a:p>
+        </p:txBody>
+      </p:sp>
+      <p:sp>
+        <p:nvSpPr>
+          <p:cNvPr id="324" name="TextBox 323"/>
           <p:cNvSpPr txBox="1"/>
           <p:nvPr/>
         </p:nvSpPr>
         <p:spPr>
           <a:xfrm>
-            <a:off x="5650992" y="4005072"/>
-            <a:ext cx="3054096" cy="210312"/>
+            <a:off x="4629150" y="3752850"/>
+            <a:ext cx="2381250" cy="209550"/>
           </a:xfrm>
           <a:prstGeom prst="rect">
             <a:avLst/>
@@ -8770,21 +7484,21 @@
                 <a:latin typeface="맑은 고딕"/>
                 <a:ea typeface="맑은 고딕"/>
               </a:rPr>
-              <a:t>512 GB  ·  800 GB/s</a:t>
-            </a:r>
-          </a:p>
-        </p:txBody>
-      </p:sp>
-      <p:sp>
-        <p:nvSpPr>
-          <p:cNvPr id="321" name="TextBox 320"/>
+              <a:t>1,024 GB  ·  350 GB/s</a:t>
+            </a:r>
+          </a:p>
+        </p:txBody>
+      </p:sp>
+      <p:sp>
+        <p:nvSpPr>
+          <p:cNvPr id="325" name="TextBox 324"/>
           <p:cNvSpPr txBox="1"/>
           <p:nvPr/>
         </p:nvSpPr>
         <p:spPr>
           <a:xfrm>
-            <a:off x="8833104" y="4005072"/>
-            <a:ext cx="3054096" cy="210312"/>
+            <a:off x="7143750" y="3752850"/>
+            <a:ext cx="4733925" cy="209550"/>
           </a:xfrm>
           <a:prstGeom prst="rect">
             <a:avLst/>
@@ -8797,30 +7511,30 @@
           </a:bodyPr>
           <a:lstStyle/>
           <a:p>
-            <a:pPr algn="ctr"/>
-            <a:r>
-              <a:rPr sz="900" b="0" i="0">
-                <a:solidFill>
-                  <a:srgbClr val="404040"/>
-                </a:solidFill>
-                <a:latin typeface="맑은 고딕"/>
-                <a:ea typeface="맑은 고딕"/>
-              </a:rPr>
-              <a:t>512 GB  ·  800 GB/s</a:t>
-            </a:r>
-          </a:p>
-        </p:txBody>
-      </p:sp>
-      <p:sp>
-        <p:nvSpPr>
-          <p:cNvPr id="322" name="TextBox 321"/>
+            <a:pPr algn="l"/>
+            <a:r>
+              <a:rPr sz="800" b="0" i="0">
+                <a:solidFill>
+                  <a:srgbClr val="595959"/>
+                </a:solidFill>
+                <a:latin typeface="맑은 고딕"/>
+                <a:ea typeface="맑은 고딕"/>
+              </a:rPr>
+              <a:t>Xeon 8480+급 56C ×2 · DDR5-4800 8ch×64GB = 512GB, 유효 175 GB/s/소켓 — 2×512, 2×175</a:t>
+            </a:r>
+          </a:p>
+        </p:txBody>
+      </p:sp>
+      <p:sp>
+        <p:nvSpPr>
+          <p:cNvPr id="326" name="TextBox 325"/>
           <p:cNvSpPr txBox="1"/>
           <p:nvPr/>
         </p:nvSpPr>
         <p:spPr>
           <a:xfrm>
-            <a:off x="365760" y="4215384"/>
-            <a:ext cx="2011680" cy="210312"/>
+            <a:off x="361950" y="3962400"/>
+            <a:ext cx="1733550" cy="209550"/>
           </a:xfrm>
           <a:prstGeom prst="rect">
             <a:avLst/>
@@ -8842,21 +7556,21 @@
                 <a:latin typeface="맑은 고딕"/>
                 <a:ea typeface="맑은 고딕"/>
               </a:rPr>
-              <a:t>CPU DDR</a:t>
-            </a:r>
-          </a:p>
-        </p:txBody>
-      </p:sp>
-      <p:sp>
-        <p:nvSpPr>
-          <p:cNvPr id="323" name="TextBox 322"/>
+              <a:t>NVMe SSD</a:t>
+            </a:r>
+          </a:p>
+        </p:txBody>
+      </p:sp>
+      <p:sp>
+        <p:nvSpPr>
+          <p:cNvPr id="327" name="TextBox 326"/>
           <p:cNvSpPr txBox="1"/>
           <p:nvPr/>
         </p:nvSpPr>
         <p:spPr>
           <a:xfrm>
-            <a:off x="2468880" y="4215384"/>
-            <a:ext cx="3054096" cy="210312"/>
+            <a:off x="2171700" y="3962400"/>
+            <a:ext cx="2381250" cy="209550"/>
           </a:xfrm>
           <a:prstGeom prst="rect">
             <a:avLst/>
@@ -8878,21 +7592,21 @@
                 <a:latin typeface="맑은 고딕"/>
                 <a:ea typeface="맑은 고딕"/>
               </a:rPr>
-              <a:t>1,024 GB  ·  350 GB/s</a:t>
-            </a:r>
-          </a:p>
-        </p:txBody>
-      </p:sp>
-      <p:sp>
-        <p:nvSpPr>
-          <p:cNvPr id="324" name="TextBox 323"/>
+              <a:t>16,000 GB  ·  28 GB/s</a:t>
+            </a:r>
+          </a:p>
+        </p:txBody>
+      </p:sp>
+      <p:sp>
+        <p:nvSpPr>
+          <p:cNvPr id="328" name="TextBox 327"/>
           <p:cNvSpPr txBox="1"/>
           <p:nvPr/>
         </p:nvSpPr>
         <p:spPr>
           <a:xfrm>
-            <a:off x="5650992" y="4215384"/>
-            <a:ext cx="3054096" cy="210312"/>
+            <a:off x="4629150" y="3962400"/>
+            <a:ext cx="2381250" cy="209550"/>
           </a:xfrm>
           <a:prstGeom prst="rect">
             <a:avLst/>
@@ -8914,21 +7628,21 @@
                 <a:latin typeface="맑은 고딕"/>
                 <a:ea typeface="맑은 고딕"/>
               </a:rPr>
-              <a:t>1,024 GB  ·  350 GB/s</a:t>
-            </a:r>
-          </a:p>
-        </p:txBody>
-      </p:sp>
-      <p:sp>
-        <p:nvSpPr>
-          <p:cNvPr id="325" name="TextBox 324"/>
+              <a:t>16,000 GB  ·  28 GB/s</a:t>
+            </a:r>
+          </a:p>
+        </p:txBody>
+      </p:sp>
+      <p:sp>
+        <p:nvSpPr>
+          <p:cNvPr id="329" name="TextBox 328"/>
           <p:cNvSpPr txBox="1"/>
           <p:nvPr/>
         </p:nvSpPr>
         <p:spPr>
           <a:xfrm>
-            <a:off x="8833104" y="4215384"/>
-            <a:ext cx="3054096" cy="210312"/>
+            <a:off x="7143750" y="3962400"/>
+            <a:ext cx="4733925" cy="209550"/>
           </a:xfrm>
           <a:prstGeom prst="rect">
             <a:avLst/>
@@ -8941,30 +7655,30 @@
           </a:bodyPr>
           <a:lstStyle/>
           <a:p>
-            <a:pPr algn="ctr"/>
-            <a:r>
-              <a:rPr sz="900" b="0" i="0">
-                <a:solidFill>
-                  <a:srgbClr val="404040"/>
-                </a:solidFill>
-                <a:latin typeface="맑은 고딕"/>
-                <a:ea typeface="맑은 고딕"/>
-              </a:rPr>
-              <a:t>1,024 GB  ·  350 GB/s</a:t>
-            </a:r>
-          </a:p>
-        </p:txBody>
-      </p:sp>
-      <p:sp>
-        <p:nvSpPr>
-          <p:cNvPr id="326" name="TextBox 325"/>
+            <a:pPr algn="l"/>
+            <a:r>
+              <a:rPr sz="800" b="0" i="0">
+                <a:solidFill>
+                  <a:srgbClr val="595959"/>
+                </a:solidFill>
+                <a:latin typeface="맑은 고딕"/>
+                <a:ea typeface="맑은 고딕"/>
+              </a:rPr>
+              <a:t>NVMe PCIe Gen4 U.3 TLC · 4TB×4 = 16TB, 7 GB/s×4 = 28 GB/s</a:t>
+            </a:r>
+          </a:p>
+        </p:txBody>
+      </p:sp>
+      <p:sp>
+        <p:nvSpPr>
+          <p:cNvPr id="330" name="TextBox 329"/>
           <p:cNvSpPr txBox="1"/>
           <p:nvPr/>
         </p:nvSpPr>
         <p:spPr>
           <a:xfrm>
-            <a:off x="365760" y="4425696"/>
-            <a:ext cx="2011680" cy="210312"/>
+            <a:off x="361950" y="4171950"/>
+            <a:ext cx="1733550" cy="209550"/>
           </a:xfrm>
           <a:prstGeom prst="rect">
             <a:avLst/>
@@ -8986,21 +7700,21 @@
                 <a:latin typeface="맑은 고딕"/>
                 <a:ea typeface="맑은 고딕"/>
               </a:rPr>
-              <a:t>NVMe SSD</a:t>
-            </a:r>
-          </a:p>
-        </p:txBody>
-      </p:sp>
-      <p:sp>
-        <p:nvSpPr>
-          <p:cNvPr id="327" name="TextBox 326"/>
+              <a:t>PIM-SSD</a:t>
+            </a:r>
+          </a:p>
+        </p:txBody>
+      </p:sp>
+      <p:sp>
+        <p:nvSpPr>
+          <p:cNvPr id="331" name="TextBox 330"/>
           <p:cNvSpPr txBox="1"/>
           <p:nvPr/>
         </p:nvSpPr>
         <p:spPr>
           <a:xfrm>
-            <a:off x="2468880" y="4425696"/>
-            <a:ext cx="3054096" cy="210312"/>
+            <a:off x="2171700" y="4171950"/>
+            <a:ext cx="2381250" cy="209550"/>
           </a:xfrm>
           <a:prstGeom prst="rect">
             <a:avLst/>
@@ -9022,21 +7736,21 @@
                 <a:latin typeface="맑은 고딕"/>
                 <a:ea typeface="맑은 고딕"/>
               </a:rPr>
-              <a:t>16,000 GB  ·  28 GB/s</a:t>
-            </a:r>
-          </a:p>
-        </p:txBody>
-      </p:sp>
-      <p:sp>
-        <p:nvSpPr>
-          <p:cNvPr id="328" name="TextBox 327"/>
+              <a:t>—</a:t>
+            </a:r>
+          </a:p>
+        </p:txBody>
+      </p:sp>
+      <p:sp>
+        <p:nvSpPr>
+          <p:cNvPr id="332" name="TextBox 331"/>
           <p:cNvSpPr txBox="1"/>
           <p:nvPr/>
         </p:nvSpPr>
         <p:spPr>
           <a:xfrm>
-            <a:off x="5650992" y="4425696"/>
-            <a:ext cx="3054096" cy="210312"/>
+            <a:off x="4629150" y="4171950"/>
+            <a:ext cx="2381250" cy="209550"/>
           </a:xfrm>
           <a:prstGeom prst="rect">
             <a:avLst/>
@@ -9065,14 +7779,14 @@
       </p:sp>
       <p:sp>
         <p:nvSpPr>
-          <p:cNvPr id="329" name="TextBox 328"/>
+          <p:cNvPr id="333" name="TextBox 332"/>
           <p:cNvSpPr txBox="1"/>
           <p:nvPr/>
         </p:nvSpPr>
         <p:spPr>
           <a:xfrm>
-            <a:off x="8833104" y="4425696"/>
-            <a:ext cx="3054096" cy="210312"/>
+            <a:off x="7143750" y="4171950"/>
+            <a:ext cx="4733925" cy="209550"/>
           </a:xfrm>
           <a:prstGeom prst="rect">
             <a:avLst/>
@@ -9085,160 +7799,16 @@
           </a:bodyPr>
           <a:lstStyle/>
           <a:p>
-            <a:pPr algn="ctr"/>
-            <a:r>
-              <a:rPr sz="900" b="0" i="0">
-                <a:solidFill>
-                  <a:srgbClr val="404040"/>
-                </a:solidFill>
-                <a:latin typeface="맑은 고딕"/>
-                <a:ea typeface="맑은 고딕"/>
-              </a:rPr>
-              <a:t>16,000 GB  ·  28 GB/s</a:t>
-            </a:r>
-          </a:p>
-        </p:txBody>
-      </p:sp>
-      <p:sp>
-        <p:nvSpPr>
-          <p:cNvPr id="330" name="TextBox 329"/>
-          <p:cNvSpPr txBox="1"/>
-          <p:nvPr/>
-        </p:nvSpPr>
-        <p:spPr>
-          <a:xfrm>
-            <a:off x="365760" y="4636008"/>
-            <a:ext cx="2011680" cy="210312"/>
-          </a:xfrm>
-          <a:prstGeom prst="rect">
-            <a:avLst/>
-          </a:prstGeom>
-          <a:noFill/>
-        </p:spPr>
-        <p:txBody>
-          <a:bodyPr wrap="square" lIns="0" tIns="0" rIns="0" bIns="0" anchor="ctr">
-            <a:spAutoFit/>
-          </a:bodyPr>
-          <a:lstStyle/>
-          <a:p>
             <a:pPr algn="l"/>
             <a:r>
-              <a:rPr sz="900" b="0" i="0">
-                <a:solidFill>
-                  <a:srgbClr val="808080"/>
-                </a:solidFill>
-                <a:latin typeface="맑은 고딕"/>
-                <a:ea typeface="맑은 고딕"/>
-              </a:rPr>
-              <a:t>PIM-SSD</a:t>
-            </a:r>
-          </a:p>
-        </p:txBody>
-      </p:sp>
-      <p:sp>
-        <p:nvSpPr>
-          <p:cNvPr id="331" name="TextBox 330"/>
-          <p:cNvSpPr txBox="1"/>
-          <p:nvPr/>
-        </p:nvSpPr>
-        <p:spPr>
-          <a:xfrm>
-            <a:off x="2468880" y="4636008"/>
-            <a:ext cx="3054096" cy="210312"/>
-          </a:xfrm>
-          <a:prstGeom prst="rect">
-            <a:avLst/>
-          </a:prstGeom>
-          <a:noFill/>
-        </p:spPr>
-        <p:txBody>
-          <a:bodyPr wrap="square" lIns="0" tIns="0" rIns="0" bIns="0" anchor="ctr">
-            <a:spAutoFit/>
-          </a:bodyPr>
-          <a:lstStyle/>
-          <a:p>
-            <a:pPr algn="ctr"/>
-            <a:r>
-              <a:rPr sz="900" b="0" i="0">
-                <a:solidFill>
-                  <a:srgbClr val="404040"/>
-                </a:solidFill>
-                <a:latin typeface="맑은 고딕"/>
-                <a:ea typeface="맑은 고딕"/>
-              </a:rPr>
-              <a:t>—</a:t>
-            </a:r>
-          </a:p>
-        </p:txBody>
-      </p:sp>
-      <p:sp>
-        <p:nvSpPr>
-          <p:cNvPr id="332" name="TextBox 331"/>
-          <p:cNvSpPr txBox="1"/>
-          <p:nvPr/>
-        </p:nvSpPr>
-        <p:spPr>
-          <a:xfrm>
-            <a:off x="5650992" y="4636008"/>
-            <a:ext cx="3054096" cy="210312"/>
-          </a:xfrm>
-          <a:prstGeom prst="rect">
-            <a:avLst/>
-          </a:prstGeom>
-          <a:noFill/>
-        </p:spPr>
-        <p:txBody>
-          <a:bodyPr wrap="square" lIns="0" tIns="0" rIns="0" bIns="0" anchor="ctr">
-            <a:spAutoFit/>
-          </a:bodyPr>
-          <a:lstStyle/>
-          <a:p>
-            <a:pPr algn="ctr"/>
-            <a:r>
-              <a:rPr sz="900" b="0" i="0">
-                <a:solidFill>
-                  <a:srgbClr val="404040"/>
-                </a:solidFill>
-                <a:latin typeface="맑은 고딕"/>
-                <a:ea typeface="맑은 고딕"/>
-              </a:rPr>
-              <a:t>16,000 GB  ·  28 GB/s</a:t>
-            </a:r>
-          </a:p>
-        </p:txBody>
-      </p:sp>
-      <p:sp>
-        <p:nvSpPr>
-          <p:cNvPr id="333" name="TextBox 332"/>
-          <p:cNvSpPr txBox="1"/>
-          <p:nvPr/>
-        </p:nvSpPr>
-        <p:spPr>
-          <a:xfrm>
-            <a:off x="8833104" y="4636008"/>
-            <a:ext cx="3054096" cy="210312"/>
-          </a:xfrm>
-          <a:prstGeom prst="rect">
-            <a:avLst/>
-          </a:prstGeom>
-          <a:noFill/>
-        </p:spPr>
-        <p:txBody>
-          <a:bodyPr wrap="square" lIns="0" tIns="0" rIns="0" bIns="0" anchor="ctr">
-            <a:spAutoFit/>
-          </a:bodyPr>
-          <a:lstStyle/>
-          <a:p>
-            <a:pPr algn="ctr"/>
-            <a:r>
-              <a:rPr sz="900" b="0" i="0">
-                <a:solidFill>
-                  <a:srgbClr val="404040"/>
-                </a:solidFill>
-                <a:latin typeface="맑은 고딕"/>
-                <a:ea typeface="맑은 고딕"/>
-              </a:rPr>
-              <a:t>16,000 GB  ·  28 GB/s</a:t>
+              <a:rPr sz="800" b="0" i="0">
+                <a:solidFill>
+                  <a:srgbClr val="595959"/>
+                </a:solidFill>
+                <a:latin typeface="맑은 고딕"/>
+                <a:ea typeface="맑은 고딕"/>
+              </a:rPr>
+              <a:t>PIM(연산 내장) SSD · NVMe와 동일 용량·대역폭·단가 가정 — 16TB, 28 GB/s</a:t>
             </a:r>
           </a:p>
         </p:txBody>
@@ -9251,8 +7821,8 @@
         </p:nvSpPr>
         <p:spPr>
           <a:xfrm>
-            <a:off x="365760" y="4882896"/>
-            <a:ext cx="11521440" cy="210312"/>
+            <a:off x="361950" y="4419600"/>
+            <a:ext cx="11515725" cy="209550"/>
           </a:xfrm>
           <a:prstGeom prst="rect">
             <a:avLst/>
@@ -9300,8 +7870,8 @@
         </p:nvSpPr>
         <p:spPr>
           <a:xfrm>
-            <a:off x="438912" y="4882896"/>
-            <a:ext cx="2011680" cy="210312"/>
+            <a:off x="438150" y="4419600"/>
+            <a:ext cx="1657350" cy="209550"/>
           </a:xfrm>
           <a:prstGeom prst="rect">
             <a:avLst/>
@@ -9336,8 +7906,8 @@
         </p:nvSpPr>
         <p:spPr>
           <a:xfrm>
-            <a:off x="2468880" y="4882896"/>
-            <a:ext cx="3054096" cy="210312"/>
+            <a:off x="2171700" y="4419600"/>
+            <a:ext cx="2381250" cy="209550"/>
           </a:xfrm>
           <a:prstGeom prst="rect">
             <a:avLst/>
@@ -9372,8 +7942,8 @@
         </p:nvSpPr>
         <p:spPr>
           <a:xfrm>
-            <a:off x="5650992" y="4882896"/>
-            <a:ext cx="3054096" cy="210312"/>
+            <a:off x="4629150" y="4419600"/>
+            <a:ext cx="2381250" cy="209550"/>
           </a:xfrm>
           <a:prstGeom prst="rect">
             <a:avLst/>
@@ -9408,8 +7978,8 @@
         </p:nvSpPr>
         <p:spPr>
           <a:xfrm>
-            <a:off x="8833104" y="4882896"/>
-            <a:ext cx="3054096" cy="210312"/>
+            <a:off x="7143750" y="4419600"/>
+            <a:ext cx="4733925" cy="209550"/>
           </a:xfrm>
           <a:prstGeom prst="rect">
             <a:avLst/>
@@ -9422,16 +7992,16 @@
           </a:bodyPr>
           <a:lstStyle/>
           <a:p>
-            <a:pPr algn="ctr"/>
-            <a:r>
-              <a:rPr sz="950" b="1" i="0">
-                <a:solidFill>
-                  <a:srgbClr val="262626"/>
-                </a:solidFill>
-                <a:latin typeface="맑은 고딕"/>
-                <a:ea typeface="맑은 고딕"/>
-              </a:rPr>
-              <a:t>1,952 GB  (3.05×)</a:t>
+            <a:pPr algn="l"/>
+            <a:r>
+              <a:rPr sz="800" b="0" i="0">
+                <a:solidFill>
+                  <a:srgbClr val="404040"/>
+                </a:solidFill>
+                <a:latin typeface="맑은 고딕"/>
+                <a:ea typeface="맑은 고딕"/>
+              </a:rPr>
+              <a:t>HBM + PNM : 640 / 320 + 512 = 832 GB</a:t>
             </a:r>
           </a:p>
         </p:txBody>
@@ -9444,8 +8014,8 @@
         </p:nvSpPr>
         <p:spPr>
           <a:xfrm>
-            <a:off x="365760" y="5093208"/>
-            <a:ext cx="11521440" cy="210312"/>
+            <a:off x="361950" y="4629150"/>
+            <a:ext cx="11515725" cy="209550"/>
           </a:xfrm>
           <a:prstGeom prst="rect">
             <a:avLst/>
@@ -9493,8 +8063,8 @@
         </p:nvSpPr>
         <p:spPr>
           <a:xfrm>
-            <a:off x="438912" y="5093208"/>
-            <a:ext cx="2011680" cy="210312"/>
+            <a:off x="438150" y="4629150"/>
+            <a:ext cx="1657350" cy="209550"/>
           </a:xfrm>
           <a:prstGeom prst="rect">
             <a:avLst/>
@@ -9529,8 +8099,8 @@
         </p:nvSpPr>
         <p:spPr>
           <a:xfrm>
-            <a:off x="2468880" y="5093208"/>
-            <a:ext cx="3054096" cy="210312"/>
+            <a:off x="2171700" y="4629150"/>
+            <a:ext cx="2381250" cy="209550"/>
           </a:xfrm>
           <a:prstGeom prst="rect">
             <a:avLst/>
@@ -9552,7 +8122,7 @@
                 <a:latin typeface="맑은 고딕"/>
                 <a:ea typeface="맑은 고딕"/>
               </a:rPr>
-              <a:t>16.0 TB/s  (1.00×)</a:t>
+              <a:t>26.8 TB/s  (1.00×)</a:t>
             </a:r>
           </a:p>
         </p:txBody>
@@ -9565,8 +8135,8 @@
         </p:nvSpPr>
         <p:spPr>
           <a:xfrm>
-            <a:off x="5650992" y="5093208"/>
-            <a:ext cx="3054096" cy="210312"/>
+            <a:off x="4629150" y="4629150"/>
+            <a:ext cx="2381250" cy="209550"/>
           </a:xfrm>
           <a:prstGeom prst="rect">
             <a:avLst/>
@@ -9588,7 +8158,7 @@
                 <a:latin typeface="맑은 고딕"/>
                 <a:ea typeface="맑은 고딕"/>
               </a:rPr>
-              <a:t>8.8 TB/s  (0.55×)</a:t>
+              <a:t>14.2 TB/s  (0.53×)</a:t>
             </a:r>
           </a:p>
         </p:txBody>
@@ -9601,8 +8171,8 @@
         </p:nvSpPr>
         <p:spPr>
           <a:xfrm>
-            <a:off x="8833104" y="5093208"/>
-            <a:ext cx="3054096" cy="210312"/>
+            <a:off x="7143750" y="4629150"/>
+            <a:ext cx="4733925" cy="209550"/>
           </a:xfrm>
           <a:prstGeom prst="rect">
             <a:avLst/>
@@ -9615,16 +8185,16 @@
           </a:bodyPr>
           <a:lstStyle/>
           <a:p>
-            <a:pPr algn="ctr"/>
-            <a:r>
-              <a:rPr sz="950" b="1" i="0">
-                <a:solidFill>
-                  <a:srgbClr val="262626"/>
-                </a:solidFill>
-                <a:latin typeface="맑은 고딕"/>
-                <a:ea typeface="맑은 고딕"/>
-              </a:rPr>
-              <a:t>8.8 TB/s  (0.55×)</a:t>
+            <a:pPr algn="l"/>
+            <a:r>
+              <a:rPr sz="800" b="0" i="0">
+                <a:solidFill>
+                  <a:srgbClr val="404040"/>
+                </a:solidFill>
+                <a:latin typeface="맑은 고딕"/>
+                <a:ea typeface="맑은 고딕"/>
+              </a:rPr>
+              <a:t>HBM + PNM : 8×3.35 = 26.8 / 4×3.35 + 4×0.2 = 14.2 TB/s</a:t>
             </a:r>
           </a:p>
         </p:txBody>
@@ -9637,8 +8207,8 @@
         </p:nvSpPr>
         <p:spPr>
           <a:xfrm>
-            <a:off x="365760" y="5303520"/>
-            <a:ext cx="11521440" cy="210312"/>
+            <a:off x="361950" y="4838700"/>
+            <a:ext cx="11515725" cy="209550"/>
           </a:xfrm>
           <a:prstGeom prst="rect">
             <a:avLst/>
@@ -9686,8 +8256,8 @@
         </p:nvSpPr>
         <p:spPr>
           <a:xfrm>
-            <a:off x="438912" y="5303520"/>
-            <a:ext cx="2011680" cy="210312"/>
+            <a:off x="438150" y="4838700"/>
+            <a:ext cx="1657350" cy="209550"/>
           </a:xfrm>
           <a:prstGeom prst="rect">
             <a:avLst/>
@@ -9722,8 +8292,8 @@
         </p:nvSpPr>
         <p:spPr>
           <a:xfrm>
-            <a:off x="2468880" y="5303520"/>
-            <a:ext cx="3054096" cy="210312"/>
+            <a:off x="2171700" y="4838700"/>
+            <a:ext cx="2381250" cy="209550"/>
           </a:xfrm>
           <a:prstGeom prst="rect">
             <a:avLst/>
@@ -9758,8 +8328,8 @@
         </p:nvSpPr>
         <p:spPr>
           <a:xfrm>
-            <a:off x="5650992" y="5303520"/>
-            <a:ext cx="3054096" cy="210312"/>
+            <a:off x="4629150" y="4838700"/>
+            <a:ext cx="2381250" cy="209550"/>
           </a:xfrm>
           <a:prstGeom prst="rect">
             <a:avLst/>
@@ -9794,8 +8364,8 @@
         </p:nvSpPr>
         <p:spPr>
           <a:xfrm>
-            <a:off x="8833104" y="5303520"/>
-            <a:ext cx="3054096" cy="210312"/>
+            <a:off x="7143750" y="4838700"/>
+            <a:ext cx="4733925" cy="209550"/>
           </a:xfrm>
           <a:prstGeom prst="rect">
             <a:avLst/>
@@ -9808,16 +8378,16 @@
           </a:bodyPr>
           <a:lstStyle/>
           <a:p>
-            <a:pPr algn="ctr"/>
-            <a:r>
-              <a:rPr sz="950" b="1" i="0">
-                <a:solidFill>
-                  <a:srgbClr val="262626"/>
-                </a:solidFill>
-                <a:latin typeface="맑은 고딕"/>
-                <a:ea typeface="맑은 고딕"/>
-              </a:rPr>
-              <a:t>34,976 GB  (1.98×)</a:t>
+            <a:pPr algn="l"/>
+            <a:r>
+              <a:rPr sz="800" b="0" i="0">
+                <a:solidFill>
+                  <a:srgbClr val="404040"/>
+                </a:solidFill>
+                <a:latin typeface="맑은 고딕"/>
+                <a:ea typeface="맑은 고딕"/>
+              </a:rPr>
+              <a:t>HBM+PNM+DDR+NVMe+PIM : 640+1,024+16,000 / 320+512+1,024+16,000+16,000</a:t>
             </a:r>
           </a:p>
         </p:txBody>
@@ -9830,8 +8400,8 @@
         </p:nvSpPr>
         <p:spPr>
           <a:xfrm>
-            <a:off x="365760" y="5513832"/>
-            <a:ext cx="11521440" cy="210312"/>
+            <a:off x="361950" y="5467350"/>
+            <a:ext cx="11515725" cy="209550"/>
           </a:xfrm>
           <a:prstGeom prst="rect">
             <a:avLst/>
@@ -9879,8 +8449,8 @@
         </p:nvSpPr>
         <p:spPr>
           <a:xfrm>
-            <a:off x="438912" y="5513832"/>
-            <a:ext cx="2011680" cy="210312"/>
+            <a:off x="438150" y="5467350"/>
+            <a:ext cx="1657350" cy="209550"/>
           </a:xfrm>
           <a:prstGeom prst="rect">
             <a:avLst/>
@@ -9902,7 +8472,7 @@
                 <a:latin typeface="맑은 고딕"/>
                 <a:ea typeface="맑은 고딕"/>
               </a:rPr>
-              <a:t>총 비용 (메모리 + 카드)</a:t>
+              <a:t>총 비용 (4노드)</a:t>
             </a:r>
           </a:p>
         </p:txBody>
@@ -9915,8 +8485,8 @@
         </p:nvSpPr>
         <p:spPr>
           <a:xfrm>
-            <a:off x="2468880" y="5513832"/>
-            <a:ext cx="3054096" cy="210312"/>
+            <a:off x="2171700" y="5467350"/>
+            <a:ext cx="2381250" cy="209550"/>
           </a:xfrm>
           <a:prstGeom prst="rect">
             <a:avLst/>
@@ -9938,7 +8508,7 @@
                 <a:latin typeface="맑은 고딕"/>
                 <a:ea typeface="맑은 고딕"/>
               </a:rPr>
-              <a:t>$145.0K  (1.00×)</a:t>
+              <a:t>$1,132K  (1.00×)</a:t>
             </a:r>
           </a:p>
         </p:txBody>
@@ -9951,8 +8521,8 @@
         </p:nvSpPr>
         <p:spPr>
           <a:xfrm>
-            <a:off x="5650992" y="5513832"/>
-            <a:ext cx="3054096" cy="210312"/>
+            <a:off x="4629150" y="5467350"/>
+            <a:ext cx="2381250" cy="209550"/>
           </a:xfrm>
           <a:prstGeom prst="rect">
             <a:avLst/>
@@ -9974,7 +8544,7 @@
                 <a:latin typeface="맑은 고딕"/>
                 <a:ea typeface="맑은 고딕"/>
               </a:rPr>
-              <a:t>$131.4K  (0.91×)</a:t>
+              <a:t>$777K  (0.69×)</a:t>
             </a:r>
           </a:p>
         </p:txBody>
@@ -9987,8 +8557,8 @@
         </p:nvSpPr>
         <p:spPr>
           <a:xfrm>
-            <a:off x="8833104" y="5513832"/>
-            <a:ext cx="3054096" cy="210312"/>
+            <a:off x="7143750" y="5467350"/>
+            <a:ext cx="4733925" cy="209550"/>
           </a:xfrm>
           <a:prstGeom prst="rect">
             <a:avLst/>
@@ -10001,16 +8571,16 @@
           </a:bodyPr>
           <a:lstStyle/>
           <a:p>
-            <a:pPr algn="ctr"/>
-            <a:r>
-              <a:rPr sz="950" b="1" i="0">
+            <a:pPr algn="l"/>
+            <a:r>
+              <a:rPr sz="800" b="0" i="0">
                 <a:solidFill>
                   <a:srgbClr val="FFFFFF"/>
                 </a:solidFill>
                 <a:latin typeface="맑은 고딕"/>
                 <a:ea typeface="맑은 고딕"/>
               </a:rPr>
-              <a:t>$131.4K  (0.91×)</a:t>
+              <a:t>메모리·SSD + 카드 : $172K + $960K / $273K + $504K  (CPU·보드·전원 제외)</a:t>
             </a:r>
           </a:p>
         </p:txBody>
@@ -10023,8 +8593,8 @@
         </p:nvSpPr>
         <p:spPr>
           <a:xfrm>
-            <a:off x="365760" y="5797296"/>
-            <a:ext cx="11521440" cy="420624"/>
+            <a:off x="365760" y="5753100"/>
+            <a:ext cx="11521440" cy="381000"/>
           </a:xfrm>
           <a:prstGeom prst="rect">
             <a:avLst/>
@@ -10070,7 +8640,7 @@
                 <a:latin typeface="맑은 고딕"/>
                 <a:ea typeface="맑은 고딕"/>
               </a:rPr>
-              <a:t>집계 대역폭 0.55×는 슬롯당 대역폭이 낮아진 게 아니라 GPU가 4대 줄어든 몫이다 — 슬롯당 HBM 2.0 TB/s는 세 구성 모두 같고, decode attention이 묶이는 것은 슬롯당 대역폭이다</a:t>
+              <a:t>집계 대역폭 0.53×는 슬롯당 대역폭이 낮아진 게 아니라 GPU가 4대 줄어든 몫이다 — 슬롯당 HBM 3.35 TB/s는 두 구성 모두 같고, decode attention이 묶이는 것은 슬롯당 대역폭이다</a:t>
             </a:r>
           </a:p>
           <a:p>
@@ -10087,7 +8657,7 @@
                 <a:latin typeface="맑은 고딕"/>
                 <a:ea typeface="맑은 고딕"/>
               </a:rPr>
-              <a:t>매체 지연 : HBM ~100 ns · CXL-PNM ~300 ns · HBF ~10 μs급(NAND) · NVMe ~100 μs → HBF는 read-dominant 계층(weight · cold KV)이고, KV 상주 계층은 HBM · CXL-PNM이 맡는다</a:t>
+              <a:t>매체 지연 : HBM ~100 ns · CXL-PNM ~300 ns · NVMe ~100 μs → KV 상주 계층은 HBM · CXL-PNM이 맡고, NVMe · PIM-SSD는 cold 계층이다</a:t>
             </a:r>
           </a:p>
         </p:txBody>
@@ -10100,7 +8670,7 @@
         </p:nvSpPr>
         <p:spPr>
           <a:xfrm>
-            <a:off x="365760" y="6291072"/>
+            <a:off x="365760" y="6210300"/>
             <a:ext cx="11521440" cy="420624"/>
           </a:xfrm>
           <a:prstGeom prst="rect">
@@ -10127,7 +8697,7 @@
                 <a:latin typeface="맑은 고딕"/>
                 <a:ea typeface="맑은 고딕"/>
               </a:rPr>
-              <a:t>※ GPU = A100급(108 SM · HBM 2.0 TB/s) · CPU DDR 175 GB/s × 2소켓 · CXL-PNM(Structera-A) 200 GB/s × 4카드. Target 2는 HBM 스택 절반을 HBF로 교체 — 동일 스택 비용에 8× 용량, 스택당 HBM급 대역폭(SanDisk HBF 공개 주장) 전제.</a:t>
+              <a:t>※ GPU = H100 SXM5 (132 SM · HBM3 80GB · 3.35 TB/s) · CPU DDR 175 GB/s × 2소켓 · CXL-PNM(Structera A) 200 GB/s × 4카드. 용량 · 대역폭은 1노드 기준.</a:t>
             </a:r>
           </a:p>
           <a:p>
@@ -10144,7 +8714,393 @@
                 <a:latin typeface="맑은 고딕"/>
                 <a:ea typeface="맑은 고딕"/>
               </a:rPr>
-              <a:t>※ 단가(2026.10) GPU 카드 $12K(A100 80GB, HBM 포함 → 카드만 $11.4K) · PNM 카드 $1.5K(가정) · HBM2e $8 / HBF $1.00 / DDR5 $40 / NVMe·PIM-SSD $0.50 per GB. 메모리만 비교 시 $54.1K / $80.0K (1.48×).</a:t>
+              <a:t>※ 신품 단가(2026.10) H100 SXM5 80GB $30K(범위 $25~35K, HBM 포함) · DDR5 RDIMM $35/GB · 엔터프라이즈 NVMe·PIM-SSD $0.45/GB · PNM 카드 $1.5K(가정). 4노드 합계, CPU·보드·전원은 제외.</a:t>
+            </a:r>
+          </a:p>
+        </p:txBody>
+      </p:sp>
+      <p:sp>
+        <p:nvSpPr>
+          <p:cNvPr id="356" name="Rectangle N1"/>
+          <p:cNvSpPr/>
+          <p:nvPr/>
+        </p:nvSpPr>
+        <p:spPr>
+          <a:xfrm>
+            <a:off x="361950" y="5048250"/>
+            <a:ext cx="11515725" cy="209550"/>
+          </a:xfrm>
+          <a:prstGeom prst="rect">
+            <a:avLst/>
+          </a:prstGeom>
+          <a:solidFill>
+            <a:srgbClr val="F2F2F2"/>
+          </a:solidFill>
+          <a:ln>
+            <a:noFill/>
+          </a:ln>
+          <a:effectLst/>
+        </p:spPr>
+        <p:style>
+          <a:lnRef idx="1">
+            <a:schemeClr val="accent1"/>
+          </a:lnRef>
+          <a:fillRef idx="3">
+            <a:schemeClr val="accent1"/>
+          </a:fillRef>
+          <a:effectRef idx="2">
+            <a:schemeClr val="accent1"/>
+          </a:effectRef>
+          <a:fontRef idx="minor">
+            <a:schemeClr val="lt1"/>
+          </a:fontRef>
+        </p:style>
+        <p:txBody>
+          <a:bodyPr wrap="square" lIns="27432" tIns="0" rIns="27432" bIns="0" rtlCol="0" anchor="ctr"/>
+          <a:lstStyle/>
+          <a:p>
+            <a:pPr algn="ctr">
+              <a:lnSpc>
+                <a:spcPct val="95000"/>
+              </a:lnSpc>
+            </a:pPr>
+            <a:endParaRPr/>
+          </a:p>
+        </p:txBody>
+      </p:sp>
+      <p:sp>
+        <p:nvSpPr>
+          <p:cNvPr id="357" name="TextBox NL1"/>
+          <p:cNvSpPr txBox="1"/>
+          <p:nvPr/>
+        </p:nvSpPr>
+        <p:spPr>
+          <a:xfrm>
+            <a:off x="438150" y="5048250"/>
+            <a:ext cx="1657350" cy="209550"/>
+          </a:xfrm>
+          <a:prstGeom prst="rect">
+            <a:avLst/>
+          </a:prstGeom>
+          <a:noFill/>
+        </p:spPr>
+        <p:txBody>
+          <a:bodyPr wrap="square" lIns="0" tIns="0" rIns="0" bIns="0" anchor="ctr">
+            <a:spAutoFit/>
+          </a:bodyPr>
+          <a:lstStyle/>
+          <a:p>
+            <a:pPr algn="l"/>
+            <a:r>
+              <a:rPr sz="950" b="1" i="0">
+                <a:solidFill>
+                  <a:srgbClr val="262626"/>
+                </a:solidFill>
+                <a:latin typeface="맑은 고딕"/>
+                <a:ea typeface="맑은 고딕"/>
+              </a:rPr>
+              <a:t>메모리·SSD 비용 (4노드)</a:t>
+            </a:r>
+          </a:p>
+        </p:txBody>
+      </p:sp>
+      <p:sp>
+        <p:nvSpPr>
+          <p:cNvPr id="358" name="TextBox NB1"/>
+          <p:cNvSpPr txBox="1"/>
+          <p:nvPr/>
+        </p:nvSpPr>
+        <p:spPr>
+          <a:xfrm>
+            <a:off x="2171700" y="5048250"/>
+            <a:ext cx="2381250" cy="209550"/>
+          </a:xfrm>
+          <a:prstGeom prst="rect">
+            <a:avLst/>
+          </a:prstGeom>
+          <a:noFill/>
+        </p:spPr>
+        <p:txBody>
+          <a:bodyPr wrap="square" lIns="0" tIns="0" rIns="0" bIns="0" anchor="ctr">
+            <a:spAutoFit/>
+          </a:bodyPr>
+          <a:lstStyle/>
+          <a:p>
+            <a:pPr algn="ctr"/>
+            <a:r>
+              <a:rPr sz="950" b="1" i="0">
+                <a:solidFill>
+                  <a:srgbClr val="262626"/>
+                </a:solidFill>
+                <a:latin typeface="맑은 고딕"/>
+                <a:ea typeface="맑은 고딕"/>
+              </a:rPr>
+              <a:t>$172K  (1.00×)</a:t>
+            </a:r>
+          </a:p>
+        </p:txBody>
+      </p:sp>
+      <p:sp>
+        <p:nvSpPr>
+          <p:cNvPr id="359" name="TextBox NT1"/>
+          <p:cNvSpPr txBox="1"/>
+          <p:nvPr/>
+        </p:nvSpPr>
+        <p:spPr>
+          <a:xfrm>
+            <a:off x="4629150" y="5048250"/>
+            <a:ext cx="2381250" cy="209550"/>
+          </a:xfrm>
+          <a:prstGeom prst="rect">
+            <a:avLst/>
+          </a:prstGeom>
+          <a:noFill/>
+        </p:spPr>
+        <p:txBody>
+          <a:bodyPr wrap="square" lIns="0" tIns="0" rIns="0" bIns="0" anchor="ctr">
+            <a:spAutoFit/>
+          </a:bodyPr>
+          <a:lstStyle/>
+          <a:p>
+            <a:pPr algn="ctr"/>
+            <a:r>
+              <a:rPr sz="950" b="1" i="0">
+                <a:solidFill>
+                  <a:srgbClr val="262626"/>
+                </a:solidFill>
+                <a:latin typeface="맑은 고딕"/>
+                <a:ea typeface="맑은 고딕"/>
+              </a:rPr>
+              <a:t>$273K  (1.58×)</a:t>
+            </a:r>
+          </a:p>
+        </p:txBody>
+      </p:sp>
+      <p:sp>
+        <p:nvSpPr>
+          <p:cNvPr id="360" name="TextBox NF1"/>
+          <p:cNvSpPr txBox="1"/>
+          <p:nvPr/>
+        </p:nvSpPr>
+        <p:spPr>
+          <a:xfrm>
+            <a:off x="7143750" y="5048250"/>
+            <a:ext cx="4733925" cy="209550"/>
+          </a:xfrm>
+          <a:prstGeom prst="rect">
+            <a:avLst/>
+          </a:prstGeom>
+          <a:noFill/>
+        </p:spPr>
+        <p:txBody>
+          <a:bodyPr wrap="square" lIns="0" tIns="0" rIns="0" bIns="0" anchor="ctr">
+            <a:spAutoFit/>
+          </a:bodyPr>
+          <a:lstStyle/>
+          <a:p>
+            <a:pPr algn="l"/>
+            <a:r>
+              <a:rPr sz="800" b="0" i="0">
+                <a:solidFill>
+                  <a:srgbClr val="404040"/>
+                </a:solidFill>
+                <a:latin typeface="맑은 고딕"/>
+                <a:ea typeface="맑은 고딕"/>
+              </a:rPr>
+              <a:t>4×[DDR 1,024GB×$35 + NVMe 16TB×$0.45] / 4×[DDR 1,536GB×$35 + SSD 32TB×$0.45]</a:t>
+            </a:r>
+          </a:p>
+        </p:txBody>
+      </p:sp>
+      <p:sp>
+        <p:nvSpPr>
+          <p:cNvPr id="361" name="Rectangle N2"/>
+          <p:cNvSpPr/>
+          <p:nvPr/>
+        </p:nvSpPr>
+        <p:spPr>
+          <a:xfrm>
+            <a:off x="361950" y="5257800"/>
+            <a:ext cx="11515725" cy="209550"/>
+          </a:xfrm>
+          <a:prstGeom prst="rect">
+            <a:avLst/>
+          </a:prstGeom>
+          <a:solidFill>
+            <a:srgbClr val="F2F2F2"/>
+          </a:solidFill>
+          <a:ln>
+            <a:noFill/>
+          </a:ln>
+          <a:effectLst/>
+        </p:spPr>
+        <p:style>
+          <a:lnRef idx="1">
+            <a:schemeClr val="accent1"/>
+          </a:lnRef>
+          <a:fillRef idx="3">
+            <a:schemeClr val="accent1"/>
+          </a:fillRef>
+          <a:effectRef idx="2">
+            <a:schemeClr val="accent1"/>
+          </a:effectRef>
+          <a:fontRef idx="minor">
+            <a:schemeClr val="lt1"/>
+          </a:fontRef>
+        </p:style>
+        <p:txBody>
+          <a:bodyPr wrap="square" lIns="27432" tIns="0" rIns="27432" bIns="0" rtlCol="0" anchor="ctr"/>
+          <a:lstStyle/>
+          <a:p>
+            <a:pPr algn="ctr">
+              <a:lnSpc>
+                <a:spcPct val="95000"/>
+              </a:lnSpc>
+            </a:pPr>
+            <a:endParaRPr/>
+          </a:p>
+        </p:txBody>
+      </p:sp>
+      <p:sp>
+        <p:nvSpPr>
+          <p:cNvPr id="362" name="TextBox NL2"/>
+          <p:cNvSpPr txBox="1"/>
+          <p:nvPr/>
+        </p:nvSpPr>
+        <p:spPr>
+          <a:xfrm>
+            <a:off x="438150" y="5257800"/>
+            <a:ext cx="1657350" cy="209550"/>
+          </a:xfrm>
+          <a:prstGeom prst="rect">
+            <a:avLst/>
+          </a:prstGeom>
+          <a:noFill/>
+        </p:spPr>
+        <p:txBody>
+          <a:bodyPr wrap="square" lIns="0" tIns="0" rIns="0" bIns="0" anchor="ctr">
+            <a:spAutoFit/>
+          </a:bodyPr>
+          <a:lstStyle/>
+          <a:p>
+            <a:pPr algn="l"/>
+            <a:r>
+              <a:rPr sz="950" b="1" i="0">
+                <a:solidFill>
+                  <a:srgbClr val="262626"/>
+                </a:solidFill>
+                <a:latin typeface="맑은 고딕"/>
+                <a:ea typeface="맑은 고딕"/>
+              </a:rPr>
+              <a:t>카드 비용 (4노드)</a:t>
+            </a:r>
+          </a:p>
+        </p:txBody>
+      </p:sp>
+      <p:sp>
+        <p:nvSpPr>
+          <p:cNvPr id="363" name="TextBox NB2"/>
+          <p:cNvSpPr txBox="1"/>
+          <p:nvPr/>
+        </p:nvSpPr>
+        <p:spPr>
+          <a:xfrm>
+            <a:off x="2171700" y="5257800"/>
+            <a:ext cx="2381250" cy="209550"/>
+          </a:xfrm>
+          <a:prstGeom prst="rect">
+            <a:avLst/>
+          </a:prstGeom>
+          <a:noFill/>
+        </p:spPr>
+        <p:txBody>
+          <a:bodyPr wrap="square" lIns="0" tIns="0" rIns="0" bIns="0" anchor="ctr">
+            <a:spAutoFit/>
+          </a:bodyPr>
+          <a:lstStyle/>
+          <a:p>
+            <a:pPr algn="ctr"/>
+            <a:r>
+              <a:rPr sz="950" b="1" i="0">
+                <a:solidFill>
+                  <a:srgbClr val="262626"/>
+                </a:solidFill>
+                <a:latin typeface="맑은 고딕"/>
+                <a:ea typeface="맑은 고딕"/>
+              </a:rPr>
+              <a:t>$960K  (1.00×)</a:t>
+            </a:r>
+          </a:p>
+        </p:txBody>
+      </p:sp>
+      <p:sp>
+        <p:nvSpPr>
+          <p:cNvPr id="364" name="TextBox NT2"/>
+          <p:cNvSpPr txBox="1"/>
+          <p:nvPr/>
+        </p:nvSpPr>
+        <p:spPr>
+          <a:xfrm>
+            <a:off x="4629150" y="5257800"/>
+            <a:ext cx="2381250" cy="209550"/>
+          </a:xfrm>
+          <a:prstGeom prst="rect">
+            <a:avLst/>
+          </a:prstGeom>
+          <a:noFill/>
+        </p:spPr>
+        <p:txBody>
+          <a:bodyPr wrap="square" lIns="0" tIns="0" rIns="0" bIns="0" anchor="ctr">
+            <a:spAutoFit/>
+          </a:bodyPr>
+          <a:lstStyle/>
+          <a:p>
+            <a:pPr algn="ctr"/>
+            <a:r>
+              <a:rPr sz="950" b="1" i="0">
+                <a:solidFill>
+                  <a:srgbClr val="262626"/>
+                </a:solidFill>
+                <a:latin typeface="맑은 고딕"/>
+                <a:ea typeface="맑은 고딕"/>
+              </a:rPr>
+              <a:t>$504K  (0.53×)</a:t>
+            </a:r>
+          </a:p>
+        </p:txBody>
+      </p:sp>
+      <p:sp>
+        <p:nvSpPr>
+          <p:cNvPr id="365" name="TextBox NF2"/>
+          <p:cNvSpPr txBox="1"/>
+          <p:nvPr/>
+        </p:nvSpPr>
+        <p:spPr>
+          <a:xfrm>
+            <a:off x="7143750" y="5257800"/>
+            <a:ext cx="4733925" cy="209550"/>
+          </a:xfrm>
+          <a:prstGeom prst="rect">
+            <a:avLst/>
+          </a:prstGeom>
+          <a:noFill/>
+        </p:spPr>
+        <p:txBody>
+          <a:bodyPr wrap="square" lIns="0" tIns="0" rIns="0" bIns="0" anchor="ctr">
+            <a:spAutoFit/>
+          </a:bodyPr>
+          <a:lstStyle/>
+          <a:p>
+            <a:pPr algn="l"/>
+            <a:r>
+              <a:rPr sz="800" b="0" i="0">
+                <a:solidFill>
+                  <a:srgbClr val="404040"/>
+                </a:solidFill>
+                <a:latin typeface="맑은 고딕"/>
+                <a:ea typeface="맑은 고딕"/>
+              </a:rPr>
+              <a:t>4×(8×$30K) / 4×(4×$30K + 4×$1.5K PNM) — H100 가격에 HBM 포함</a:t>
             </a:r>
           </a:p>
         </p:txBody>

</xml_diff>

<commit_message>
Target: 6x H100 (2 with half HBM + HBF) + 2x CXL-PNM per node
Co-Authored-By: Claude Sonnet 5.5 <noreply@anthropic.com>
Claude-Session: https://claude.ai/code/session_01N1hDbMkxPdrcYvvdEog1Sh
</commit_message>
<xml_diff>
--- a/Baseline_vs_Target_cost_updated.pptx
+++ b/Baseline_vs_Target_cost_updated.pptx
@@ -4067,7 +4067,7 @@
                 <a:latin typeface="맑은 고딕"/>
                 <a:ea typeface="맑은 고딕"/>
               </a:rPr>
-              <a:t>Target  —  H100 × 4  +  CXL-PNM × 4</a:t>
+              <a:t>Target  —  H100 × 6  +  CXL-PNM × 2</a:t>
             </a:r>
           </a:p>
         </p:txBody>
@@ -6201,7 +6201,7 @@
         </p:nvSpPr>
         <p:spPr>
           <a:xfrm>
-            <a:off x="4705350" y="2181225"/>
+            <a:off x="5819775" y="2181225"/>
             <a:ext cx="523875" cy="209550"/>
           </a:xfrm>
           <a:prstGeom prst="rect">
@@ -6259,7 +6259,7 @@
         </p:nvSpPr>
         <p:spPr>
           <a:xfrm>
-            <a:off x="4705350" y="2409825"/>
+            <a:off x="5819775" y="2409825"/>
             <a:ext cx="523875" cy="304800"/>
           </a:xfrm>
           <a:prstGeom prst="rect">
@@ -6319,7 +6319,7 @@
         </p:nvSpPr>
         <p:spPr>
           <a:xfrm>
-            <a:off x="5262562" y="2181225"/>
+            <a:off x="6376988" y="2181225"/>
             <a:ext cx="523875" cy="209550"/>
           </a:xfrm>
           <a:prstGeom prst="rect">
@@ -6377,7 +6377,7 @@
         </p:nvSpPr>
         <p:spPr>
           <a:xfrm>
-            <a:off x="5262562" y="2409825"/>
+            <a:off x="6376988" y="2409825"/>
             <a:ext cx="523875" cy="304800"/>
           </a:xfrm>
           <a:prstGeom prst="rect">
@@ -6431,242 +6431,6 @@
       </p:sp>
       <p:sp>
         <p:nvSpPr>
-          <p:cNvPr id="277" name="Rectangle 47"/>
-          <p:cNvSpPr/>
-          <p:nvPr/>
-        </p:nvSpPr>
-        <p:spPr>
-          <a:xfrm>
-            <a:off x="5819775" y="2181225"/>
-            <a:ext cx="523875" cy="209550"/>
-          </a:xfrm>
-          <a:prstGeom prst="rect">
-            <a:avLst/>
-          </a:prstGeom>
-          <a:solidFill>
-            <a:srgbClr val="BF8F00"/>
-          </a:solidFill>
-          <a:ln>
-            <a:noFill/>
-          </a:ln>
-          <a:effectLst/>
-        </p:spPr>
-        <p:style>
-          <a:lnRef idx="1">
-            <a:schemeClr val="accent1"/>
-          </a:lnRef>
-          <a:fillRef idx="3">
-            <a:schemeClr val="accent1"/>
-          </a:fillRef>
-          <a:effectRef idx="2">
-            <a:schemeClr val="accent1"/>
-          </a:effectRef>
-          <a:fontRef idx="minor">
-            <a:schemeClr val="lt1"/>
-          </a:fontRef>
-        </p:style>
-        <p:txBody>
-          <a:bodyPr wrap="square" lIns="27432" tIns="0" rIns="27432" bIns="0" rtlCol="0" anchor="ctr"/>
-          <a:lstStyle/>
-          <a:p>
-            <a:pPr algn="ctr">
-              <a:lnSpc>
-                <a:spcPct val="95000"/>
-              </a:lnSpc>
-            </a:pPr>
-            <a:r>
-              <a:rPr sz="700" b="1" i="0">
-                <a:solidFill>
-                  <a:srgbClr val="FFFFFF"/>
-                </a:solidFill>
-                <a:latin typeface="맑은 고딕"/>
-                <a:ea typeface="맑은 고딕"/>
-              </a:rPr>
-              <a:t>PNM2</a:t>
-            </a:r>
-          </a:p>
-        </p:txBody>
-      </p:sp>
-      <p:sp>
-        <p:nvSpPr>
-          <p:cNvPr id="278" name="Rectangle 48"/>
-          <p:cNvSpPr/>
-          <p:nvPr/>
-        </p:nvSpPr>
-        <p:spPr>
-          <a:xfrm>
-            <a:off x="5819775" y="2409825"/>
-            <a:ext cx="523875" cy="304800"/>
-          </a:xfrm>
-          <a:prstGeom prst="rect">
-            <a:avLst/>
-          </a:prstGeom>
-          <a:solidFill>
-            <a:srgbClr val="FFF2CC"/>
-          </a:solidFill>
-          <a:ln w="9525">
-            <a:solidFill>
-              <a:srgbClr val="BF8F00"/>
-            </a:solidFill>
-          </a:ln>
-          <a:effectLst/>
-        </p:spPr>
-        <p:style>
-          <a:lnRef idx="1">
-            <a:schemeClr val="accent1"/>
-          </a:lnRef>
-          <a:fillRef idx="3">
-            <a:schemeClr val="accent1"/>
-          </a:fillRef>
-          <a:effectRef idx="2">
-            <a:schemeClr val="accent1"/>
-          </a:effectRef>
-          <a:fontRef idx="minor">
-            <a:schemeClr val="lt1"/>
-          </a:fontRef>
-        </p:style>
-        <p:txBody>
-          <a:bodyPr wrap="square" lIns="27432" tIns="0" rIns="27432" bIns="0" rtlCol="0" anchor="ctr"/>
-          <a:lstStyle/>
-          <a:p>
-            <a:pPr algn="ctr">
-              <a:lnSpc>
-                <a:spcPct val="95000"/>
-              </a:lnSpc>
-            </a:pPr>
-            <a:r>
-              <a:rPr sz="700" b="1" i="0">
-                <a:solidFill>
-                  <a:srgbClr val="7F5F00"/>
-                </a:solidFill>
-                <a:latin typeface="맑은 고딕"/>
-                <a:ea typeface="맑은 고딕"/>
-              </a:rPr>
-              <a:t>DDR 128GB</a:t>
-            </a:r>
-          </a:p>
-        </p:txBody>
-      </p:sp>
-      <p:sp>
-        <p:nvSpPr>
-          <p:cNvPr id="279" name="Rectangle 49"/>
-          <p:cNvSpPr/>
-          <p:nvPr/>
-        </p:nvSpPr>
-        <p:spPr>
-          <a:xfrm>
-            <a:off x="6376988" y="2181225"/>
-            <a:ext cx="523875" cy="209550"/>
-          </a:xfrm>
-          <a:prstGeom prst="rect">
-            <a:avLst/>
-          </a:prstGeom>
-          <a:solidFill>
-            <a:srgbClr val="BF8F00"/>
-          </a:solidFill>
-          <a:ln>
-            <a:noFill/>
-          </a:ln>
-          <a:effectLst/>
-        </p:spPr>
-        <p:style>
-          <a:lnRef idx="1">
-            <a:schemeClr val="accent1"/>
-          </a:lnRef>
-          <a:fillRef idx="3">
-            <a:schemeClr val="accent1"/>
-          </a:fillRef>
-          <a:effectRef idx="2">
-            <a:schemeClr val="accent1"/>
-          </a:effectRef>
-          <a:fontRef idx="minor">
-            <a:schemeClr val="lt1"/>
-          </a:fontRef>
-        </p:style>
-        <p:txBody>
-          <a:bodyPr wrap="square" lIns="27432" tIns="0" rIns="27432" bIns="0" rtlCol="0" anchor="ctr"/>
-          <a:lstStyle/>
-          <a:p>
-            <a:pPr algn="ctr">
-              <a:lnSpc>
-                <a:spcPct val="95000"/>
-              </a:lnSpc>
-            </a:pPr>
-            <a:r>
-              <a:rPr sz="700" b="1" i="0">
-                <a:solidFill>
-                  <a:srgbClr val="FFFFFF"/>
-                </a:solidFill>
-                <a:latin typeface="맑은 고딕"/>
-                <a:ea typeface="맑은 고딕"/>
-              </a:rPr>
-              <a:t>PNM3</a:t>
-            </a:r>
-          </a:p>
-        </p:txBody>
-      </p:sp>
-      <p:sp>
-        <p:nvSpPr>
-          <p:cNvPr id="280" name="Rectangle 50"/>
-          <p:cNvSpPr/>
-          <p:nvPr/>
-        </p:nvSpPr>
-        <p:spPr>
-          <a:xfrm>
-            <a:off x="6376988" y="2409825"/>
-            <a:ext cx="523875" cy="304800"/>
-          </a:xfrm>
-          <a:prstGeom prst="rect">
-            <a:avLst/>
-          </a:prstGeom>
-          <a:solidFill>
-            <a:srgbClr val="FFF2CC"/>
-          </a:solidFill>
-          <a:ln w="9525">
-            <a:solidFill>
-              <a:srgbClr val="BF8F00"/>
-            </a:solidFill>
-          </a:ln>
-          <a:effectLst/>
-        </p:spPr>
-        <p:style>
-          <a:lnRef idx="1">
-            <a:schemeClr val="accent1"/>
-          </a:lnRef>
-          <a:fillRef idx="3">
-            <a:schemeClr val="accent1"/>
-          </a:fillRef>
-          <a:effectRef idx="2">
-            <a:schemeClr val="accent1"/>
-          </a:effectRef>
-          <a:fontRef idx="minor">
-            <a:schemeClr val="lt1"/>
-          </a:fontRef>
-        </p:style>
-        <p:txBody>
-          <a:bodyPr wrap="square" lIns="27432" tIns="0" rIns="27432" bIns="0" rtlCol="0" anchor="ctr"/>
-          <a:lstStyle/>
-          <a:p>
-            <a:pPr algn="ctr">
-              <a:lnSpc>
-                <a:spcPct val="95000"/>
-              </a:lnSpc>
-            </a:pPr>
-            <a:r>
-              <a:rPr sz="700" b="1" i="0">
-                <a:solidFill>
-                  <a:srgbClr val="7F5F00"/>
-                </a:solidFill>
-                <a:latin typeface="맑은 고딕"/>
-                <a:ea typeface="맑은 고딕"/>
-              </a:rPr>
-              <a:t>DDR 128GB</a:t>
-            </a:r>
-          </a:p>
-        </p:txBody>
-      </p:sp>
-      <p:sp>
-        <p:nvSpPr>
           <p:cNvPr id="281" name="Rectangle 51"/>
           <p:cNvSpPr/>
           <p:nvPr/>
@@ -6832,7 +6596,7 @@
                 <a:spcPct val="115000"/>
               </a:lnSpc>
               <a:spcAft>
-                <a:spcPts val="400"/>
+                <a:spcPts val="300"/>
               </a:spcAft>
             </a:pPr>
             <a:r>
@@ -6853,7 +6617,7 @@
                 <a:latin typeface="맑은 고딕"/>
                 <a:ea typeface="맑은 고딕"/>
               </a:rPr>
-              <a:t>NVIDIA H100 SXM5 80GB · HBM3 (5-stack) · 3.35 TB/s · 132 SM — 신품 $30K/장 (HBM 포함)</a:t>
+              <a:t>NVIDIA H100 SXM5 80GB · HBM3 · 3.35 TB/s · 132 SM — 신품 $30K/장 (HBM 포함). Target 6대 중 4대는 HBM 80GB, 2대는 HBM 40GB + HBF 320GB</a:t>
             </a:r>
           </a:p>
           <a:p>
@@ -6862,7 +6626,7 @@
                 <a:spcPct val="115000"/>
               </a:lnSpc>
               <a:spcAft>
-                <a:spcPts val="400"/>
+                <a:spcPts val="300"/>
               </a:spcAft>
             </a:pPr>
             <a:r>
@@ -6873,7 +6637,7 @@
                 <a:latin typeface="맑은 고딕"/>
                 <a:ea typeface="맑은 고딕"/>
               </a:rPr>
-              <a:t>CPU  </a:t>
+              <a:t>HBF  </a:t>
             </a:r>
             <a:r>
               <a:rPr sz="800" b="0" i="0">
@@ -6883,7 +6647,7 @@
                 <a:latin typeface="맑은 고딕"/>
                 <a:ea typeface="맑은 고딕"/>
               </a:rPr>
-              <a:t>Xeon Platinum 8480+급 (Sapphire Rapids, 56C) × 2소켓 · DDR5-4800 8ch × 64GB RDIMM = 512GB/소켓 — 신품 $35/GB</a:t>
+              <a:t>High Bandwidth Flash (NAND 적층, SanDisk · SK hynix OCP 규격) — HBM 스택 절반 교체, 동일 스택 비용에 8× 용량 · HBM급 BW 전제 → $15.6 ÷ 8 = $1.95/GB (가정)</a:t>
             </a:r>
           </a:p>
           <a:p>
@@ -6892,7 +6656,7 @@
                 <a:spcPct val="115000"/>
               </a:lnSpc>
               <a:spcAft>
-                <a:spcPts val="400"/>
+                <a:spcPts val="300"/>
               </a:spcAft>
             </a:pPr>
             <a:r>
@@ -6903,7 +6667,7 @@
                 <a:latin typeface="맑은 고딕"/>
                 <a:ea typeface="맑은 고딕"/>
               </a:rPr>
-              <a:t>CXL-PNM  </a:t>
+              <a:t>CPU  </a:t>
             </a:r>
             <a:r>
               <a:rPr sz="800" b="0" i="0">
@@ -6913,7 +6677,7 @@
                 <a:latin typeface="맑은 고딕"/>
                 <a:ea typeface="맑은 고딕"/>
               </a:rPr>
-              <a:t>Marvell Structera A 2504 (CXL Type-3 · Arm Neoverse V2 16코어 near-memory) · DDR5-6400 4ch × 32GB RDIMM = 128GB/카드 — 카드 $1.5K (가정, 가격 비공개)</a:t>
+              <a:t>Xeon Platinum 8480+급 56C × 2소켓 · DDR5-4800 8ch × 64GB RDIMM = 512GB/소켓 — 신품 $35/GB</a:t>
             </a:r>
           </a:p>
           <a:p>
@@ -6922,7 +6686,7 @@
                 <a:spcPct val="115000"/>
               </a:lnSpc>
               <a:spcAft>
-                <a:spcPts val="400"/>
+                <a:spcPts val="300"/>
               </a:spcAft>
             </a:pPr>
             <a:r>
@@ -6933,7 +6697,7 @@
                 <a:latin typeface="맑은 고딕"/>
                 <a:ea typeface="맑은 고딕"/>
               </a:rPr>
-              <a:t>NVMe SSD  </a:t>
+              <a:t>CXL-PNM  </a:t>
             </a:r>
             <a:r>
               <a:rPr sz="800" b="0" i="0">
@@ -6943,7 +6707,7 @@
                 <a:latin typeface="맑은 고딕"/>
                 <a:ea typeface="맑은 고딕"/>
               </a:rPr>
-              <a:t>엔터프라이즈 PCIe Gen4 U.3 TLC (Micron 7450 PRO급) 4TB × 4대, 7 GB/s × 4 = 28 GB/s — 신품 $0.45/GB</a:t>
+              <a:t>Marvell Structera A 2504 (CXL Type-3 · Arm Neoverse V2 16코어) · DDR5-6400 4ch × 32GB = 128GB/카드 — 카드 $1.5K (가정)</a:t>
             </a:r>
           </a:p>
           <a:p>
@@ -6952,7 +6716,7 @@
                 <a:spcPct val="115000"/>
               </a:lnSpc>
               <a:spcAft>
-                <a:spcPts val="400"/>
+                <a:spcPts val="300"/>
               </a:spcAft>
             </a:pPr>
             <a:r>
@@ -6963,7 +6727,7 @@
                 <a:latin typeface="맑은 고딕"/>
                 <a:ea typeface="맑은 고딕"/>
               </a:rPr>
-              <a:t>PIM-SSD  </a:t>
+              <a:t>NVMe SSD  </a:t>
             </a:r>
             <a:r>
               <a:rPr sz="800" b="0" i="0">
@@ -6973,7 +6737,7 @@
                 <a:latin typeface="맑은 고딕"/>
                 <a:ea typeface="맑은 고딕"/>
               </a:rPr>
-              <a:t>연산 내장 SSD — NVMe와 동일 용량 · 대역폭 · 단가로 가정</a:t>
+              <a:t>엔터프라이즈 PCIe Gen4 U.3 TLC (Micron 7450 PRO급) 4TB × 4대, 7 GB/s × 4 = 28 GB/s — 신품 $0.45/GB</a:t>
             </a:r>
           </a:p>
           <a:p>
@@ -6982,7 +6746,7 @@
                 <a:spcPct val="115000"/>
               </a:lnSpc>
               <a:spcAft>
-                <a:spcPts val="400"/>
+                <a:spcPts val="300"/>
               </a:spcAft>
             </a:pPr>
             <a:r>
@@ -6993,7 +6757,7 @@
                 <a:latin typeface="맑은 고딕"/>
                 <a:ea typeface="맑은 고딕"/>
               </a:rPr>
-              <a:t>노드  </a:t>
+              <a:t>PIM-SSD  </a:t>
             </a:r>
             <a:r>
               <a:rPr sz="800" b="0" i="0">
@@ -7003,7 +6767,7 @@
                 <a:latin typeface="맑은 고딕"/>
                 <a:ea typeface="맑은 고딕"/>
               </a:rPr>
-              <a:t>Baseline · Target 모두 4노드. 표의 용량 · 대역폭은 1노드 기준, 비용은 4노드 합계</a:t>
+              <a:t>연산 내장 SSD — NVMe와 동일 사양 · 단가 가정.  두 구성 모두 4노드</a:t>
             </a:r>
           </a:p>
         </p:txBody>
@@ -7102,7 +6866,7 @@
         <p:spPr>
           <a:xfrm>
             <a:off x="361950" y="3333750"/>
-            <a:ext cx="1733550" cy="209550"/>
+            <a:ext cx="1733550" cy="200025"/>
           </a:xfrm>
           <a:prstGeom prst="rect">
             <a:avLst/>
@@ -7138,7 +6902,7 @@
         <p:spPr>
           <a:xfrm>
             <a:off x="2171700" y="3333750"/>
-            <a:ext cx="2381250" cy="209550"/>
+            <a:ext cx="2381250" cy="200025"/>
           </a:xfrm>
           <a:prstGeom prst="rect">
             <a:avLst/>
@@ -7174,7 +6938,7 @@
         <p:spPr>
           <a:xfrm>
             <a:off x="4629150" y="3333750"/>
-            <a:ext cx="2381250" cy="209550"/>
+            <a:ext cx="2381250" cy="200025"/>
           </a:xfrm>
           <a:prstGeom prst="rect">
             <a:avLst/>
@@ -7196,7 +6960,7 @@
                 <a:latin typeface="맑은 고딕"/>
                 <a:ea typeface="맑은 고딕"/>
               </a:rPr>
-              <a:t>320 GB  ·  13.4 TB/s</a:t>
+              <a:t>400 GB  ·  16.75 TB/s</a:t>
             </a:r>
           </a:p>
         </p:txBody>
@@ -7210,7 +6974,7 @@
         <p:spPr>
           <a:xfrm>
             <a:off x="7143750" y="3333750"/>
-            <a:ext cx="4733925" cy="209550"/>
+            <a:ext cx="4733925" cy="200025"/>
           </a:xfrm>
           <a:prstGeom prst="rect">
             <a:avLst/>
@@ -7232,21 +6996,21 @@
                 <a:latin typeface="맑은 고딕"/>
                 <a:ea typeface="맑은 고딕"/>
               </a:rPr>
-              <a:t>H100 SXM5 80GB · HBM3 · 3.35 TB/s — Base 8×80GB, 8×3.35 / Target 4×80GB, 4×3.35</a:t>
-            </a:r>
-          </a:p>
-        </p:txBody>
-      </p:sp>
-      <p:sp>
-        <p:nvSpPr>
-          <p:cNvPr id="318" name="TextBox 317"/>
+              <a:t>H100 HBM3 3.35 TB/s — 8×80GB, 8×3.35 / 4×80 + 2×40 = 400GB, 4×3.35 + 2×1.675</a:t>
+            </a:r>
+          </a:p>
+        </p:txBody>
+      </p:sp>
+      <p:sp>
+        <p:nvSpPr>
+          <p:cNvPr id="314" name="TextBox 313"/>
           <p:cNvSpPr txBox="1"/>
           <p:nvPr/>
         </p:nvSpPr>
         <p:spPr>
           <a:xfrm>
-            <a:off x="361950" y="3543300"/>
-            <a:ext cx="1733550" cy="209550"/>
+            <a:off x="361950" y="3533775"/>
+            <a:ext cx="1733550" cy="200025"/>
           </a:xfrm>
           <a:prstGeom prst="rect">
             <a:avLst/>
@@ -7268,21 +7032,21 @@
                 <a:latin typeface="맑은 고딕"/>
                 <a:ea typeface="맑은 고딕"/>
               </a:rPr>
-              <a:t>CXL-PNM (DDR)</a:t>
-            </a:r>
-          </a:p>
-        </p:txBody>
-      </p:sp>
-      <p:sp>
-        <p:nvSpPr>
-          <p:cNvPr id="319" name="TextBox 318"/>
+              <a:t>HBF</a:t>
+            </a:r>
+          </a:p>
+        </p:txBody>
+      </p:sp>
+      <p:sp>
+        <p:nvSpPr>
+          <p:cNvPr id="315" name="TextBox 314"/>
           <p:cNvSpPr txBox="1"/>
           <p:nvPr/>
         </p:nvSpPr>
         <p:spPr>
           <a:xfrm>
-            <a:off x="2171700" y="3543300"/>
-            <a:ext cx="2381250" cy="209550"/>
+            <a:off x="2171700" y="3533775"/>
+            <a:ext cx="2381250" cy="200025"/>
           </a:xfrm>
           <a:prstGeom prst="rect">
             <a:avLst/>
@@ -7311,14 +7075,14 @@
       </p:sp>
       <p:sp>
         <p:nvSpPr>
-          <p:cNvPr id="320" name="TextBox 319"/>
+          <p:cNvPr id="316" name="TextBox 315"/>
           <p:cNvSpPr txBox="1"/>
           <p:nvPr/>
         </p:nvSpPr>
         <p:spPr>
           <a:xfrm>
-            <a:off x="4629150" y="3543300"/>
-            <a:ext cx="2381250" cy="209550"/>
+            <a:off x="4629150" y="3533775"/>
+            <a:ext cx="2381250" cy="200025"/>
           </a:xfrm>
           <a:prstGeom prst="rect">
             <a:avLst/>
@@ -7340,21 +7104,21 @@
                 <a:latin typeface="맑은 고딕"/>
                 <a:ea typeface="맑은 고딕"/>
               </a:rPr>
-              <a:t>512 GB  ·  800 GB/s</a:t>
-            </a:r>
-          </a:p>
-        </p:txBody>
-      </p:sp>
-      <p:sp>
-        <p:nvSpPr>
-          <p:cNvPr id="321" name="TextBox 320"/>
+              <a:t>640 GB  ·  3.35 TB/s</a:t>
+            </a:r>
+          </a:p>
+        </p:txBody>
+      </p:sp>
+      <p:sp>
+        <p:nvSpPr>
+          <p:cNvPr id="317" name="TextBox 316"/>
           <p:cNvSpPr txBox="1"/>
           <p:nvPr/>
         </p:nvSpPr>
         <p:spPr>
           <a:xfrm>
-            <a:off x="7143750" y="3543300"/>
-            <a:ext cx="4733925" cy="209550"/>
+            <a:off x="7143750" y="3533775"/>
+            <a:ext cx="4733925" cy="200025"/>
           </a:xfrm>
           <a:prstGeom prst="rect">
             <a:avLst/>
@@ -7376,21 +7140,21 @@
                 <a:latin typeface="맑은 고딕"/>
                 <a:ea typeface="맑은 고딕"/>
               </a:rPr>
-              <a:t>Structera A 2504 · DDR5-6400 4ch×32GB = 128GB, ≈200 GB/s/카드 — 4카드: 4×128, 4×200</a:t>
-            </a:r>
-          </a:p>
-        </p:txBody>
-      </p:sp>
-      <p:sp>
-        <p:nvSpPr>
-          <p:cNvPr id="322" name="TextBox 321"/>
+              <a:t>HBF (SanDisk·SK hynix) 2대 × 320GB = 640GB · BW 2×1.675 = 3.35 TB/s</a:t>
+            </a:r>
+          </a:p>
+        </p:txBody>
+      </p:sp>
+      <p:sp>
+        <p:nvSpPr>
+          <p:cNvPr id="318" name="TextBox 317"/>
           <p:cNvSpPr txBox="1"/>
           <p:nvPr/>
         </p:nvSpPr>
         <p:spPr>
           <a:xfrm>
-            <a:off x="361950" y="3752850"/>
-            <a:ext cx="1733550" cy="209550"/>
+            <a:off x="361950" y="3733800"/>
+            <a:ext cx="1733550" cy="200025"/>
           </a:xfrm>
           <a:prstGeom prst="rect">
             <a:avLst/>
@@ -7412,21 +7176,21 @@
                 <a:latin typeface="맑은 고딕"/>
                 <a:ea typeface="맑은 고딕"/>
               </a:rPr>
-              <a:t>CPU DDR</a:t>
-            </a:r>
-          </a:p>
-        </p:txBody>
-      </p:sp>
-      <p:sp>
-        <p:nvSpPr>
-          <p:cNvPr id="323" name="TextBox 322"/>
+              <a:t>CXL-PNM (DDR)</a:t>
+            </a:r>
+          </a:p>
+        </p:txBody>
+      </p:sp>
+      <p:sp>
+        <p:nvSpPr>
+          <p:cNvPr id="319" name="TextBox 318"/>
           <p:cNvSpPr txBox="1"/>
           <p:nvPr/>
         </p:nvSpPr>
         <p:spPr>
           <a:xfrm>
-            <a:off x="2171700" y="3752850"/>
-            <a:ext cx="2381250" cy="209550"/>
+            <a:off x="2171700" y="3733800"/>
+            <a:ext cx="2381250" cy="200025"/>
           </a:xfrm>
           <a:prstGeom prst="rect">
             <a:avLst/>
@@ -7448,21 +7212,21 @@
                 <a:latin typeface="맑은 고딕"/>
                 <a:ea typeface="맑은 고딕"/>
               </a:rPr>
-              <a:t>1,024 GB  ·  350 GB/s</a:t>
-            </a:r>
-          </a:p>
-        </p:txBody>
-      </p:sp>
-      <p:sp>
-        <p:nvSpPr>
-          <p:cNvPr id="324" name="TextBox 323"/>
+              <a:t>—</a:t>
+            </a:r>
+          </a:p>
+        </p:txBody>
+      </p:sp>
+      <p:sp>
+        <p:nvSpPr>
+          <p:cNvPr id="320" name="TextBox 319"/>
           <p:cNvSpPr txBox="1"/>
           <p:nvPr/>
         </p:nvSpPr>
         <p:spPr>
           <a:xfrm>
-            <a:off x="4629150" y="3752850"/>
-            <a:ext cx="2381250" cy="209550"/>
+            <a:off x="4629150" y="3733800"/>
+            <a:ext cx="2381250" cy="200025"/>
           </a:xfrm>
           <a:prstGeom prst="rect">
             <a:avLst/>
@@ -7484,21 +7248,21 @@
                 <a:latin typeface="맑은 고딕"/>
                 <a:ea typeface="맑은 고딕"/>
               </a:rPr>
-              <a:t>1,024 GB  ·  350 GB/s</a:t>
-            </a:r>
-          </a:p>
-        </p:txBody>
-      </p:sp>
-      <p:sp>
-        <p:nvSpPr>
-          <p:cNvPr id="325" name="TextBox 324"/>
+              <a:t>256 GB  ·  400 GB/s</a:t>
+            </a:r>
+          </a:p>
+        </p:txBody>
+      </p:sp>
+      <p:sp>
+        <p:nvSpPr>
+          <p:cNvPr id="321" name="TextBox 320"/>
           <p:cNvSpPr txBox="1"/>
           <p:nvPr/>
         </p:nvSpPr>
         <p:spPr>
           <a:xfrm>
-            <a:off x="7143750" y="3752850"/>
-            <a:ext cx="4733925" cy="209550"/>
+            <a:off x="7143750" y="3733800"/>
+            <a:ext cx="4733925" cy="200025"/>
           </a:xfrm>
           <a:prstGeom prst="rect">
             <a:avLst/>
@@ -7520,21 +7284,21 @@
                 <a:latin typeface="맑은 고딕"/>
                 <a:ea typeface="맑은 고딕"/>
               </a:rPr>
-              <a:t>Xeon 8480+급 56C ×2 · DDR5-4800 8ch×64GB = 512GB, 유효 175 GB/s/소켓 — 2×512, 2×175</a:t>
-            </a:r>
-          </a:p>
-        </p:txBody>
-      </p:sp>
-      <p:sp>
-        <p:nvSpPr>
-          <p:cNvPr id="326" name="TextBox 325"/>
+              <a:t>Structera A 2504 · DDR5-6400 4ch×32GB = 128GB, ≈200 GB/s/카드 — 2카드: 2×128, 2×200</a:t>
+            </a:r>
+          </a:p>
+        </p:txBody>
+      </p:sp>
+      <p:sp>
+        <p:nvSpPr>
+          <p:cNvPr id="322" name="TextBox 321"/>
           <p:cNvSpPr txBox="1"/>
           <p:nvPr/>
         </p:nvSpPr>
         <p:spPr>
           <a:xfrm>
-            <a:off x="361950" y="3962400"/>
-            <a:ext cx="1733550" cy="209550"/>
+            <a:off x="361950" y="3933825"/>
+            <a:ext cx="1733550" cy="200025"/>
           </a:xfrm>
           <a:prstGeom prst="rect">
             <a:avLst/>
@@ -7556,21 +7320,21 @@
                 <a:latin typeface="맑은 고딕"/>
                 <a:ea typeface="맑은 고딕"/>
               </a:rPr>
-              <a:t>NVMe SSD</a:t>
-            </a:r>
-          </a:p>
-        </p:txBody>
-      </p:sp>
-      <p:sp>
-        <p:nvSpPr>
-          <p:cNvPr id="327" name="TextBox 326"/>
+              <a:t>CPU DDR</a:t>
+            </a:r>
+          </a:p>
+        </p:txBody>
+      </p:sp>
+      <p:sp>
+        <p:nvSpPr>
+          <p:cNvPr id="323" name="TextBox 322"/>
           <p:cNvSpPr txBox="1"/>
           <p:nvPr/>
         </p:nvSpPr>
         <p:spPr>
           <a:xfrm>
-            <a:off x="2171700" y="3962400"/>
-            <a:ext cx="2381250" cy="209550"/>
+            <a:off x="2171700" y="3933825"/>
+            <a:ext cx="2381250" cy="200025"/>
           </a:xfrm>
           <a:prstGeom prst="rect">
             <a:avLst/>
@@ -7592,21 +7356,21 @@
                 <a:latin typeface="맑은 고딕"/>
                 <a:ea typeface="맑은 고딕"/>
               </a:rPr>
-              <a:t>16,000 GB  ·  28 GB/s</a:t>
-            </a:r>
-          </a:p>
-        </p:txBody>
-      </p:sp>
-      <p:sp>
-        <p:nvSpPr>
-          <p:cNvPr id="328" name="TextBox 327"/>
+              <a:t>1,024 GB  ·  350 GB/s</a:t>
+            </a:r>
+          </a:p>
+        </p:txBody>
+      </p:sp>
+      <p:sp>
+        <p:nvSpPr>
+          <p:cNvPr id="324" name="TextBox 323"/>
           <p:cNvSpPr txBox="1"/>
           <p:nvPr/>
         </p:nvSpPr>
         <p:spPr>
           <a:xfrm>
-            <a:off x="4629150" y="3962400"/>
-            <a:ext cx="2381250" cy="209550"/>
+            <a:off x="4629150" y="3933825"/>
+            <a:ext cx="2381250" cy="200025"/>
           </a:xfrm>
           <a:prstGeom prst="rect">
             <a:avLst/>
@@ -7628,21 +7392,21 @@
                 <a:latin typeface="맑은 고딕"/>
                 <a:ea typeface="맑은 고딕"/>
               </a:rPr>
-              <a:t>16,000 GB  ·  28 GB/s</a:t>
-            </a:r>
-          </a:p>
-        </p:txBody>
-      </p:sp>
-      <p:sp>
-        <p:nvSpPr>
-          <p:cNvPr id="329" name="TextBox 328"/>
+              <a:t>1,024 GB  ·  350 GB/s</a:t>
+            </a:r>
+          </a:p>
+        </p:txBody>
+      </p:sp>
+      <p:sp>
+        <p:nvSpPr>
+          <p:cNvPr id="325" name="TextBox 324"/>
           <p:cNvSpPr txBox="1"/>
           <p:nvPr/>
         </p:nvSpPr>
         <p:spPr>
           <a:xfrm>
-            <a:off x="7143750" y="3962400"/>
-            <a:ext cx="4733925" cy="209550"/>
+            <a:off x="7143750" y="3933825"/>
+            <a:ext cx="4733925" cy="200025"/>
           </a:xfrm>
           <a:prstGeom prst="rect">
             <a:avLst/>
@@ -7664,21 +7428,21 @@
                 <a:latin typeface="맑은 고딕"/>
                 <a:ea typeface="맑은 고딕"/>
               </a:rPr>
-              <a:t>NVMe PCIe Gen4 U.3 TLC · 4TB×4 = 16TB, 7 GB/s×4 = 28 GB/s</a:t>
-            </a:r>
-          </a:p>
-        </p:txBody>
-      </p:sp>
-      <p:sp>
-        <p:nvSpPr>
-          <p:cNvPr id="330" name="TextBox 329"/>
+              <a:t>Xeon 8480+급 56C ×2 · DDR5-4800 8ch×64GB = 512GB, 유효 175 GB/s/소켓 — 2×512, 2×175</a:t>
+            </a:r>
+          </a:p>
+        </p:txBody>
+      </p:sp>
+      <p:sp>
+        <p:nvSpPr>
+          <p:cNvPr id="326" name="TextBox 325"/>
           <p:cNvSpPr txBox="1"/>
           <p:nvPr/>
         </p:nvSpPr>
         <p:spPr>
           <a:xfrm>
-            <a:off x="361950" y="4171950"/>
-            <a:ext cx="1733550" cy="209550"/>
+            <a:off x="361950" y="4133850"/>
+            <a:ext cx="1733550" cy="200025"/>
           </a:xfrm>
           <a:prstGeom prst="rect">
             <a:avLst/>
@@ -7700,21 +7464,21 @@
                 <a:latin typeface="맑은 고딕"/>
                 <a:ea typeface="맑은 고딕"/>
               </a:rPr>
-              <a:t>PIM-SSD</a:t>
-            </a:r>
-          </a:p>
-        </p:txBody>
-      </p:sp>
-      <p:sp>
-        <p:nvSpPr>
-          <p:cNvPr id="331" name="TextBox 330"/>
+              <a:t>NVMe SSD</a:t>
+            </a:r>
+          </a:p>
+        </p:txBody>
+      </p:sp>
+      <p:sp>
+        <p:nvSpPr>
+          <p:cNvPr id="327" name="TextBox 326"/>
           <p:cNvSpPr txBox="1"/>
           <p:nvPr/>
         </p:nvSpPr>
         <p:spPr>
           <a:xfrm>
-            <a:off x="2171700" y="4171950"/>
-            <a:ext cx="2381250" cy="209550"/>
+            <a:off x="2171700" y="4133850"/>
+            <a:ext cx="2381250" cy="200025"/>
           </a:xfrm>
           <a:prstGeom prst="rect">
             <a:avLst/>
@@ -7736,21 +7500,21 @@
                 <a:latin typeface="맑은 고딕"/>
                 <a:ea typeface="맑은 고딕"/>
               </a:rPr>
-              <a:t>—</a:t>
-            </a:r>
-          </a:p>
-        </p:txBody>
-      </p:sp>
-      <p:sp>
-        <p:nvSpPr>
-          <p:cNvPr id="332" name="TextBox 331"/>
+              <a:t>16,000 GB  ·  28 GB/s</a:t>
+            </a:r>
+          </a:p>
+        </p:txBody>
+      </p:sp>
+      <p:sp>
+        <p:nvSpPr>
+          <p:cNvPr id="328" name="TextBox 327"/>
           <p:cNvSpPr txBox="1"/>
           <p:nvPr/>
         </p:nvSpPr>
         <p:spPr>
           <a:xfrm>
-            <a:off x="4629150" y="4171950"/>
-            <a:ext cx="2381250" cy="209550"/>
+            <a:off x="4629150" y="4133850"/>
+            <a:ext cx="2381250" cy="200025"/>
           </a:xfrm>
           <a:prstGeom prst="rect">
             <a:avLst/>
@@ -7779,14 +7543,14 @@
       </p:sp>
       <p:sp>
         <p:nvSpPr>
-          <p:cNvPr id="333" name="TextBox 332"/>
+          <p:cNvPr id="329" name="TextBox 328"/>
           <p:cNvSpPr txBox="1"/>
           <p:nvPr/>
         </p:nvSpPr>
         <p:spPr>
           <a:xfrm>
-            <a:off x="7143750" y="4171950"/>
-            <a:ext cx="4733925" cy="209550"/>
+            <a:off x="7143750" y="4133850"/>
+            <a:ext cx="4733925" cy="200025"/>
           </a:xfrm>
           <a:prstGeom prst="rect">
             <a:avLst/>
@@ -7808,6 +7572,150 @@
                 <a:latin typeface="맑은 고딕"/>
                 <a:ea typeface="맑은 고딕"/>
               </a:rPr>
+              <a:t>NVMe PCIe Gen4 U.3 TLC · 4TB×4 = 16TB, 7 GB/s×4 = 28 GB/s</a:t>
+            </a:r>
+          </a:p>
+        </p:txBody>
+      </p:sp>
+      <p:sp>
+        <p:nvSpPr>
+          <p:cNvPr id="330" name="TextBox 329"/>
+          <p:cNvSpPr txBox="1"/>
+          <p:nvPr/>
+        </p:nvSpPr>
+        <p:spPr>
+          <a:xfrm>
+            <a:off x="361950" y="4333875"/>
+            <a:ext cx="1733550" cy="200025"/>
+          </a:xfrm>
+          <a:prstGeom prst="rect">
+            <a:avLst/>
+          </a:prstGeom>
+          <a:noFill/>
+        </p:spPr>
+        <p:txBody>
+          <a:bodyPr wrap="square" lIns="0" tIns="0" rIns="0" bIns="0" anchor="ctr">
+            <a:spAutoFit/>
+          </a:bodyPr>
+          <a:lstStyle/>
+          <a:p>
+            <a:pPr algn="l"/>
+            <a:r>
+              <a:rPr sz="900" b="0" i="0">
+                <a:solidFill>
+                  <a:srgbClr val="808080"/>
+                </a:solidFill>
+                <a:latin typeface="맑은 고딕"/>
+                <a:ea typeface="맑은 고딕"/>
+              </a:rPr>
+              <a:t>PIM-SSD</a:t>
+            </a:r>
+          </a:p>
+        </p:txBody>
+      </p:sp>
+      <p:sp>
+        <p:nvSpPr>
+          <p:cNvPr id="331" name="TextBox 330"/>
+          <p:cNvSpPr txBox="1"/>
+          <p:nvPr/>
+        </p:nvSpPr>
+        <p:spPr>
+          <a:xfrm>
+            <a:off x="2171700" y="4333875"/>
+            <a:ext cx="2381250" cy="200025"/>
+          </a:xfrm>
+          <a:prstGeom prst="rect">
+            <a:avLst/>
+          </a:prstGeom>
+          <a:noFill/>
+        </p:spPr>
+        <p:txBody>
+          <a:bodyPr wrap="square" lIns="0" tIns="0" rIns="0" bIns="0" anchor="ctr">
+            <a:spAutoFit/>
+          </a:bodyPr>
+          <a:lstStyle/>
+          <a:p>
+            <a:pPr algn="ctr"/>
+            <a:r>
+              <a:rPr sz="900" b="0" i="0">
+                <a:solidFill>
+                  <a:srgbClr val="404040"/>
+                </a:solidFill>
+                <a:latin typeface="맑은 고딕"/>
+                <a:ea typeface="맑은 고딕"/>
+              </a:rPr>
+              <a:t>—</a:t>
+            </a:r>
+          </a:p>
+        </p:txBody>
+      </p:sp>
+      <p:sp>
+        <p:nvSpPr>
+          <p:cNvPr id="332" name="TextBox 331"/>
+          <p:cNvSpPr txBox="1"/>
+          <p:nvPr/>
+        </p:nvSpPr>
+        <p:spPr>
+          <a:xfrm>
+            <a:off x="4629150" y="4333875"/>
+            <a:ext cx="2381250" cy="200025"/>
+          </a:xfrm>
+          <a:prstGeom prst="rect">
+            <a:avLst/>
+          </a:prstGeom>
+          <a:noFill/>
+        </p:spPr>
+        <p:txBody>
+          <a:bodyPr wrap="square" lIns="0" tIns="0" rIns="0" bIns="0" anchor="ctr">
+            <a:spAutoFit/>
+          </a:bodyPr>
+          <a:lstStyle/>
+          <a:p>
+            <a:pPr algn="ctr"/>
+            <a:r>
+              <a:rPr sz="900" b="0" i="0">
+                <a:solidFill>
+                  <a:srgbClr val="404040"/>
+                </a:solidFill>
+                <a:latin typeface="맑은 고딕"/>
+                <a:ea typeface="맑은 고딕"/>
+              </a:rPr>
+              <a:t>16,000 GB  ·  28 GB/s</a:t>
+            </a:r>
+          </a:p>
+        </p:txBody>
+      </p:sp>
+      <p:sp>
+        <p:nvSpPr>
+          <p:cNvPr id="333" name="TextBox 332"/>
+          <p:cNvSpPr txBox="1"/>
+          <p:nvPr/>
+        </p:nvSpPr>
+        <p:spPr>
+          <a:xfrm>
+            <a:off x="7143750" y="4333875"/>
+            <a:ext cx="4733925" cy="200025"/>
+          </a:xfrm>
+          <a:prstGeom prst="rect">
+            <a:avLst/>
+          </a:prstGeom>
+          <a:noFill/>
+        </p:spPr>
+        <p:txBody>
+          <a:bodyPr wrap="square" lIns="0" tIns="0" rIns="0" bIns="0" anchor="ctr">
+            <a:spAutoFit/>
+          </a:bodyPr>
+          <a:lstStyle/>
+          <a:p>
+            <a:pPr algn="l"/>
+            <a:r>
+              <a:rPr sz="800" b="0" i="0">
+                <a:solidFill>
+                  <a:srgbClr val="595959"/>
+                </a:solidFill>
+                <a:latin typeface="맑은 고딕"/>
+                <a:ea typeface="맑은 고딕"/>
+              </a:rPr>
               <a:t>PIM(연산 내장) SSD · NVMe와 동일 용량·대역폭·단가 가정 — 16TB, 28 GB/s</a:t>
             </a:r>
           </a:p>
@@ -7821,8 +7729,8 @@
         </p:nvSpPr>
         <p:spPr>
           <a:xfrm>
-            <a:off x="361950" y="4419600"/>
-            <a:ext cx="11515725" cy="209550"/>
+            <a:off x="361950" y="4572000"/>
+            <a:ext cx="11515725" cy="200025"/>
           </a:xfrm>
           <a:prstGeom prst="rect">
             <a:avLst/>
@@ -7870,8 +7778,8 @@
         </p:nvSpPr>
         <p:spPr>
           <a:xfrm>
-            <a:off x="438150" y="4419600"/>
-            <a:ext cx="1657350" cy="209550"/>
+            <a:off x="438150" y="4572000"/>
+            <a:ext cx="1657350" cy="200025"/>
           </a:xfrm>
           <a:prstGeom prst="rect">
             <a:avLst/>
@@ -7906,8 +7814,8 @@
         </p:nvSpPr>
         <p:spPr>
           <a:xfrm>
-            <a:off x="2171700" y="4419600"/>
-            <a:ext cx="2381250" cy="209550"/>
+            <a:off x="2171700" y="4572000"/>
+            <a:ext cx="2381250" cy="200025"/>
           </a:xfrm>
           <a:prstGeom prst="rect">
             <a:avLst/>
@@ -7942,8 +7850,8 @@
         </p:nvSpPr>
         <p:spPr>
           <a:xfrm>
-            <a:off x="4629150" y="4419600"/>
-            <a:ext cx="2381250" cy="209550"/>
+            <a:off x="4629150" y="4572000"/>
+            <a:ext cx="2381250" cy="200025"/>
           </a:xfrm>
           <a:prstGeom prst="rect">
             <a:avLst/>
@@ -7965,7 +7873,7 @@
                 <a:latin typeface="맑은 고딕"/>
                 <a:ea typeface="맑은 고딕"/>
               </a:rPr>
-              <a:t>832 GB  (1.30×)</a:t>
+              <a:t>1,296 GB  (2.03×)</a:t>
             </a:r>
           </a:p>
         </p:txBody>
@@ -7978,8 +7886,8 @@
         </p:nvSpPr>
         <p:spPr>
           <a:xfrm>
-            <a:off x="7143750" y="4419600"/>
-            <a:ext cx="4733925" cy="209550"/>
+            <a:off x="7143750" y="4572000"/>
+            <a:ext cx="4733925" cy="200025"/>
           </a:xfrm>
           <a:prstGeom prst="rect">
             <a:avLst/>
@@ -8001,7 +7909,7 @@
                 <a:latin typeface="맑은 고딕"/>
                 <a:ea typeface="맑은 고딕"/>
               </a:rPr>
-              <a:t>HBM + PNM : 640 / 320 + 512 = 832 GB</a:t>
+              <a:t>HBM + HBF + PNM : 640 / 400 + 640 + 256 = 1,296 GB</a:t>
             </a:r>
           </a:p>
         </p:txBody>
@@ -8014,8 +7922,8 @@
         </p:nvSpPr>
         <p:spPr>
           <a:xfrm>
-            <a:off x="361950" y="4629150"/>
-            <a:ext cx="11515725" cy="209550"/>
+            <a:off x="361950" y="4772025"/>
+            <a:ext cx="11515725" cy="200025"/>
           </a:xfrm>
           <a:prstGeom prst="rect">
             <a:avLst/>
@@ -8063,8 +7971,8 @@
         </p:nvSpPr>
         <p:spPr>
           <a:xfrm>
-            <a:off x="438150" y="4629150"/>
-            <a:ext cx="1657350" cy="209550"/>
+            <a:off x="438150" y="4772025"/>
+            <a:ext cx="1657350" cy="200025"/>
           </a:xfrm>
           <a:prstGeom prst="rect">
             <a:avLst/>
@@ -8099,8 +8007,8 @@
         </p:nvSpPr>
         <p:spPr>
           <a:xfrm>
-            <a:off x="2171700" y="4629150"/>
-            <a:ext cx="2381250" cy="209550"/>
+            <a:off x="2171700" y="4772025"/>
+            <a:ext cx="2381250" cy="200025"/>
           </a:xfrm>
           <a:prstGeom prst="rect">
             <a:avLst/>
@@ -8135,8 +8043,8 @@
         </p:nvSpPr>
         <p:spPr>
           <a:xfrm>
-            <a:off x="4629150" y="4629150"/>
-            <a:ext cx="2381250" cy="209550"/>
+            <a:off x="4629150" y="4772025"/>
+            <a:ext cx="2381250" cy="200025"/>
           </a:xfrm>
           <a:prstGeom prst="rect">
             <a:avLst/>
@@ -8158,7 +8066,7 @@
                 <a:latin typeface="맑은 고딕"/>
                 <a:ea typeface="맑은 고딕"/>
               </a:rPr>
-              <a:t>14.2 TB/s  (0.53×)</a:t>
+              <a:t>20.5 TB/s  (0.76×)</a:t>
             </a:r>
           </a:p>
         </p:txBody>
@@ -8171,8 +8079,8 @@
         </p:nvSpPr>
         <p:spPr>
           <a:xfrm>
-            <a:off x="7143750" y="4629150"/>
-            <a:ext cx="4733925" cy="209550"/>
+            <a:off x="7143750" y="4772025"/>
+            <a:ext cx="4733925" cy="200025"/>
           </a:xfrm>
           <a:prstGeom prst="rect">
             <a:avLst/>
@@ -8194,7 +8102,7 @@
                 <a:latin typeface="맑은 고딕"/>
                 <a:ea typeface="맑은 고딕"/>
               </a:rPr>
-              <a:t>HBM + PNM : 8×3.35 = 26.8 / 4×3.35 + 4×0.2 = 14.2 TB/s</a:t>
+              <a:t>HBM + HBF + PNM : 8×3.35 = 26.8 / 16.75 + 3.35 + 0.4 = 20.5 TB/s</a:t>
             </a:r>
           </a:p>
         </p:txBody>
@@ -8207,8 +8115,8 @@
         </p:nvSpPr>
         <p:spPr>
           <a:xfrm>
-            <a:off x="361950" y="4838700"/>
-            <a:ext cx="11515725" cy="209550"/>
+            <a:off x="361950" y="4972050"/>
+            <a:ext cx="11515725" cy="200025"/>
           </a:xfrm>
           <a:prstGeom prst="rect">
             <a:avLst/>
@@ -8256,8 +8164,8 @@
         </p:nvSpPr>
         <p:spPr>
           <a:xfrm>
-            <a:off x="438150" y="4838700"/>
-            <a:ext cx="1657350" cy="209550"/>
+            <a:off x="438150" y="4972050"/>
+            <a:ext cx="1657350" cy="200025"/>
           </a:xfrm>
           <a:prstGeom prst="rect">
             <a:avLst/>
@@ -8292,8 +8200,8 @@
         </p:nvSpPr>
         <p:spPr>
           <a:xfrm>
-            <a:off x="2171700" y="4838700"/>
-            <a:ext cx="2381250" cy="209550"/>
+            <a:off x="2171700" y="4972050"/>
+            <a:ext cx="2381250" cy="200025"/>
           </a:xfrm>
           <a:prstGeom prst="rect">
             <a:avLst/>
@@ -8328,8 +8236,8 @@
         </p:nvSpPr>
         <p:spPr>
           <a:xfrm>
-            <a:off x="4629150" y="4838700"/>
-            <a:ext cx="2381250" cy="209550"/>
+            <a:off x="4629150" y="4972050"/>
+            <a:ext cx="2381250" cy="200025"/>
           </a:xfrm>
           <a:prstGeom prst="rect">
             <a:avLst/>
@@ -8351,7 +8259,7 @@
                 <a:latin typeface="맑은 고딕"/>
                 <a:ea typeface="맑은 고딕"/>
               </a:rPr>
-              <a:t>33,856 GB  (1.92×)</a:t>
+              <a:t>34,320 GB  (1.94×)</a:t>
             </a:r>
           </a:p>
         </p:txBody>
@@ -8364,8 +8272,8 @@
         </p:nvSpPr>
         <p:spPr>
           <a:xfrm>
-            <a:off x="7143750" y="4838700"/>
-            <a:ext cx="4733925" cy="209550"/>
+            <a:off x="7143750" y="4972050"/>
+            <a:ext cx="4733925" cy="200025"/>
           </a:xfrm>
           <a:prstGeom prst="rect">
             <a:avLst/>
@@ -8387,7 +8295,7 @@
                 <a:latin typeface="맑은 고딕"/>
                 <a:ea typeface="맑은 고딕"/>
               </a:rPr>
-              <a:t>HBM+PNM+DDR+NVMe+PIM : 640+1,024+16,000 / 320+512+1,024+16,000+16,000</a:t>
+              <a:t>HBM+HBF+PNM+DDR+NVMe+PIM : 640+1,024+16,000 / 1,296+1,024+16,000+16,000</a:t>
             </a:r>
           </a:p>
         </p:txBody>
@@ -8400,8 +8308,8 @@
         </p:nvSpPr>
         <p:spPr>
           <a:xfrm>
-            <a:off x="361950" y="5467350"/>
-            <a:ext cx="11515725" cy="209550"/>
+            <a:off x="361950" y="5572125"/>
+            <a:ext cx="11515725" cy="200025"/>
           </a:xfrm>
           <a:prstGeom prst="rect">
             <a:avLst/>
@@ -8449,8 +8357,8 @@
         </p:nvSpPr>
         <p:spPr>
           <a:xfrm>
-            <a:off x="438150" y="5467350"/>
-            <a:ext cx="1657350" cy="209550"/>
+            <a:off x="438150" y="5572125"/>
+            <a:ext cx="1657350" cy="200025"/>
           </a:xfrm>
           <a:prstGeom prst="rect">
             <a:avLst/>
@@ -8485,8 +8393,8 @@
         </p:nvSpPr>
         <p:spPr>
           <a:xfrm>
-            <a:off x="2171700" y="5467350"/>
-            <a:ext cx="2381250" cy="209550"/>
+            <a:off x="2171700" y="5572125"/>
+            <a:ext cx="2381250" cy="200025"/>
           </a:xfrm>
           <a:prstGeom prst="rect">
             <a:avLst/>
@@ -8521,8 +8429,8 @@
         </p:nvSpPr>
         <p:spPr>
           <a:xfrm>
-            <a:off x="4629150" y="5467350"/>
-            <a:ext cx="2381250" cy="209550"/>
+            <a:off x="4629150" y="5572125"/>
+            <a:ext cx="2381250" cy="200025"/>
           </a:xfrm>
           <a:prstGeom prst="rect">
             <a:avLst/>
@@ -8544,7 +8452,7 @@
                 <a:latin typeface="맑은 고딕"/>
                 <a:ea typeface="맑은 고딕"/>
               </a:rPr>
-              <a:t>$777K  (0.69×)</a:t>
+              <a:t>$969K  (0.86×)</a:t>
             </a:r>
           </a:p>
         </p:txBody>
@@ -8557,8 +8465,8 @@
         </p:nvSpPr>
         <p:spPr>
           <a:xfrm>
-            <a:off x="7143750" y="5467350"/>
-            <a:ext cx="4733925" cy="209550"/>
+            <a:off x="7143750" y="5572125"/>
+            <a:ext cx="4733925" cy="200025"/>
           </a:xfrm>
           <a:prstGeom prst="rect">
             <a:avLst/>
@@ -8580,7 +8488,7 @@
                 <a:latin typeface="맑은 고딕"/>
                 <a:ea typeface="맑은 고딕"/>
               </a:rPr>
-              <a:t>메모리·SSD + 카드 : $172K + $960K / $273K + $504K  (CPU·보드·전원 제외)</a:t>
+              <a:t>메모리·SSD + 카드 : $172K + $960K / $237K + $732K  (CPU·보드·전원 제외)</a:t>
             </a:r>
           </a:p>
         </p:txBody>
@@ -8593,8 +8501,8 @@
         </p:nvSpPr>
         <p:spPr>
           <a:xfrm>
-            <a:off x="365760" y="5753100"/>
-            <a:ext cx="11521440" cy="381000"/>
+            <a:off x="365760" y="5829300"/>
+            <a:ext cx="11521440" cy="361950"/>
           </a:xfrm>
           <a:prstGeom prst="rect">
             <a:avLst/>
@@ -8640,7 +8548,7 @@
                 <a:latin typeface="맑은 고딕"/>
                 <a:ea typeface="맑은 고딕"/>
               </a:rPr>
-              <a:t>집계 대역폭 0.53×는 슬롯당 대역폭이 낮아진 게 아니라 GPU가 4대 줄어든 몫이다 — 슬롯당 HBM 3.35 TB/s는 두 구성 모두 같고, decode attention이 묶이는 것은 슬롯당 대역폭이다</a:t>
+              <a:t>집계 대역폭 0.76×는 GPU 2대가 PNM으로 바뀐 몫이다 — HBF 장착 GPU는 HBM 절반 + HBF로 슬롯당 대역폭을 유지, decode attention이 묶이는 것은 슬롯당 대역폭이다</a:t>
             </a:r>
           </a:p>
           <a:p>
@@ -8657,7 +8565,7 @@
                 <a:latin typeface="맑은 고딕"/>
                 <a:ea typeface="맑은 고딕"/>
               </a:rPr>
-              <a:t>매체 지연 : HBM ~100 ns · CXL-PNM ~300 ns · NVMe ~100 μs → KV 상주 계층은 HBM · CXL-PNM이 맡고, NVMe · PIM-SSD는 cold 계층이다</a:t>
+              <a:t>매체 지연 : HBM ~100 ns · CXL-PNM ~300 ns · HBF ~10 μs급(NAND) · NVMe ~100 μs → HBF는 read-dominant 계층(weight · cold KV)이고, KV 상주 계층은 HBM · CXL-PNM이 맡는다</a:t>
             </a:r>
           </a:p>
         </p:txBody>
@@ -8670,7 +8578,7 @@
         </p:nvSpPr>
         <p:spPr>
           <a:xfrm>
-            <a:off x="365760" y="6210300"/>
+            <a:off x="365760" y="6248400"/>
             <a:ext cx="11521440" cy="420624"/>
           </a:xfrm>
           <a:prstGeom prst="rect">
@@ -8697,7 +8605,7 @@
                 <a:latin typeface="맑은 고딕"/>
                 <a:ea typeface="맑은 고딕"/>
               </a:rPr>
-              <a:t>※ GPU = H100 SXM5 (132 SM · HBM3 80GB · 3.35 TB/s) · CPU DDR 175 GB/s × 2소켓 · CXL-PNM(Structera A) 200 GB/s × 4카드. 용량 · 대역폭은 1노드 기준.</a:t>
+              <a:t>※ GPU = H100 SXM5 (132 SM · HBM3 80GB · 3.35 TB/s) · CPU DDR 175 GB/s × 2소켓 · CXL-PNM(Structera A) 200 GB/s/카드. Target = H100 4대(HBM 80GB) + 2대(HBM 40GB + HBF 320GB) + PNM 2카드.</a:t>
             </a:r>
           </a:p>
           <a:p>
@@ -8714,21 +8622,377 @@
                 <a:latin typeface="맑은 고딕"/>
                 <a:ea typeface="맑은 고딕"/>
               </a:rPr>
-              <a:t>※ 신품 단가(2026.10) H100 SXM5 80GB $30K(범위 $25~35K, HBM 포함) · DDR5 RDIMM $35/GB · 엔터프라이즈 NVMe·PIM-SSD $0.45/GB · PNM 카드 $1.5K(가정). 4노드 합계, CPU·보드·전원은 제외.</a:t>
-            </a:r>
-          </a:p>
-        </p:txBody>
-      </p:sp>
-      <p:sp>
-        <p:nvSpPr>
-          <p:cNvPr id="356" name="Rectangle N1"/>
+              <a:t>※ 신품 단가(2026.10) H100 $30K(HBM 포함) · HBM3 $15.6/GB · HBF $1.95/GB(HBM÷8 가정) · DDR5 $35/GB · NVMe·PIM-SSD $0.45/GB · PNM 카드 $1.5K(가정). 4노드 합계, CPU·보드·전원 제외.</a:t>
+            </a:r>
+          </a:p>
+        </p:txBody>
+      </p:sp>
+      <p:sp>
+        <p:nvSpPr>
+          <p:cNvPr id="356" name="GPU label H4"/>
           <p:cNvSpPr/>
           <p:nvPr/>
         </p:nvSpPr>
         <p:spPr>
           <a:xfrm>
-            <a:off x="361950" y="5048250"/>
-            <a:ext cx="11515725" cy="209550"/>
+            <a:off x="4705350" y="2181225"/>
+            <a:ext cx="523875" cy="209550"/>
+          </a:xfrm>
+          <a:prstGeom prst="rect">
+            <a:avLst/>
+          </a:prstGeom>
+          <a:solidFill>
+            <a:srgbClr val="1F6FB5"/>
+          </a:solidFill>
+          <a:ln>
+            <a:noFill/>
+          </a:ln>
+          <a:effectLst/>
+        </p:spPr>
+        <p:style>
+          <a:lnRef idx="1">
+            <a:schemeClr val="accent1"/>
+          </a:lnRef>
+          <a:fillRef idx="3">
+            <a:schemeClr val="accent1"/>
+          </a:fillRef>
+          <a:effectRef idx="2">
+            <a:schemeClr val="accent1"/>
+          </a:effectRef>
+          <a:fontRef idx="minor">
+            <a:schemeClr val="lt1"/>
+          </a:fontRef>
+        </p:style>
+        <p:txBody>
+          <a:bodyPr wrap="square" lIns="27432" tIns="0" rIns="27432" bIns="0" rtlCol="0" anchor="ctr"/>
+          <a:lstStyle/>
+          <a:p>
+            <a:pPr algn="ctr">
+              <a:lnSpc>
+                <a:spcPct val="95000"/>
+              </a:lnSpc>
+            </a:pPr>
+            <a:r>
+              <a:rPr sz="700" b="1" i="0">
+                <a:solidFill>
+                  <a:srgbClr val="FFFFFF"/>
+                </a:solidFill>
+                <a:latin typeface="맑은 고딕"/>
+                <a:ea typeface="맑은 고딕"/>
+              </a:rPr>
+              <a:t>GPU4</a:t>
+            </a:r>
+          </a:p>
+        </p:txBody>
+      </p:sp>
+      <p:sp>
+        <p:nvSpPr>
+          <p:cNvPr id="357" name="GPU label H5"/>
+          <p:cNvSpPr/>
+          <p:nvPr/>
+        </p:nvSpPr>
+        <p:spPr>
+          <a:xfrm>
+            <a:off x="5262562" y="2181225"/>
+            <a:ext cx="523875" cy="209550"/>
+          </a:xfrm>
+          <a:prstGeom prst="rect">
+            <a:avLst/>
+          </a:prstGeom>
+          <a:solidFill>
+            <a:srgbClr val="1F6FB5"/>
+          </a:solidFill>
+          <a:ln>
+            <a:noFill/>
+          </a:ln>
+          <a:effectLst/>
+        </p:spPr>
+        <p:style>
+          <a:lnRef idx="1">
+            <a:schemeClr val="accent1"/>
+          </a:lnRef>
+          <a:fillRef idx="3">
+            <a:schemeClr val="accent1"/>
+          </a:fillRef>
+          <a:effectRef idx="2">
+            <a:schemeClr val="accent1"/>
+          </a:effectRef>
+          <a:fontRef idx="minor">
+            <a:schemeClr val="lt1"/>
+          </a:fontRef>
+        </p:style>
+        <p:txBody>
+          <a:bodyPr wrap="square" lIns="27432" tIns="0" rIns="27432" bIns="0" rtlCol="0" anchor="ctr"/>
+          <a:lstStyle/>
+          <a:p>
+            <a:pPr algn="ctr">
+              <a:lnSpc>
+                <a:spcPct val="95000"/>
+              </a:lnSpc>
+            </a:pPr>
+            <a:r>
+              <a:rPr sz="700" b="1" i="0">
+                <a:solidFill>
+                  <a:srgbClr val="FFFFFF"/>
+                </a:solidFill>
+                <a:latin typeface="맑은 고딕"/>
+                <a:ea typeface="맑은 고딕"/>
+              </a:rPr>
+              <a:t>GPU5</a:t>
+            </a:r>
+          </a:p>
+        </p:txBody>
+      </p:sp>
+      <p:sp>
+        <p:nvSpPr>
+          <p:cNvPr id="358" name="HBM half 4"/>
+          <p:cNvSpPr/>
+          <p:nvPr/>
+        </p:nvSpPr>
+        <p:spPr>
+          <a:xfrm>
+            <a:off x="4705350" y="2409825"/>
+            <a:ext cx="523875" cy="152400"/>
+          </a:xfrm>
+          <a:prstGeom prst="rect">
+            <a:avLst/>
+          </a:prstGeom>
+          <a:solidFill>
+            <a:srgbClr val="DAE8F6"/>
+          </a:solidFill>
+          <a:ln w="9525">
+            <a:solidFill>
+              <a:srgbClr val="1F6FB5"/>
+            </a:solidFill>
+          </a:ln>
+          <a:effectLst/>
+        </p:spPr>
+        <p:style>
+          <a:lnRef idx="1">
+            <a:schemeClr val="accent1"/>
+          </a:lnRef>
+          <a:fillRef idx="3">
+            <a:schemeClr val="accent1"/>
+          </a:fillRef>
+          <a:effectRef idx="2">
+            <a:schemeClr val="accent1"/>
+          </a:effectRef>
+          <a:fontRef idx="minor">
+            <a:schemeClr val="lt1"/>
+          </a:fontRef>
+        </p:style>
+        <p:txBody>
+          <a:bodyPr wrap="square" lIns="27432" tIns="0" rIns="27432" bIns="0" rtlCol="0" anchor="ctr"/>
+          <a:lstStyle/>
+          <a:p>
+            <a:pPr algn="ctr">
+              <a:lnSpc>
+                <a:spcPct val="95000"/>
+              </a:lnSpc>
+            </a:pPr>
+            <a:r>
+              <a:rPr sz="600" b="1" i="0">
+                <a:solidFill>
+                  <a:srgbClr val="1F6FB5"/>
+                </a:solidFill>
+                <a:latin typeface="맑은 고딕"/>
+                <a:ea typeface="맑은 고딕"/>
+              </a:rPr>
+              <a:t>HBM 40GB</a:t>
+            </a:r>
+          </a:p>
+        </p:txBody>
+      </p:sp>
+      <p:sp>
+        <p:nvSpPr>
+          <p:cNvPr id="359" name="HBM half 5"/>
+          <p:cNvSpPr/>
+          <p:nvPr/>
+        </p:nvSpPr>
+        <p:spPr>
+          <a:xfrm>
+            <a:off x="5262562" y="2409825"/>
+            <a:ext cx="523875" cy="152400"/>
+          </a:xfrm>
+          <a:prstGeom prst="rect">
+            <a:avLst/>
+          </a:prstGeom>
+          <a:solidFill>
+            <a:srgbClr val="DAE8F6"/>
+          </a:solidFill>
+          <a:ln w="9525">
+            <a:solidFill>
+              <a:srgbClr val="1F6FB5"/>
+            </a:solidFill>
+          </a:ln>
+          <a:effectLst/>
+        </p:spPr>
+        <p:style>
+          <a:lnRef idx="1">
+            <a:schemeClr val="accent1"/>
+          </a:lnRef>
+          <a:fillRef idx="3">
+            <a:schemeClr val="accent1"/>
+          </a:fillRef>
+          <a:effectRef idx="2">
+            <a:schemeClr val="accent1"/>
+          </a:effectRef>
+          <a:fontRef idx="minor">
+            <a:schemeClr val="lt1"/>
+          </a:fontRef>
+        </p:style>
+        <p:txBody>
+          <a:bodyPr wrap="square" lIns="27432" tIns="0" rIns="27432" bIns="0" rtlCol="0" anchor="ctr"/>
+          <a:lstStyle/>
+          <a:p>
+            <a:pPr algn="ctr">
+              <a:lnSpc>
+                <a:spcPct val="95000"/>
+              </a:lnSpc>
+            </a:pPr>
+            <a:r>
+              <a:rPr sz="600" b="1" i="0">
+                <a:solidFill>
+                  <a:srgbClr val="1F6FB5"/>
+                </a:solidFill>
+                <a:latin typeface="맑은 고딕"/>
+                <a:ea typeface="맑은 고딕"/>
+              </a:rPr>
+              <a:t>HBM 40GB</a:t>
+            </a:r>
+          </a:p>
+        </p:txBody>
+      </p:sp>
+      <p:sp>
+        <p:nvSpPr>
+          <p:cNvPr id="360" name="HBF box 4"/>
+          <p:cNvSpPr/>
+          <p:nvPr/>
+        </p:nvSpPr>
+        <p:spPr>
+          <a:xfrm>
+            <a:off x="4705350" y="2562225"/>
+            <a:ext cx="523875" cy="152400"/>
+          </a:xfrm>
+          <a:prstGeom prst="rect">
+            <a:avLst/>
+          </a:prstGeom>
+          <a:solidFill>
+            <a:srgbClr val="E7DEF2"/>
+          </a:solidFill>
+          <a:ln w="9525">
+            <a:solidFill>
+              <a:srgbClr val="7B5EA7"/>
+            </a:solidFill>
+          </a:ln>
+          <a:effectLst/>
+        </p:spPr>
+        <p:style>
+          <a:lnRef idx="1">
+            <a:schemeClr val="accent1"/>
+          </a:lnRef>
+          <a:fillRef idx="3">
+            <a:schemeClr val="accent1"/>
+          </a:fillRef>
+          <a:effectRef idx="2">
+            <a:schemeClr val="accent1"/>
+          </a:effectRef>
+          <a:fontRef idx="minor">
+            <a:schemeClr val="lt1"/>
+          </a:fontRef>
+        </p:style>
+        <p:txBody>
+          <a:bodyPr wrap="square" lIns="27432" tIns="0" rIns="27432" bIns="0" rtlCol="0" anchor="ctr"/>
+          <a:lstStyle/>
+          <a:p>
+            <a:pPr algn="ctr">
+              <a:lnSpc>
+                <a:spcPct val="95000"/>
+              </a:lnSpc>
+            </a:pPr>
+            <a:r>
+              <a:rPr sz="600" b="1" i="0">
+                <a:solidFill>
+                  <a:srgbClr val="4A2E73"/>
+                </a:solidFill>
+                <a:latin typeface="맑은 고딕"/>
+                <a:ea typeface="맑은 고딕"/>
+              </a:rPr>
+              <a:t>HBF 320GB</a:t>
+            </a:r>
+          </a:p>
+        </p:txBody>
+      </p:sp>
+      <p:sp>
+        <p:nvSpPr>
+          <p:cNvPr id="361" name="HBF box 5"/>
+          <p:cNvSpPr/>
+          <p:nvPr/>
+        </p:nvSpPr>
+        <p:spPr>
+          <a:xfrm>
+            <a:off x="5262562" y="2562225"/>
+            <a:ext cx="523875" cy="152400"/>
+          </a:xfrm>
+          <a:prstGeom prst="rect">
+            <a:avLst/>
+          </a:prstGeom>
+          <a:solidFill>
+            <a:srgbClr val="E7DEF2"/>
+          </a:solidFill>
+          <a:ln w="9525">
+            <a:solidFill>
+              <a:srgbClr val="7B5EA7"/>
+            </a:solidFill>
+          </a:ln>
+          <a:effectLst/>
+        </p:spPr>
+        <p:style>
+          <a:lnRef idx="1">
+            <a:schemeClr val="accent1"/>
+          </a:lnRef>
+          <a:fillRef idx="3">
+            <a:schemeClr val="accent1"/>
+          </a:fillRef>
+          <a:effectRef idx="2">
+            <a:schemeClr val="accent1"/>
+          </a:effectRef>
+          <a:fontRef idx="minor">
+            <a:schemeClr val="lt1"/>
+          </a:fontRef>
+        </p:style>
+        <p:txBody>
+          <a:bodyPr wrap="square" lIns="27432" tIns="0" rIns="27432" bIns="0" rtlCol="0" anchor="ctr"/>
+          <a:lstStyle/>
+          <a:p>
+            <a:pPr algn="ctr">
+              <a:lnSpc>
+                <a:spcPct val="95000"/>
+              </a:lnSpc>
+            </a:pPr>
+            <a:r>
+              <a:rPr sz="600" b="1" i="0">
+                <a:solidFill>
+                  <a:srgbClr val="4A2E73"/>
+                </a:solidFill>
+                <a:latin typeface="맑은 고딕"/>
+                <a:ea typeface="맑은 고딕"/>
+              </a:rPr>
+              <a:t>HBF 320GB</a:t>
+            </a:r>
+          </a:p>
+        </p:txBody>
+      </p:sp>
+      <p:sp>
+        <p:nvSpPr>
+          <p:cNvPr id="362" name="Rectangle N1"/>
+          <p:cNvSpPr/>
+          <p:nvPr/>
+        </p:nvSpPr>
+        <p:spPr>
+          <a:xfrm>
+            <a:off x="361950" y="5172075"/>
+            <a:ext cx="11515725" cy="200025"/>
           </a:xfrm>
           <a:prstGeom prst="rect">
             <a:avLst/>
@@ -8770,14 +9034,14 @@
       </p:sp>
       <p:sp>
         <p:nvSpPr>
-          <p:cNvPr id="357" name="TextBox NL1"/>
+          <p:cNvPr id="363" name="TextBox NL1"/>
           <p:cNvSpPr txBox="1"/>
           <p:nvPr/>
         </p:nvSpPr>
         <p:spPr>
           <a:xfrm>
-            <a:off x="438150" y="5048250"/>
-            <a:ext cx="1657350" cy="209550"/>
+            <a:off x="438150" y="5172075"/>
+            <a:ext cx="1657350" cy="200025"/>
           </a:xfrm>
           <a:prstGeom prst="rect">
             <a:avLst/>
@@ -8806,14 +9070,14 @@
       </p:sp>
       <p:sp>
         <p:nvSpPr>
-          <p:cNvPr id="358" name="TextBox NB1"/>
+          <p:cNvPr id="364" name="TextBox NB1"/>
           <p:cNvSpPr txBox="1"/>
           <p:nvPr/>
         </p:nvSpPr>
         <p:spPr>
           <a:xfrm>
-            <a:off x="2171700" y="5048250"/>
-            <a:ext cx="2381250" cy="209550"/>
+            <a:off x="2171700" y="5172075"/>
+            <a:ext cx="2381250" cy="200025"/>
           </a:xfrm>
           <a:prstGeom prst="rect">
             <a:avLst/>
@@ -8842,14 +9106,14 @@
       </p:sp>
       <p:sp>
         <p:nvSpPr>
-          <p:cNvPr id="359" name="TextBox NT1"/>
+          <p:cNvPr id="365" name="TextBox NT1"/>
           <p:cNvSpPr txBox="1"/>
           <p:nvPr/>
         </p:nvSpPr>
         <p:spPr>
           <a:xfrm>
-            <a:off x="4629150" y="5048250"/>
-            <a:ext cx="2381250" cy="209550"/>
+            <a:off x="4629150" y="5172075"/>
+            <a:ext cx="2381250" cy="200025"/>
           </a:xfrm>
           <a:prstGeom prst="rect">
             <a:avLst/>
@@ -8871,21 +9135,21 @@
                 <a:latin typeface="맑은 고딕"/>
                 <a:ea typeface="맑은 고딕"/>
               </a:rPr>
-              <a:t>$273K  (1.58×)</a:t>
-            </a:r>
-          </a:p>
-        </p:txBody>
-      </p:sp>
-      <p:sp>
-        <p:nvSpPr>
-          <p:cNvPr id="360" name="TextBox NF1"/>
+              <a:t>$237K  (1.38×)</a:t>
+            </a:r>
+          </a:p>
+        </p:txBody>
+      </p:sp>
+      <p:sp>
+        <p:nvSpPr>
+          <p:cNvPr id="366" name="TextBox NF1"/>
           <p:cNvSpPr txBox="1"/>
           <p:nvPr/>
         </p:nvSpPr>
         <p:spPr>
           <a:xfrm>
-            <a:off x="7143750" y="5048250"/>
-            <a:ext cx="4733925" cy="209550"/>
+            <a:off x="7143750" y="5172075"/>
+            <a:ext cx="4733925" cy="200025"/>
           </a:xfrm>
           <a:prstGeom prst="rect">
             <a:avLst/>
@@ -8907,21 +9171,21 @@
                 <a:latin typeface="맑은 고딕"/>
                 <a:ea typeface="맑은 고딕"/>
               </a:rPr>
-              <a:t>4×[DDR 1,024GB×$35 + NVMe 16TB×$0.45] / 4×[DDR 1,536GB×$35 + SSD 32TB×$0.45]</a:t>
-            </a:r>
-          </a:p>
-        </p:txBody>
-      </p:sp>
-      <p:sp>
-        <p:nvSpPr>
-          <p:cNvPr id="361" name="Rectangle N2"/>
+              <a:t>4×[DDR 1,024GB×$35 + NVMe 16TB×$0.45] / 4×[DDR 1,280GB×$35 + SSD 32TB×$0.45]</a:t>
+            </a:r>
+          </a:p>
+        </p:txBody>
+      </p:sp>
+      <p:sp>
+        <p:nvSpPr>
+          <p:cNvPr id="367" name="Rectangle N2"/>
           <p:cNvSpPr/>
           <p:nvPr/>
         </p:nvSpPr>
         <p:spPr>
           <a:xfrm>
-            <a:off x="361950" y="5257800"/>
-            <a:ext cx="11515725" cy="209550"/>
+            <a:off x="361950" y="5372100"/>
+            <a:ext cx="11515725" cy="200025"/>
           </a:xfrm>
           <a:prstGeom prst="rect">
             <a:avLst/>
@@ -8963,14 +9227,14 @@
       </p:sp>
       <p:sp>
         <p:nvSpPr>
-          <p:cNvPr id="362" name="TextBox NL2"/>
+          <p:cNvPr id="368" name="TextBox NL2"/>
           <p:cNvSpPr txBox="1"/>
           <p:nvPr/>
         </p:nvSpPr>
         <p:spPr>
           <a:xfrm>
-            <a:off x="438150" y="5257800"/>
-            <a:ext cx="1657350" cy="209550"/>
+            <a:off x="438150" y="5372100"/>
+            <a:ext cx="1657350" cy="200025"/>
           </a:xfrm>
           <a:prstGeom prst="rect">
             <a:avLst/>
@@ -8999,14 +9263,14 @@
       </p:sp>
       <p:sp>
         <p:nvSpPr>
-          <p:cNvPr id="363" name="TextBox NB2"/>
+          <p:cNvPr id="369" name="TextBox NB2"/>
           <p:cNvSpPr txBox="1"/>
           <p:nvPr/>
         </p:nvSpPr>
         <p:spPr>
           <a:xfrm>
-            <a:off x="2171700" y="5257800"/>
-            <a:ext cx="2381250" cy="209550"/>
+            <a:off x="2171700" y="5372100"/>
+            <a:ext cx="2381250" cy="200025"/>
           </a:xfrm>
           <a:prstGeom prst="rect">
             <a:avLst/>
@@ -9035,14 +9299,14 @@
       </p:sp>
       <p:sp>
         <p:nvSpPr>
-          <p:cNvPr id="364" name="TextBox NT2"/>
+          <p:cNvPr id="370" name="TextBox NT2"/>
           <p:cNvSpPr txBox="1"/>
           <p:nvPr/>
         </p:nvSpPr>
         <p:spPr>
           <a:xfrm>
-            <a:off x="4629150" y="5257800"/>
-            <a:ext cx="2381250" cy="209550"/>
+            <a:off x="4629150" y="5372100"/>
+            <a:ext cx="2381250" cy="200025"/>
           </a:xfrm>
           <a:prstGeom prst="rect">
             <a:avLst/>
@@ -9064,21 +9328,21 @@
                 <a:latin typeface="맑은 고딕"/>
                 <a:ea typeface="맑은 고딕"/>
               </a:rPr>
-              <a:t>$504K  (0.53×)</a:t>
-            </a:r>
-          </a:p>
-        </p:txBody>
-      </p:sp>
-      <p:sp>
-        <p:nvSpPr>
-          <p:cNvPr id="365" name="TextBox NF2"/>
+              <a:t>$732K  (0.76×)</a:t>
+            </a:r>
+          </a:p>
+        </p:txBody>
+      </p:sp>
+      <p:sp>
+        <p:nvSpPr>
+          <p:cNvPr id="371" name="TextBox NF2"/>
           <p:cNvSpPr txBox="1"/>
           <p:nvPr/>
         </p:nvSpPr>
         <p:spPr>
           <a:xfrm>
-            <a:off x="7143750" y="5257800"/>
-            <a:ext cx="4733925" cy="209550"/>
+            <a:off x="7143750" y="5372100"/>
+            <a:ext cx="4733925" cy="200025"/>
           </a:xfrm>
           <a:prstGeom prst="rect">
             <a:avLst/>
@@ -9100,7 +9364,7 @@
                 <a:latin typeface="맑은 고딕"/>
                 <a:ea typeface="맑은 고딕"/>
               </a:rPr>
-              <a:t>4×(8×$30K) / 4×(4×$30K + 4×$1.5K PNM) — H100 가격에 HBM 포함</a:t>
+              <a:t>4×(8×$30K) / 4×(6×$30K + 2×$1.5K) · HBF GPU: HBM 40GB −$624 + HBF 320GB +$624</a:t>
             </a:r>
           </a:p>
         </p:txBody>

</xml_diff>